<commit_message>
feat: PPT v7 final + Self-Attention architecture diagram
PPT fixes:
  - Title bar: reduced font (24pt), wider box (12.2"), overflow prevention
  - All framed text boxes now prefixed with keyword tags:
    [特征解耦] [注意力路由] [对称破缺] [价值引导] etc.
  - Box height limits relaxed to 1.6" for better fill
  - P2 body expanded with structured bullet format (致命缺陷/具体表现/根因)

New figure: results/viz/fig_self_attention_arch.pdf
  - Clean flowchart: Obs[33] -> 3 Tokens -> Linear -> MHA -> Pool -> MLP -> Action
  - Embedded on P3 alongside existing Fig 3 stats
  - Ocean Gradient palette, white background, publication style
</commit_message>
<xml_diff>
--- a/results/ppt/formation_coop_v7.pptx
+++ b/results/ppt/formation_coop_v7.pptx
@@ -2166,7 +2166,7 @@
         </p:nvSpPr>
         <p:spPr>
           <a:xfrm>
-            <a:off x="274320" y="137160"/>
+            <a:off x="228600" y="109728"/>
             <a:ext cx="45720" cy="365760"/>
           </a:xfrm>
           <a:prstGeom prst="rect">
@@ -2186,8 +2186,8 @@
         </p:nvSpPr>
         <p:spPr>
           <a:xfrm>
-            <a:off x="274320" y="91440"/>
-            <a:ext cx="548640" cy="411480"/>
+            <a:off x="228600" y="73152"/>
+            <a:ext cx="457200" cy="411480"/>
           </a:xfrm>
           <a:prstGeom prst="rect">
             <a:avLst/>
@@ -2203,7 +2203,7 @@
               <a:buNone/>
             </a:pPr>
             <a:r>
-              <a:rPr lang="en-US" sz="2200" b="1" dirty="0">
+              <a:rPr lang="en-US" sz="2000" b="1" dirty="0">
                 <a:solidFill>
                   <a:srgbClr val="F96167"/>
                 </a:solidFill>
@@ -2213,7 +2213,7 @@
               </a:rPr>
               <a:t>9</a:t>
             </a:r>
-            <a:endParaRPr lang="en-US" sz="2200" dirty="0"/>
+            <a:endParaRPr lang="en-US" sz="2000" dirty="0"/>
           </a:p>
         </p:txBody>
       </p:sp>
@@ -2225,8 +2225,8 @@
         </p:nvSpPr>
         <p:spPr>
           <a:xfrm>
-            <a:off x="822960" y="91440"/>
-            <a:ext cx="411480" cy="0"/>
+            <a:off x="731520" y="73152"/>
+            <a:ext cx="11155680" cy="457200"/>
           </a:xfrm>
           <a:prstGeom prst="rect">
             <a:avLst/>
@@ -2242,7 +2242,7 @@
               <a:buNone/>
             </a:pPr>
             <a:r>
-              <a:rPr lang="en-US" sz="2600" b="1" dirty="0">
+              <a:rPr lang="en-US" sz="2400" b="1" dirty="0">
                 <a:solidFill>
                   <a:srgbClr val="065A82"/>
                 </a:solidFill>
@@ -2252,7 +2252,7 @@
               </a:rPr>
               <a:t>核心成果 2: 自发性对称破缺与持续性隐式协同</a:t>
             </a:r>
-            <a:endParaRPr lang="en-US" sz="2600" dirty="0"/>
+            <a:endParaRPr lang="en-US" sz="2400" dirty="0"/>
           </a:p>
         </p:txBody>
       </p:sp>
@@ -2264,8 +2264,8 @@
         </p:nvSpPr>
         <p:spPr>
           <a:xfrm>
-            <a:off x="274320" y="566928"/>
-            <a:ext cx="11612880" cy="9144"/>
+            <a:off x="228600" y="566928"/>
+            <a:ext cx="11704320" cy="9144"/>
           </a:xfrm>
           <a:prstGeom prst="rect">
             <a:avLst/>
@@ -2284,12 +2284,12 @@
         </p:nvSpPr>
         <p:spPr>
           <a:xfrm>
-            <a:off x="274320" y="777240"/>
-            <a:ext cx="5486400" cy="1371600"/>
+            <a:off x="228600" y="777240"/>
+            <a:ext cx="5486400" cy="1463040"/>
           </a:xfrm>
           <a:prstGeom prst="roundRect">
             <a:avLst>
-              <a:gd name="adj" fmla="val 3333"/>
+              <a:gd name="adj" fmla="val 3125"/>
             </a:avLst>
           </a:prstGeom>
           <a:solidFill>
@@ -2313,8 +2313,8 @@
         </p:nvSpPr>
         <p:spPr>
           <a:xfrm>
-            <a:off x="438912" y="777240"/>
-            <a:ext cx="5157216" cy="1371600"/>
+            <a:off x="411480" y="777240"/>
+            <a:ext cx="5120640" cy="1463040"/>
           </a:xfrm>
           <a:prstGeom prst="rect">
             <a:avLst/>
@@ -2328,7 +2328,7 @@
           <a:p>
             <a:pPr indent="0" marL="0">
               <a:lnSpc>
-                <a:spcPct val="115000"/>
+                <a:spcPct val="112000"/>
               </a:lnSpc>
               <a:buNone/>
             </a:pPr>
@@ -2341,7 +2341,7 @@
                 <a:ea typeface="Calibri" pitchFamily="34" charset="-122"/>
                 <a:cs typeface="Calibri" pitchFamily="34" charset="-120"/>
               </a:rPr>
-              <a:t>Cohen d = -0.53 强效应量: 7,858 步瞬时几何角色切片。Interceptor MHA Self→Target 以极高统计显著性超越 Striker 31%，展现果断的高速弥补距离劣势角色偏好</a:t>
+              <a:t>[效应量] Cohen d = -0.53 强效应量: 7,858 步瞬时几何角色切片。Interceptor MHA Self→Target 以极高统计显著性超越 Striker 31%，展现果断的高速弥补距离劣势角色偏好</a:t>
             </a:r>
             <a:endParaRPr lang="en-US" sz="1800" dirty="0"/>
           </a:p>
@@ -2355,12 +2355,12 @@
         </p:nvSpPr>
         <p:spPr>
           <a:xfrm>
-            <a:off x="274320" y="2221992"/>
-            <a:ext cx="5486400" cy="1371600"/>
+            <a:off x="228600" y="2295144"/>
+            <a:ext cx="5486400" cy="1463040"/>
           </a:xfrm>
           <a:prstGeom prst="roundRect">
             <a:avLst>
-              <a:gd name="adj" fmla="val 3333"/>
+              <a:gd name="adj" fmla="val 3125"/>
             </a:avLst>
           </a:prstGeom>
           <a:solidFill>
@@ -2384,8 +2384,8 @@
         </p:nvSpPr>
         <p:spPr>
           <a:xfrm>
-            <a:off x="438912" y="2221992"/>
-            <a:ext cx="5157216" cy="1371600"/>
+            <a:off x="411480" y="2295144"/>
+            <a:ext cx="5120640" cy="1463040"/>
           </a:xfrm>
           <a:prstGeom prst="rect">
             <a:avLst/>
@@ -2399,7 +2399,7 @@
           <a:p>
             <a:pPr indent="0" marL="0">
               <a:lnSpc>
-                <a:spcPct val="115000"/>
+                <a:spcPct val="112000"/>
               </a:lnSpc>
               <a:buNone/>
             </a:pPr>
@@ -2412,7 +2412,7 @@
                 <a:ea typeface="Calibri" pitchFamily="34" charset="-122"/>
                 <a:cs typeface="Calibri" pitchFamily="34" charset="-120"/>
               </a:rPr>
-              <a:t>持续性隐式协同 (推翻二元切换假设): 两机 MHA Self→Mate 全时锁定在 0.44-0.45 极高一致高位。骨子里维持全时高强度团队默契，仅基于瞬时物理拓扑微调目标专注度——高级隐式协同范式</a:t>
+              <a:t>[范式] 持续性隐式协同 (推翻二元切换假设): 两机 MHA Self→Mate 全时锁定在 0.44-0.45 极高一致高位。骨子里维持全时高强度团队默契，仅基于瞬时物理拓扑微调目标专注度——高级隐式协同范式</a:t>
             </a:r>
             <a:endParaRPr lang="en-US" sz="1800" dirty="0"/>
           </a:p>
@@ -2433,8 +2433,8 @@
         </p:blipFill>
         <p:spPr>
           <a:xfrm>
-            <a:off x="6217920" y="822960"/>
-            <a:ext cx="5669280" cy="5760720"/>
+            <a:off x="6217920" y="777240"/>
+            <a:ext cx="5669280" cy="5852160"/>
           </a:xfrm>
           <a:prstGeom prst="rect">
             <a:avLst/>
@@ -2481,7 +2481,7 @@
         </p:nvSpPr>
         <p:spPr>
           <a:xfrm>
-            <a:off x="274320" y="137160"/>
+            <a:off x="228600" y="109728"/>
             <a:ext cx="45720" cy="365760"/>
           </a:xfrm>
           <a:prstGeom prst="rect">
@@ -2501,8 +2501,8 @@
         </p:nvSpPr>
         <p:spPr>
           <a:xfrm>
-            <a:off x="274320" y="91440"/>
-            <a:ext cx="548640" cy="411480"/>
+            <a:off x="228600" y="73152"/>
+            <a:ext cx="457200" cy="411480"/>
           </a:xfrm>
           <a:prstGeom prst="rect">
             <a:avLst/>
@@ -2518,7 +2518,7 @@
               <a:buNone/>
             </a:pPr>
             <a:r>
-              <a:rPr lang="en-US" sz="2200" b="1" dirty="0">
+              <a:rPr lang="en-US" sz="2000" b="1" dirty="0">
                 <a:solidFill>
                   <a:srgbClr val="F96167"/>
                 </a:solidFill>
@@ -2528,7 +2528,7 @@
               </a:rPr>
               <a:t>10</a:t>
             </a:r>
-            <a:endParaRPr lang="en-US" sz="2200" dirty="0"/>
+            <a:endParaRPr lang="en-US" sz="2000" dirty="0"/>
           </a:p>
         </p:txBody>
       </p:sp>
@@ -2540,8 +2540,8 @@
         </p:nvSpPr>
         <p:spPr>
           <a:xfrm>
-            <a:off x="822960" y="91440"/>
-            <a:ext cx="411480" cy="0"/>
+            <a:off x="731520" y="73152"/>
+            <a:ext cx="11155680" cy="457200"/>
           </a:xfrm>
           <a:prstGeom prst="rect">
             <a:avLst/>
@@ -2557,7 +2557,7 @@
               <a:buNone/>
             </a:pPr>
             <a:r>
-              <a:rPr lang="en-US" sz="2600" b="1" dirty="0">
+              <a:rPr lang="en-US" sz="2400" b="1" dirty="0">
                 <a:solidFill>
                   <a:srgbClr val="065A82"/>
                 </a:solidFill>
@@ -2567,7 +2567,7 @@
               </a:rPr>
               <a:t>信息论边界: CTDE 熵墙与 Failure Case 深度解剖</a:t>
             </a:r>
-            <a:endParaRPr lang="en-US" sz="2600" dirty="0"/>
+            <a:endParaRPr lang="en-US" sz="2400" dirty="0"/>
           </a:p>
         </p:txBody>
       </p:sp>
@@ -2579,8 +2579,8 @@
         </p:nvSpPr>
         <p:spPr>
           <a:xfrm>
-            <a:off x="274320" y="566928"/>
-            <a:ext cx="11612880" cy="9144"/>
+            <a:off x="228600" y="566928"/>
+            <a:ext cx="11704320" cy="9144"/>
           </a:xfrm>
           <a:prstGeom prst="rect">
             <a:avLst/>
@@ -2599,7 +2599,7 @@
         </p:nvSpPr>
         <p:spPr>
           <a:xfrm>
-            <a:off x="274320" y="822960"/>
+            <a:off x="228600" y="804672"/>
             <a:ext cx="5303520" cy="694944"/>
           </a:xfrm>
           <a:prstGeom prst="roundRect">
@@ -2628,7 +2628,7 @@
         </p:nvSpPr>
         <p:spPr>
           <a:xfrm>
-            <a:off x="457200" y="822960"/>
+            <a:off x="411480" y="804672"/>
             <a:ext cx="3200400" cy="384048"/>
           </a:xfrm>
           <a:prstGeom prst="rect">
@@ -2667,7 +2667,7 @@
         </p:nvSpPr>
         <p:spPr>
           <a:xfrm>
-            <a:off x="3840480" y="822960"/>
+            <a:off x="3840480" y="804672"/>
             <a:ext cx="1280160" cy="384048"/>
           </a:xfrm>
           <a:prstGeom prst="rect">
@@ -2706,7 +2706,7 @@
         </p:nvSpPr>
         <p:spPr>
           <a:xfrm>
-            <a:off x="457200" y="1207008"/>
+            <a:off x="411480" y="1188720"/>
             <a:ext cx="4572000" cy="219456"/>
           </a:xfrm>
           <a:prstGeom prst="rect">
@@ -2745,7 +2745,7 @@
         </p:nvSpPr>
         <p:spPr>
           <a:xfrm>
-            <a:off x="274320" y="1572768"/>
+            <a:off x="228600" y="1554480"/>
             <a:ext cx="5303520" cy="694944"/>
           </a:xfrm>
           <a:prstGeom prst="roundRect">
@@ -2774,7 +2774,7 @@
         </p:nvSpPr>
         <p:spPr>
           <a:xfrm>
-            <a:off x="457200" y="1572768"/>
+            <a:off x="411480" y="1554480"/>
             <a:ext cx="3200400" cy="384048"/>
           </a:xfrm>
           <a:prstGeom prst="rect">
@@ -2813,7 +2813,7 @@
         </p:nvSpPr>
         <p:spPr>
           <a:xfrm>
-            <a:off x="3840480" y="1572768"/>
+            <a:off x="3840480" y="1554480"/>
             <a:ext cx="1280160" cy="384048"/>
           </a:xfrm>
           <a:prstGeom prst="rect">
@@ -2852,7 +2852,7 @@
         </p:nvSpPr>
         <p:spPr>
           <a:xfrm>
-            <a:off x="457200" y="1956816"/>
+            <a:off x="411480" y="1938528"/>
             <a:ext cx="4572000" cy="219456"/>
           </a:xfrm>
           <a:prstGeom prst="rect">
@@ -2891,7 +2891,7 @@
         </p:nvSpPr>
         <p:spPr>
           <a:xfrm>
-            <a:off x="274320" y="2322576"/>
+            <a:off x="228600" y="2304288"/>
             <a:ext cx="5303520" cy="694944"/>
           </a:xfrm>
           <a:prstGeom prst="roundRect">
@@ -2920,7 +2920,7 @@
         </p:nvSpPr>
         <p:spPr>
           <a:xfrm>
-            <a:off x="457200" y="2322576"/>
+            <a:off x="411480" y="2304288"/>
             <a:ext cx="3200400" cy="384048"/>
           </a:xfrm>
           <a:prstGeom prst="rect">
@@ -2959,7 +2959,7 @@
         </p:nvSpPr>
         <p:spPr>
           <a:xfrm>
-            <a:off x="3840480" y="2322576"/>
+            <a:off x="3840480" y="2304288"/>
             <a:ext cx="1280160" cy="384048"/>
           </a:xfrm>
           <a:prstGeom prst="rect">
@@ -2998,7 +2998,7 @@
         </p:nvSpPr>
         <p:spPr>
           <a:xfrm>
-            <a:off x="457200" y="2706624"/>
+            <a:off x="411480" y="2688336"/>
             <a:ext cx="4572000" cy="219456"/>
           </a:xfrm>
           <a:prstGeom prst="rect">
@@ -3037,7 +3037,7 @@
         </p:nvSpPr>
         <p:spPr>
           <a:xfrm>
-            <a:off x="274320" y="3072384"/>
+            <a:off x="228600" y="3054096"/>
             <a:ext cx="5303520" cy="694944"/>
           </a:xfrm>
           <a:prstGeom prst="roundRect">
@@ -3066,7 +3066,7 @@
         </p:nvSpPr>
         <p:spPr>
           <a:xfrm>
-            <a:off x="457200" y="3072384"/>
+            <a:off x="411480" y="3054096"/>
             <a:ext cx="3200400" cy="384048"/>
           </a:xfrm>
           <a:prstGeom prst="rect">
@@ -3105,7 +3105,7 @@
         </p:nvSpPr>
         <p:spPr>
           <a:xfrm>
-            <a:off x="3840480" y="3072384"/>
+            <a:off x="3840480" y="3054096"/>
             <a:ext cx="1280160" cy="384048"/>
           </a:xfrm>
           <a:prstGeom prst="rect">
@@ -3144,7 +3144,7 @@
         </p:nvSpPr>
         <p:spPr>
           <a:xfrm>
-            <a:off x="457200" y="3456432"/>
+            <a:off x="411480" y="3438144"/>
             <a:ext cx="4572000" cy="219456"/>
           </a:xfrm>
           <a:prstGeom prst="rect">
@@ -3183,7 +3183,7 @@
         </p:nvSpPr>
         <p:spPr>
           <a:xfrm>
-            <a:off x="274320" y="3822192"/>
+            <a:off x="228600" y="3803904"/>
             <a:ext cx="5303520" cy="694944"/>
           </a:xfrm>
           <a:prstGeom prst="roundRect">
@@ -3212,7 +3212,7 @@
         </p:nvSpPr>
         <p:spPr>
           <a:xfrm>
-            <a:off x="457200" y="3822192"/>
+            <a:off x="411480" y="3803904"/>
             <a:ext cx="3200400" cy="384048"/>
           </a:xfrm>
           <a:prstGeom prst="rect">
@@ -3251,7 +3251,7 @@
         </p:nvSpPr>
         <p:spPr>
           <a:xfrm>
-            <a:off x="3840480" y="3822192"/>
+            <a:off x="3840480" y="3803904"/>
             <a:ext cx="1280160" cy="384048"/>
           </a:xfrm>
           <a:prstGeom prst="rect">
@@ -3290,7 +3290,7 @@
         </p:nvSpPr>
         <p:spPr>
           <a:xfrm>
-            <a:off x="457200" y="4206240"/>
+            <a:off x="411480" y="4187952"/>
             <a:ext cx="4572000" cy="219456"/>
           </a:xfrm>
           <a:prstGeom prst="rect">
@@ -3330,11 +3330,11 @@
         <p:spPr>
           <a:xfrm>
             <a:off x="5943600" y="4846320"/>
-            <a:ext cx="5943600" cy="-1054608"/>
+            <a:ext cx="5943600" cy="-1042416"/>
           </a:xfrm>
           <a:prstGeom prst="roundRect">
             <a:avLst>
-              <a:gd name="adj" fmla="val -4335"/>
+              <a:gd name="adj" fmla="val -4386"/>
             </a:avLst>
           </a:prstGeom>
           <a:solidFill>
@@ -3358,8 +3358,8 @@
         </p:nvSpPr>
         <p:spPr>
           <a:xfrm>
-            <a:off x="6108192" y="4846320"/>
-            <a:ext cx="5614416" cy="-1054608"/>
+            <a:off x="6126480" y="4846320"/>
+            <a:ext cx="5577840" cy="-1042416"/>
           </a:xfrm>
           <a:prstGeom prst="rect">
             <a:avLst/>
@@ -3373,12 +3373,12 @@
           <a:p>
             <a:pPr indent="0" marL="0">
               <a:lnSpc>
-                <a:spcPct val="115000"/>
+                <a:spcPct val="112000"/>
               </a:lnSpc>
               <a:buNone/>
             </a:pPr>
             <a:r>
-              <a:rPr lang="en-US" sz="1400" b="1" dirty="0">
+              <a:rPr lang="en-US" sz="1300" b="1" dirty="0">
                 <a:solidFill>
                   <a:srgbClr val="4A5568"/>
                 </a:solidFill>
@@ -3386,9 +3386,9 @@
                 <a:ea typeface="Calibri" pitchFamily="34" charset="-122"/>
                 <a:cs typeface="Calibri" pitchFamily="34" charset="-120"/>
               </a:rPr>
-              <a:t>边缘悬崖: 320 轮后期 Logits 跨格点抖动跌至 -6,653。离散 AND-gate 奖励曲面演变为窄深峡谷</a:t>
-            </a:r>
-            <a:endParaRPr lang="en-US" sz="1400" dirty="0"/>
+              <a:t>[诊断] 边缘悬崖效应: 320 轮后期策略熵稳定在 1.77，但离散 AND-gate 奖励曲面演变为窄深峡谷，Logits 跨格点概率抖动跌至 -6,653</a:t>
+            </a:r>
+            <a:endParaRPr lang="en-US" sz="1300" dirty="0"/>
           </a:p>
         </p:txBody>
       </p:sp>
@@ -3400,12 +3400,12 @@
         </p:nvSpPr>
         <p:spPr>
           <a:xfrm>
-            <a:off x="5943600" y="3864864"/>
-            <a:ext cx="5943600" cy="-1054608"/>
+            <a:off x="5943600" y="3858768"/>
+            <a:ext cx="5943600" cy="-1042416"/>
           </a:xfrm>
           <a:prstGeom prst="roundRect">
             <a:avLst>
-              <a:gd name="adj" fmla="val -4335"/>
+              <a:gd name="adj" fmla="val -4386"/>
             </a:avLst>
           </a:prstGeom>
           <a:solidFill>
@@ -3429,8 +3429,8 @@
         </p:nvSpPr>
         <p:spPr>
           <a:xfrm>
-            <a:off x="6108192" y="3864864"/>
-            <a:ext cx="5614416" cy="-1054608"/>
+            <a:off x="6126480" y="3858768"/>
+            <a:ext cx="5577840" cy="-1042416"/>
           </a:xfrm>
           <a:prstGeom prst="rect">
             <a:avLst/>
@@ -3444,12 +3444,12 @@
           <a:p>
             <a:pPr indent="0" marL="0">
               <a:lnSpc>
-                <a:spcPct val="115000"/>
+                <a:spcPct val="112000"/>
               </a:lnSpc>
               <a:buNone/>
             </a:pPr>
             <a:r>
-              <a:rPr lang="en-US" sz="1400" b="1" dirty="0">
+              <a:rPr lang="en-US" sz="1300" b="1" dirty="0">
                 <a:solidFill>
                   <a:srgbClr val="4A5568"/>
                 </a:solidFill>
@@ -3457,9 +3457,9 @@
                 <a:ea typeface="Calibri" pitchFamily="34" charset="-122"/>
                 <a:cs typeface="Calibri" pitchFamily="34" charset="-120"/>
               </a:rPr>
-              <a:t>Vanilla CTDE 天花板: 33-dim 局部视界缺乏 ΔTGO 表达。僚机算不准长机踩进 800m 的秒级相位戳，梯度夹杂时序噪声</a:t>
-            </a:r>
-            <a:endParaRPr lang="en-US" sz="1400" dirty="0"/>
+              <a:t>[理论] Vanilla CTDE 天花板: 33-dim 局部视界仅含瞬时运动学 Token，缺乏非局部 ΔTGO (预计到达时间差) 表达。僚机算不准长机踩进 800m 的秒级相位戳</a:t>
+            </a:r>
+            <a:endParaRPr lang="en-US" sz="1300" dirty="0"/>
           </a:p>
         </p:txBody>
       </p:sp>
@@ -3471,12 +3471,12 @@
         </p:nvSpPr>
         <p:spPr>
           <a:xfrm>
-            <a:off x="5943600" y="2883408"/>
-            <a:ext cx="5943600" cy="-1054608"/>
+            <a:off x="5943600" y="2871216"/>
+            <a:ext cx="5943600" cy="-1042416"/>
           </a:xfrm>
           <a:prstGeom prst="roundRect">
             <a:avLst>
-              <a:gd name="adj" fmla="val -4335"/>
+              <a:gd name="adj" fmla="val -4386"/>
             </a:avLst>
           </a:prstGeom>
           <a:solidFill>
@@ -3500,8 +3500,8 @@
         </p:nvSpPr>
         <p:spPr>
           <a:xfrm>
-            <a:off x="6108192" y="2883408"/>
-            <a:ext cx="5614416" cy="-1054608"/>
+            <a:off x="6126480" y="2871216"/>
+            <a:ext cx="5577840" cy="-1042416"/>
           </a:xfrm>
           <a:prstGeom prst="rect">
             <a:avLst/>
@@ -3515,12 +3515,12 @@
           <a:p>
             <a:pPr indent="0" marL="0">
               <a:lnSpc>
-                <a:spcPct val="115000"/>
+                <a:spcPct val="112000"/>
               </a:lnSpc>
               <a:buNone/>
             </a:pPr>
             <a:r>
-              <a:rPr lang="en-US" sz="1400" b="1" dirty="0">
+              <a:rPr lang="en-US" sz="1300" b="1" dirty="0">
                 <a:solidFill>
                   <a:srgbClr val="4A5568"/>
                 </a:solidFill>
@@ -3528,9 +3528,9 @@
                 <a:ea typeface="Calibri" pitchFamily="34" charset="-122"/>
                 <a:cs typeface="Calibri" pitchFamily="34" charset="-120"/>
               </a:rPr>
-              <a:t>诚实结论: 划定扁平无通信分布式控制在严格 AND 同步任务的理论边界，为层级控制+显式通信提供科学 Imperative</a:t>
-            </a:r>
-            <a:endParaRPr lang="en-US" sz="1400" dirty="0"/>
+              <a:t>[边界] 诚实划定: 扁平无显式通信的分布式控制在应对严格断崖式 AND 同步任务时的理论边界。为层级控制+显式通信提供坚实科学 Imperative</a:t>
+            </a:r>
+            <a:endParaRPr lang="en-US" sz="1300" dirty="0"/>
           </a:p>
         </p:txBody>
       </p:sp>
@@ -3549,7 +3549,7 @@
         </p:blipFill>
         <p:spPr>
           <a:xfrm>
-            <a:off x="5943600" y="868680"/>
+            <a:off x="5943600" y="841248"/>
             <a:ext cx="5943600" cy="3657600"/>
           </a:xfrm>
           <a:prstGeom prst="rect">
@@ -3597,7 +3597,7 @@
         </p:nvSpPr>
         <p:spPr>
           <a:xfrm>
-            <a:off x="274320" y="137160"/>
+            <a:off x="228600" y="109728"/>
             <a:ext cx="45720" cy="365760"/>
           </a:xfrm>
           <a:prstGeom prst="rect">
@@ -3617,8 +3617,8 @@
         </p:nvSpPr>
         <p:spPr>
           <a:xfrm>
-            <a:off x="274320" y="91440"/>
-            <a:ext cx="548640" cy="411480"/>
+            <a:off x="228600" y="73152"/>
+            <a:ext cx="457200" cy="411480"/>
           </a:xfrm>
           <a:prstGeom prst="rect">
             <a:avLst/>
@@ -3634,7 +3634,7 @@
               <a:buNone/>
             </a:pPr>
             <a:r>
-              <a:rPr lang="en-US" sz="2200" b="1" dirty="0">
+              <a:rPr lang="en-US" sz="2000" b="1" dirty="0">
                 <a:solidFill>
                   <a:srgbClr val="F96167"/>
                 </a:solidFill>
@@ -3644,7 +3644,7 @@
               </a:rPr>
               <a:t>11</a:t>
             </a:r>
-            <a:endParaRPr lang="en-US" sz="2200" dirty="0"/>
+            <a:endParaRPr lang="en-US" sz="2000" dirty="0"/>
           </a:p>
         </p:txBody>
       </p:sp>
@@ -3656,8 +3656,8 @@
         </p:nvSpPr>
         <p:spPr>
           <a:xfrm>
-            <a:off x="822960" y="91440"/>
-            <a:ext cx="411480" cy="0"/>
+            <a:off x="731520" y="73152"/>
+            <a:ext cx="11155680" cy="457200"/>
           </a:xfrm>
           <a:prstGeom prst="rect">
             <a:avLst/>
@@ -3673,7 +3673,7 @@
               <a:buNone/>
             </a:pPr>
             <a:r>
-              <a:rPr lang="en-US" sz="2600" b="1" dirty="0">
+              <a:rPr lang="en-US" sz="2400" b="1" dirty="0">
                 <a:solidFill>
                   <a:srgbClr val="065A82"/>
                 </a:solidFill>
@@ -3683,7 +3683,7 @@
               </a:rPr>
               <a:t>未来进军路线: 层级 SMDP + 匈牙利指派 + Self-Play</a:t>
             </a:r>
-            <a:endParaRPr lang="en-US" sz="2600" dirty="0"/>
+            <a:endParaRPr lang="en-US" sz="2400" dirty="0"/>
           </a:p>
         </p:txBody>
       </p:sp>
@@ -3695,8 +3695,8 @@
         </p:nvSpPr>
         <p:spPr>
           <a:xfrm>
-            <a:off x="274320" y="566928"/>
-            <a:ext cx="11612880" cy="9144"/>
+            <a:off x="228600" y="566928"/>
+            <a:ext cx="11704320" cy="9144"/>
           </a:xfrm>
           <a:prstGeom prst="rect">
             <a:avLst/>
@@ -3715,8 +3715,8 @@
         </p:nvSpPr>
         <p:spPr>
           <a:xfrm>
-            <a:off x="274320" y="868680"/>
-            <a:ext cx="11612880" cy="1234440"/>
+            <a:off x="228600" y="841248"/>
+            <a:ext cx="11704320" cy="1234440"/>
           </a:xfrm>
           <a:prstGeom prst="roundRect">
             <a:avLst>
@@ -3744,7 +3744,7 @@
         </p:nvSpPr>
         <p:spPr>
           <a:xfrm>
-            <a:off x="457200" y="1097280"/>
+            <a:off x="411480" y="1069848"/>
             <a:ext cx="594360" cy="594360"/>
           </a:xfrm>
           <a:prstGeom prst="ellipse">
@@ -3764,7 +3764,7 @@
         </p:nvSpPr>
         <p:spPr>
           <a:xfrm>
-            <a:off x="457200" y="1097280"/>
+            <a:off x="411480" y="1069848"/>
             <a:ext cx="594360" cy="594360"/>
           </a:xfrm>
           <a:prstGeom prst="rect">
@@ -3803,8 +3803,8 @@
         </p:nvSpPr>
         <p:spPr>
           <a:xfrm>
-            <a:off x="1280160" y="987552"/>
-            <a:ext cx="10424160" cy="365760"/>
+            <a:off x="1234440" y="960120"/>
+            <a:ext cx="10515600" cy="365760"/>
           </a:xfrm>
           <a:prstGeom prst="rect">
             <a:avLst/>
@@ -3842,8 +3842,8 @@
         </p:nvSpPr>
         <p:spPr>
           <a:xfrm>
-            <a:off x="1280160" y="1371600"/>
-            <a:ext cx="10424160" cy="548640"/>
+            <a:off x="1234440" y="1353312"/>
+            <a:ext cx="10515600" cy="548640"/>
           </a:xfrm>
           <a:prstGeom prst="rect">
             <a:avLst/>
@@ -3870,7 +3870,7 @@
                 <a:ea typeface="Calibri" pitchFamily="34" charset="-122"/>
                 <a:cs typeface="Calibri" pitchFamily="34" charset="-120"/>
               </a:rPr>
-              <a:t>参数共享+语义 Token 零成本 N 机扩展。转向 3v1/4v2，挂载匈牙利算法剪枝火力-目标匹配组合爆炸。</a:t>
+              <a:t>参数共享+语义 Token 天然具备零成本 N 机位置外推特性。转向 3v1/4v2 场景，挂载匈牙利算法剪枝火力-目标匹配组合爆炸。</a:t>
             </a:r>
             <a:endParaRPr lang="en-US" sz="1600" dirty="0"/>
           </a:p>
@@ -3884,8 +3884,8 @@
         </p:nvSpPr>
         <p:spPr>
           <a:xfrm>
-            <a:off x="274320" y="2240280"/>
-            <a:ext cx="11612880" cy="1234440"/>
+            <a:off x="228600" y="2212848"/>
+            <a:ext cx="11704320" cy="1234440"/>
           </a:xfrm>
           <a:prstGeom prst="roundRect">
             <a:avLst>
@@ -3913,7 +3913,7 @@
         </p:nvSpPr>
         <p:spPr>
           <a:xfrm>
-            <a:off x="457200" y="2468880"/>
+            <a:off x="411480" y="2441448"/>
             <a:ext cx="594360" cy="594360"/>
           </a:xfrm>
           <a:prstGeom prst="ellipse">
@@ -3933,7 +3933,7 @@
         </p:nvSpPr>
         <p:spPr>
           <a:xfrm>
-            <a:off x="457200" y="2468880"/>
+            <a:off x="411480" y="2441448"/>
             <a:ext cx="594360" cy="594360"/>
           </a:xfrm>
           <a:prstGeom prst="rect">
@@ -3972,8 +3972,8 @@
         </p:nvSpPr>
         <p:spPr>
           <a:xfrm>
-            <a:off x="1280160" y="2359152"/>
-            <a:ext cx="10424160" cy="365760"/>
+            <a:off x="1234440" y="2331720"/>
+            <a:ext cx="10515600" cy="365760"/>
           </a:xfrm>
           <a:prstGeom prst="rect">
             <a:avLst/>
@@ -4011,8 +4011,8 @@
         </p:nvSpPr>
         <p:spPr>
           <a:xfrm>
-            <a:off x="1280160" y="2743200"/>
-            <a:ext cx="10424160" cy="548640"/>
+            <a:off x="1234440" y="2724912"/>
+            <a:ext cx="10515600" cy="548640"/>
           </a:xfrm>
           <a:prstGeom prst="rect">
             <a:avLst/>
@@ -4039,7 +4039,7 @@
                 <a:ea typeface="Calibri" pitchFamily="34" charset="-122"/>
                 <a:cs typeface="Calibri" pitchFamily="34" charset="-120"/>
               </a:rPr>
-              <a:t>上层 Policy 2Hz 专注宏观 BFM 意图坚决输出；下层 Action Masking 60Hz 物理安全锁死。</a:t>
+              <a:t>上层 Policy 降至 2Hz 专注宏观 BFM 意图坚决输出；下层 Action Masking 维持 60Hz 物理安全锁死。桥接战略规划与战术执行。</a:t>
             </a:r>
             <a:endParaRPr lang="en-US" sz="1600" dirty="0"/>
           </a:p>
@@ -4053,8 +4053,8 @@
         </p:nvSpPr>
         <p:spPr>
           <a:xfrm>
-            <a:off x="274320" y="3611880"/>
-            <a:ext cx="11612880" cy="1234440"/>
+            <a:off x="228600" y="3584448"/>
+            <a:ext cx="11704320" cy="1234440"/>
           </a:xfrm>
           <a:prstGeom prst="roundRect">
             <a:avLst>
@@ -4082,7 +4082,7 @@
         </p:nvSpPr>
         <p:spPr>
           <a:xfrm>
-            <a:off x="457200" y="3840480"/>
+            <a:off x="411480" y="3813048"/>
             <a:ext cx="594360" cy="594360"/>
           </a:xfrm>
           <a:prstGeom prst="ellipse">
@@ -4102,7 +4102,7 @@
         </p:nvSpPr>
         <p:spPr>
           <a:xfrm>
-            <a:off x="457200" y="3840480"/>
+            <a:off x="411480" y="3813048"/>
             <a:ext cx="594360" cy="594360"/>
           </a:xfrm>
           <a:prstGeom prst="rect">
@@ -4141,8 +4141,8 @@
         </p:nvSpPr>
         <p:spPr>
           <a:xfrm>
-            <a:off x="1280160" y="3730752"/>
-            <a:ext cx="10424160" cy="365760"/>
+            <a:off x="1234440" y="3703320"/>
+            <a:ext cx="10515600" cy="365760"/>
           </a:xfrm>
           <a:prstGeom prst="rect">
             <a:avLst/>
@@ -4180,8 +4180,8 @@
         </p:nvSpPr>
         <p:spPr>
           <a:xfrm>
-            <a:off x="1280160" y="4114800"/>
-            <a:ext cx="10424160" cy="548640"/>
+            <a:off x="1234440" y="4096512"/>
+            <a:ext cx="10515600" cy="548640"/>
           </a:xfrm>
           <a:prstGeom prst="rect">
             <a:avLst/>
@@ -4208,7 +4208,7 @@
                 <a:ea typeface="Calibri" pitchFamily="34" charset="-122"/>
                 <a:cs typeface="Calibri" pitchFamily="34" charset="-120"/>
               </a:rPr>
-              <a:t>群体课程自博弈 (PCSP) + 联赛训练，拆除固定脚本，红蓝对抗中螺旋进化最高阶空战战术。</a:t>
+              <a:t>群体课程自博弈 (PCSP) + 联赛训练，彻底拆除固定脚本目标，红蓝双方在对抗对顶中实现最高阶空战战术螺旋进化。</a:t>
             </a:r>
             <a:endParaRPr lang="en-US" sz="1600" dirty="0"/>
           </a:p>
@@ -4222,8 +4222,8 @@
         </p:nvSpPr>
         <p:spPr>
           <a:xfrm>
-            <a:off x="274320" y="4983480"/>
-            <a:ext cx="11612880" cy="1234440"/>
+            <a:off x="228600" y="4956048"/>
+            <a:ext cx="11704320" cy="1234440"/>
           </a:xfrm>
           <a:prstGeom prst="roundRect">
             <a:avLst>
@@ -4251,7 +4251,7 @@
         </p:nvSpPr>
         <p:spPr>
           <a:xfrm>
-            <a:off x="457200" y="5212080"/>
+            <a:off x="411480" y="5184648"/>
             <a:ext cx="594360" cy="594360"/>
           </a:xfrm>
           <a:prstGeom prst="ellipse">
@@ -4271,7 +4271,7 @@
         </p:nvSpPr>
         <p:spPr>
           <a:xfrm>
-            <a:off x="457200" y="5212080"/>
+            <a:off x="411480" y="5184648"/>
             <a:ext cx="594360" cy="594360"/>
           </a:xfrm>
           <a:prstGeom prst="rect">
@@ -4310,8 +4310,8 @@
         </p:nvSpPr>
         <p:spPr>
           <a:xfrm>
-            <a:off x="1280160" y="5102352"/>
-            <a:ext cx="10424160" cy="365760"/>
+            <a:off x="1234440" y="5074920"/>
+            <a:ext cx="10515600" cy="365760"/>
           </a:xfrm>
           <a:prstGeom prst="rect">
             <a:avLst/>
@@ -4349,8 +4349,8 @@
         </p:nvSpPr>
         <p:spPr>
           <a:xfrm>
-            <a:off x="1280160" y="5486400"/>
-            <a:ext cx="10424160" cy="548640"/>
+            <a:off x="1234440" y="5468112"/>
+            <a:ext cx="10515600" cy="548640"/>
           </a:xfrm>
           <a:prstGeom prst="rect">
             <a:avLst/>
@@ -4377,7 +4377,7 @@
                 <a:ea typeface="Calibri" pitchFamily="34" charset="-122"/>
                 <a:cs typeface="Calibri" pitchFamily="34" charset="-120"/>
               </a:rPr>
-              <a:t>引入预计到达时间差信号，架设时空同步桥梁，一击突破 AND-gate 终极天花板。</a:t>
+              <a:t>在全局状态引入预计到达时间差信号，架设时空同步桥梁，一击突破 AND-gate 终极天花板。</a:t>
             </a:r>
             <a:endParaRPr lang="en-US" sz="1600" dirty="0"/>
           </a:p>
@@ -4391,8 +4391,8 @@
         </p:nvSpPr>
         <p:spPr>
           <a:xfrm>
-            <a:off x="274320" y="6492240"/>
-            <a:ext cx="11612880" cy="27432"/>
+            <a:off x="228600" y="6464808"/>
+            <a:ext cx="11704320" cy="27432"/>
           </a:xfrm>
           <a:prstGeom prst="rect">
             <a:avLst/>
@@ -4411,8 +4411,8 @@
         </p:nvSpPr>
         <p:spPr>
           <a:xfrm>
-            <a:off x="274320" y="6629400"/>
-            <a:ext cx="11612880" cy="457200"/>
+            <a:off x="228600" y="6601968"/>
+            <a:ext cx="11704320" cy="457200"/>
           </a:xfrm>
           <a:prstGeom prst="rect">
             <a:avLst/>
@@ -4450,8 +4450,8 @@
         </p:nvSpPr>
         <p:spPr>
           <a:xfrm>
-            <a:off x="274320" y="7086600"/>
-            <a:ext cx="11612880" cy="274320"/>
+            <a:off x="228600" y="7059168"/>
+            <a:ext cx="11704320" cy="274320"/>
           </a:xfrm>
           <a:prstGeom prst="rect">
             <a:avLst/>
@@ -4521,7 +4521,7 @@
         </p:nvSpPr>
         <p:spPr>
           <a:xfrm>
-            <a:off x="274320" y="137160"/>
+            <a:off x="228600" y="109728"/>
             <a:ext cx="45720" cy="365760"/>
           </a:xfrm>
           <a:prstGeom prst="rect">
@@ -4541,8 +4541,8 @@
         </p:nvSpPr>
         <p:spPr>
           <a:xfrm>
-            <a:off x="274320" y="91440"/>
-            <a:ext cx="548640" cy="411480"/>
+            <a:off x="228600" y="73152"/>
+            <a:ext cx="457200" cy="411480"/>
           </a:xfrm>
           <a:prstGeom prst="rect">
             <a:avLst/>
@@ -4558,7 +4558,7 @@
               <a:buNone/>
             </a:pPr>
             <a:r>
-              <a:rPr lang="en-US" sz="2200" b="1" dirty="0">
+              <a:rPr lang="en-US" sz="2000" b="1" dirty="0">
                 <a:solidFill>
                   <a:srgbClr val="F96167"/>
                 </a:solidFill>
@@ -4568,7 +4568,7 @@
               </a:rPr>
               <a:t>A</a:t>
             </a:r>
-            <a:endParaRPr lang="en-US" sz="2200" dirty="0"/>
+            <a:endParaRPr lang="en-US" sz="2000" dirty="0"/>
           </a:p>
         </p:txBody>
       </p:sp>
@@ -4580,8 +4580,8 @@
         </p:nvSpPr>
         <p:spPr>
           <a:xfrm>
-            <a:off x="822960" y="91440"/>
-            <a:ext cx="411480" cy="0"/>
+            <a:off x="731520" y="73152"/>
+            <a:ext cx="11155680" cy="457200"/>
           </a:xfrm>
           <a:prstGeom prst="rect">
             <a:avLst/>
@@ -4597,7 +4597,7 @@
               <a:buNone/>
             </a:pPr>
             <a:r>
-              <a:rPr lang="en-US" sz="2600" b="1" dirty="0">
+              <a:rPr lang="en-US" sz="2400" b="1" dirty="0">
                 <a:solidFill>
                   <a:srgbClr val="065A82"/>
                 </a:solidFill>
@@ -4605,9 +4605,9 @@
                 <a:ea typeface="Georgia" pitchFamily="34" charset="-122"/>
                 <a:cs typeface="Georgia" pitchFamily="34" charset="-120"/>
               </a:rPr>
-              <a:t>附录: 网络健康诊断 (Q&amp;A 防守页)</a:t>
-            </a:r>
-            <a:endParaRPr lang="en-US" sz="2600" dirty="0"/>
+              <a:t>附录: Critic 解释方差与网络健康诊断 (Q&amp;A 防守页)</a:t>
+            </a:r>
+            <a:endParaRPr lang="en-US" sz="2400" dirty="0"/>
           </a:p>
         </p:txBody>
       </p:sp>
@@ -4619,8 +4619,8 @@
         </p:nvSpPr>
         <p:spPr>
           <a:xfrm>
-            <a:off x="274320" y="566928"/>
-            <a:ext cx="11612880" cy="9144"/>
+            <a:off x="228600" y="566928"/>
+            <a:ext cx="11704320" cy="9144"/>
           </a:xfrm>
           <a:prstGeom prst="rect">
             <a:avLst/>
@@ -4639,12 +4639,12 @@
         </p:nvSpPr>
         <p:spPr>
           <a:xfrm>
-            <a:off x="274320" y="777240"/>
-            <a:ext cx="5486400" cy="1371600"/>
+            <a:off x="228600" y="777240"/>
+            <a:ext cx="5486400" cy="1463040"/>
           </a:xfrm>
           <a:prstGeom prst="roundRect">
             <a:avLst>
-              <a:gd name="adj" fmla="val 3333"/>
+              <a:gd name="adj" fmla="val 3125"/>
             </a:avLst>
           </a:prstGeom>
           <a:solidFill>
@@ -4668,8 +4668,8 @@
         </p:nvSpPr>
         <p:spPr>
           <a:xfrm>
-            <a:off x="438912" y="777240"/>
-            <a:ext cx="5157216" cy="1371600"/>
+            <a:off x="411480" y="777240"/>
+            <a:ext cx="5120640" cy="1463040"/>
           </a:xfrm>
           <a:prstGeom prst="rect">
             <a:avLst/>
@@ -4683,12 +4683,12 @@
           <a:p>
             <a:pPr indent="0" marL="0">
               <a:lnSpc>
-                <a:spcPct val="115000"/>
+                <a:spcPct val="112000"/>
               </a:lnSpc>
               <a:buNone/>
             </a:pPr>
             <a:r>
-              <a:rPr lang="en-US" sz="1800" b="1" dirty="0">
+              <a:rPr lang="en-US" sz="1700" b="1" dirty="0">
                 <a:solidFill>
                   <a:srgbClr val="4A5568"/>
                 </a:solidFill>
@@ -4696,9 +4696,9 @@
                 <a:ea typeface="Calibri" pitchFamily="34" charset="-122"/>
                 <a:cs typeface="Calibri" pitchFamily="34" charset="-120"/>
               </a:rPr>
-              <a:t>Explained Variance: 跨越 0.2 混沌区后以极高鲁棒性单调爬升，最终稳定在 0.85+ 高位平台——集中式评论员已彻底拟合 600 步超长时序的联合状态价值边界</a:t>
-            </a:r>
-            <a:endParaRPr lang="en-US" sz="1800" dirty="0"/>
+              <a:t>[价值拟合] Explained Variance: 跨越 0.2 初始混沌区后以极高鲁棒性单调爬升，最终稳定在 0.85+ 高位平台——集中式评论员已彻底拟合 600 步超长时序的联合状态价值边界</a:t>
+            </a:r>
+            <a:endParaRPr lang="en-US" sz="1700" dirty="0"/>
           </a:p>
         </p:txBody>
       </p:sp>
@@ -4710,12 +4710,12 @@
         </p:nvSpPr>
         <p:spPr>
           <a:xfrm>
-            <a:off x="274320" y="2221992"/>
-            <a:ext cx="5486400" cy="1371600"/>
+            <a:off x="228600" y="2295144"/>
+            <a:ext cx="5486400" cy="1463040"/>
           </a:xfrm>
           <a:prstGeom prst="roundRect">
             <a:avLst>
-              <a:gd name="adj" fmla="val 3333"/>
+              <a:gd name="adj" fmla="val 3125"/>
             </a:avLst>
           </a:prstGeom>
           <a:solidFill>
@@ -4739,8 +4739,8 @@
         </p:nvSpPr>
         <p:spPr>
           <a:xfrm>
-            <a:off x="438912" y="2221992"/>
-            <a:ext cx="5157216" cy="1371600"/>
+            <a:off x="411480" y="2295144"/>
+            <a:ext cx="5120640" cy="1463040"/>
           </a:xfrm>
           <a:prstGeom prst="rect">
             <a:avLst/>
@@ -4754,12 +4754,12 @@
           <a:p>
             <a:pPr indent="0" marL="0">
               <a:lnSpc>
-                <a:spcPct val="115000"/>
+                <a:spcPct val="112000"/>
               </a:lnSpc>
               <a:buNone/>
             </a:pPr>
             <a:r>
-              <a:rPr lang="en-US" sz="1800" b="1" dirty="0">
+              <a:rPr lang="en-US" sz="1700" b="1" dirty="0">
                 <a:solidFill>
                   <a:srgbClr val="4A5568"/>
                 </a:solidFill>
@@ -4767,9 +4767,9 @@
                 <a:ea typeface="Calibri" pitchFamily="34" charset="-122"/>
                 <a:cs typeface="Calibri" pitchFamily="34" charset="-120"/>
               </a:rPr>
-              <a:t>Policy Entropy: 策略熵由理论格点上限 2.71 极其平滑单调地下移至 1.77 中心平台。无崩塌至 0.04 导致的策略僵死，也无发散至 2.5+ 的无序随机——系统处于极佳淬火期</a:t>
-            </a:r>
-            <a:endParaRPr lang="en-US" sz="1800" dirty="0"/>
+              <a:t>[策略健康] Policy Entropy: 由理论格点上限 2.71 极其平滑单调地下移至 1.77 中心平台。无崩塌至 0.04 导致的策略僵死，也无发散至 2.5+ 的无序随机——系统处于极佳淬火期</a:t>
+            </a:r>
+            <a:endParaRPr lang="en-US" sz="1700" dirty="0"/>
           </a:p>
         </p:txBody>
       </p:sp>
@@ -4781,12 +4781,12 @@
         </p:nvSpPr>
         <p:spPr>
           <a:xfrm>
-            <a:off x="274320" y="3666744"/>
-            <a:ext cx="5486400" cy="1371600"/>
+            <a:off x="228600" y="3813048"/>
+            <a:ext cx="5486400" cy="1463040"/>
           </a:xfrm>
           <a:prstGeom prst="roundRect">
             <a:avLst>
-              <a:gd name="adj" fmla="val 3333"/>
+              <a:gd name="adj" fmla="val 3125"/>
             </a:avLst>
           </a:prstGeom>
           <a:solidFill>
@@ -4810,8 +4810,8 @@
         </p:nvSpPr>
         <p:spPr>
           <a:xfrm>
-            <a:off x="438912" y="3666744"/>
-            <a:ext cx="5157216" cy="1371600"/>
+            <a:off x="411480" y="3813048"/>
+            <a:ext cx="5120640" cy="1463040"/>
           </a:xfrm>
           <a:prstGeom prst="rect">
             <a:avLst/>
@@ -4825,12 +4825,12 @@
           <a:p>
             <a:pPr indent="0" marL="0">
               <a:lnSpc>
-                <a:spcPct val="115000"/>
+                <a:spcPct val="112000"/>
               </a:lnSpc>
               <a:buNone/>
             </a:pPr>
             <a:r>
-              <a:rPr lang="en-US" sz="1800" b="1" dirty="0">
+              <a:rPr lang="en-US" sz="1700" b="1" dirty="0">
                 <a:solidFill>
                   <a:srgbClr val="4A5568"/>
                 </a:solidFill>
@@ -4838,9 +4838,9 @@
                 <a:ea typeface="Calibri" pitchFamily="34" charset="-122"/>
                 <a:cs typeface="Calibri" pitchFamily="34" charset="-120"/>
               </a:rPr>
-              <a:t>结论: 所有前述成果的第一底层算法健康铁证。梯度无作弊、无套利、无崩溃</a:t>
-            </a:r>
-            <a:endParaRPr lang="en-US" sz="1800" dirty="0"/>
+              <a:t>[铁证] 结论: 所有前述成果的第一底层算法健康铁证。梯度无作弊、无套利、无崩溃</a:t>
+            </a:r>
+            <a:endParaRPr lang="en-US" sz="1700" dirty="0"/>
           </a:p>
         </p:txBody>
       </p:sp>
@@ -4859,8 +4859,8 @@
         </p:blipFill>
         <p:spPr>
           <a:xfrm>
-            <a:off x="6035040" y="822960"/>
-            <a:ext cx="5943600" cy="5760720"/>
+            <a:off x="6035040" y="777240"/>
+            <a:ext cx="5943600" cy="5852160"/>
           </a:xfrm>
           <a:prstGeom prst="rect">
             <a:avLst/>
@@ -4907,7 +4907,7 @@
         </p:nvSpPr>
         <p:spPr>
           <a:xfrm>
-            <a:off x="274320" y="137160"/>
+            <a:off x="228600" y="109728"/>
             <a:ext cx="45720" cy="365760"/>
           </a:xfrm>
           <a:prstGeom prst="rect">
@@ -4927,8 +4927,8 @@
         </p:nvSpPr>
         <p:spPr>
           <a:xfrm>
-            <a:off x="274320" y="91440"/>
-            <a:ext cx="548640" cy="411480"/>
+            <a:off x="228600" y="73152"/>
+            <a:ext cx="457200" cy="411480"/>
           </a:xfrm>
           <a:prstGeom prst="rect">
             <a:avLst/>
@@ -4944,7 +4944,7 @@
               <a:buNone/>
             </a:pPr>
             <a:r>
-              <a:rPr lang="en-US" sz="2200" b="1" dirty="0">
+              <a:rPr lang="en-US" sz="2000" b="1" dirty="0">
                 <a:solidFill>
                   <a:srgbClr val="F96167"/>
                 </a:solidFill>
@@ -4954,7 +4954,7 @@
               </a:rPr>
               <a:t>1</a:t>
             </a:r>
-            <a:endParaRPr lang="en-US" sz="2200" dirty="0"/>
+            <a:endParaRPr lang="en-US" sz="2000" dirty="0"/>
           </a:p>
         </p:txBody>
       </p:sp>
@@ -4966,8 +4966,8 @@
         </p:nvSpPr>
         <p:spPr>
           <a:xfrm>
-            <a:off x="822960" y="91440"/>
-            <a:ext cx="411480" cy="0"/>
+            <a:off x="731520" y="73152"/>
+            <a:ext cx="11155680" cy="457200"/>
           </a:xfrm>
           <a:prstGeom prst="rect">
             <a:avLst/>
@@ -4983,7 +4983,7 @@
               <a:buNone/>
             </a:pPr>
             <a:r>
-              <a:rPr lang="en-US" sz="2600" b="1" dirty="0">
+              <a:rPr lang="en-US" sz="2400" b="1" dirty="0">
                 <a:solidFill>
                   <a:srgbClr val="065A82"/>
                 </a:solidFill>
@@ -4993,7 +4993,7 @@
               </a:rPr>
               <a:t>核心卡点: 协同的死亡三角与时空脱节死锁</a:t>
             </a:r>
-            <a:endParaRPr lang="en-US" sz="2600" dirty="0"/>
+            <a:endParaRPr lang="en-US" sz="2400" dirty="0"/>
           </a:p>
         </p:txBody>
       </p:sp>
@@ -5005,8 +5005,8 @@
         </p:nvSpPr>
         <p:spPr>
           <a:xfrm>
-            <a:off x="274320" y="566928"/>
-            <a:ext cx="11612880" cy="9144"/>
+            <a:off x="228600" y="566928"/>
+            <a:ext cx="11704320" cy="9144"/>
           </a:xfrm>
           <a:prstGeom prst="rect">
             <a:avLst/>
@@ -5025,12 +5025,12 @@
         </p:nvSpPr>
         <p:spPr>
           <a:xfrm>
-            <a:off x="274320" y="777240"/>
-            <a:ext cx="3749040" cy="5669280"/>
+            <a:off x="228600" y="777240"/>
+            <a:ext cx="3794760" cy="5715000"/>
           </a:xfrm>
           <a:prstGeom prst="roundRect">
             <a:avLst>
-              <a:gd name="adj" fmla="val 1220"/>
+              <a:gd name="adj" fmla="val 1205"/>
             </a:avLst>
           </a:prstGeom>
           <a:solidFill>
@@ -5054,8 +5054,8 @@
         </p:nvSpPr>
         <p:spPr>
           <a:xfrm>
-            <a:off x="411480" y="868680"/>
-            <a:ext cx="3474720" cy="411480"/>
+            <a:off x="365760" y="868680"/>
+            <a:ext cx="3520440" cy="384048"/>
           </a:xfrm>
           <a:prstGeom prst="rect">
             <a:avLst/>
@@ -5071,7 +5071,7 @@
               <a:buNone/>
             </a:pPr>
             <a:r>
-              <a:rPr lang="en-US" sz="1800" b="1" dirty="0">
+              <a:rPr lang="en-US" sz="1700" b="1" dirty="0">
                 <a:solidFill>
                   <a:srgbClr val="F96167"/>
                 </a:solidFill>
@@ -5081,7 +5081,7 @@
               </a:rPr>
               <a:t>A. 非平稳性死锁 (Non-Stationarity)</a:t>
             </a:r>
-            <a:endParaRPr lang="en-US" sz="1800" dirty="0"/>
+            <a:endParaRPr lang="en-US" sz="1700" dirty="0"/>
           </a:p>
         </p:txBody>
       </p:sp>
@@ -5093,8 +5093,8 @@
         </p:nvSpPr>
         <p:spPr>
           <a:xfrm>
-            <a:off x="411480" y="1371600"/>
-            <a:ext cx="3474720" cy="3657600"/>
+            <a:off x="365760" y="1325880"/>
+            <a:ext cx="3520440" cy="3657600"/>
           </a:xfrm>
           <a:prstGeom prst="rect">
             <a:avLst/>
@@ -5108,12 +5108,12 @@
           <a:p>
             <a:pPr indent="0" marL="0">
               <a:lnSpc>
-                <a:spcPct val="160000"/>
+                <a:spcPct val="155000"/>
               </a:lnSpc>
               <a:buNone/>
             </a:pPr>
             <a:r>
-              <a:rPr lang="en-US" sz="1700" b="1" dirty="0">
+              <a:rPr lang="en-US" sz="1600" dirty="0">
                 <a:solidFill>
                   <a:srgbClr val="4A5568"/>
                 </a:solidFill>
@@ -5121,9 +5121,49 @@
                 <a:ea typeface="Calibri" pitchFamily="34" charset="-122"/>
                 <a:cs typeface="Calibri" pitchFamily="34" charset="-120"/>
               </a:rPr>
-              <a:t>独立 IPPO 缺乏隐式表征与全局价值引导，网络梯度充斥互干扰噪声，训练坠入 -7,536 死锁平台。</a:t>
-            </a:r>
-            <a:endParaRPr lang="en-US" sz="1700" dirty="0"/>
+              <a:t>致命缺陷: 独立 IPPO 缺乏隐式表征与全局价值引导</a:t>
+            </a:r>
+            <a:endParaRPr lang="en-US" sz="1600" dirty="0"/>
+          </a:p>
+          <a:p>
+            <a:pPr indent="0" marL="0">
+              <a:lnSpc>
+                <a:spcPct val="155000"/>
+              </a:lnSpc>
+              <a:buNone/>
+            </a:pPr>
+            <a:r>
+              <a:rPr lang="en-US" sz="1600" dirty="0">
+                <a:solidFill>
+                  <a:srgbClr val="4A5568"/>
+                </a:solidFill>
+                <a:latin typeface="Calibri" pitchFamily="34" charset="0"/>
+                <a:ea typeface="Calibri" pitchFamily="34" charset="-122"/>
+                <a:cs typeface="Calibri" pitchFamily="34" charset="-120"/>
+              </a:rPr>
+              <a:t>具体表现: 网络梯度充斥互干扰噪声，训练坠入 -7,536 死锁平台</a:t>
+            </a:r>
+            <a:endParaRPr lang="en-US" sz="1600" dirty="0"/>
+          </a:p>
+          <a:p>
+            <a:pPr indent="0" marL="0">
+              <a:lnSpc>
+                <a:spcPct val="155000"/>
+              </a:lnSpc>
+              <a:buNone/>
+            </a:pPr>
+            <a:r>
+              <a:rPr lang="en-US" sz="1600" dirty="0">
+                <a:solidFill>
+                  <a:srgbClr val="4A5568"/>
+                </a:solidFill>
+                <a:latin typeface="Calibri" pitchFamily="34" charset="0"/>
+                <a:ea typeface="Calibri" pitchFamily="34" charset="-122"/>
+                <a:cs typeface="Calibri" pitchFamily="34" charset="-120"/>
+              </a:rPr>
+              <a:t>根因: 同质 Agent 缺乏显式通信，对称性内卷无法自发打破</a:t>
+            </a:r>
+            <a:endParaRPr lang="en-US" sz="1600" dirty="0"/>
           </a:p>
         </p:txBody>
       </p:sp>
@@ -5135,8 +5175,8 @@
         </p:nvSpPr>
         <p:spPr>
           <a:xfrm>
-            <a:off x="411480" y="5303520"/>
-            <a:ext cx="3474720" cy="594360"/>
+            <a:off x="365760" y="5303520"/>
+            <a:ext cx="3520440" cy="594360"/>
           </a:xfrm>
           <a:prstGeom prst="roundRect">
             <a:avLst>
@@ -5157,8 +5197,8 @@
         </p:nvSpPr>
         <p:spPr>
           <a:xfrm>
-            <a:off x="502920" y="5303520"/>
-            <a:ext cx="3291840" cy="594360"/>
+            <a:off x="457200" y="5303520"/>
+            <a:ext cx="3337560" cy="594360"/>
           </a:xfrm>
           <a:prstGeom prst="rect">
             <a:avLst/>
@@ -5196,12 +5236,12 @@
         </p:nvSpPr>
         <p:spPr>
           <a:xfrm>
-            <a:off x="4206240" y="777240"/>
-            <a:ext cx="3749040" cy="5669280"/>
+            <a:off x="4160520" y="777240"/>
+            <a:ext cx="3794760" cy="5715000"/>
           </a:xfrm>
           <a:prstGeom prst="roundRect">
             <a:avLst>
-              <a:gd name="adj" fmla="val 1220"/>
+              <a:gd name="adj" fmla="val 1205"/>
             </a:avLst>
           </a:prstGeom>
           <a:solidFill>
@@ -5225,8 +5265,8 @@
         </p:nvSpPr>
         <p:spPr>
           <a:xfrm>
-            <a:off x="4343400" y="868680"/>
-            <a:ext cx="3474720" cy="411480"/>
+            <a:off x="4297680" y="868680"/>
+            <a:ext cx="3520440" cy="384048"/>
           </a:xfrm>
           <a:prstGeom prst="rect">
             <a:avLst/>
@@ -5242,7 +5282,7 @@
               <a:buNone/>
             </a:pPr>
             <a:r>
-              <a:rPr lang="en-US" sz="1800" b="1" dirty="0">
+              <a:rPr lang="en-US" sz="1700" b="1" dirty="0">
                 <a:solidFill>
                   <a:srgbClr val="F96167"/>
                 </a:solidFill>
@@ -5252,7 +5292,7 @@
               </a:rPr>
               <a:t>B. 探索高斯噪声耗散</a:t>
             </a:r>
-            <a:endParaRPr lang="en-US" sz="1800" dirty="0"/>
+            <a:endParaRPr lang="en-US" sz="1700" dirty="0"/>
           </a:p>
         </p:txBody>
       </p:sp>
@@ -5264,8 +5304,8 @@
         </p:nvSpPr>
         <p:spPr>
           <a:xfrm>
-            <a:off x="4343400" y="1371600"/>
-            <a:ext cx="3474720" cy="3657600"/>
+            <a:off x="4297680" y="1325880"/>
+            <a:ext cx="3520440" cy="3657600"/>
           </a:xfrm>
           <a:prstGeom prst="rect">
             <a:avLst/>
@@ -5279,12 +5319,12 @@
           <a:p>
             <a:pPr indent="0" marL="0">
               <a:lnSpc>
-                <a:spcPct val="160000"/>
+                <a:spcPct val="155000"/>
               </a:lnSpc>
               <a:buNone/>
             </a:pPr>
             <a:r>
-              <a:rPr lang="en-US" sz="1700" b="1" dirty="0">
+              <a:rPr lang="en-US" sz="1600" dirty="0">
                 <a:solidFill>
                   <a:srgbClr val="4A5568"/>
                 </a:solidFill>
@@ -5292,9 +5332,49 @@
                 <a:ea typeface="Calibri" pitchFamily="34" charset="-122"/>
                 <a:cs typeface="Calibri" pitchFamily="34" charset="-120"/>
               </a:rPr>
-              <a:t>连续 Box(2) 依赖高斯方差盲目探索，600 步长时序中动作高频抖动 (Chattering)，无法输出坚决战术决断。</a:t>
-            </a:r>
-            <a:endParaRPr lang="en-US" sz="1700" dirty="0"/>
+              <a:t>致命缺陷: 连续 Box(2) 依赖高斯方差盲目探索</a:t>
+            </a:r>
+            <a:endParaRPr lang="en-US" sz="1600" dirty="0"/>
+          </a:p>
+          <a:p>
+            <a:pPr indent="0" marL="0">
+              <a:lnSpc>
+                <a:spcPct val="155000"/>
+              </a:lnSpc>
+              <a:buNone/>
+            </a:pPr>
+            <a:r>
+              <a:rPr lang="en-US" sz="1600" dirty="0">
+                <a:solidFill>
+                  <a:srgbClr val="4A5568"/>
+                </a:solidFill>
+                <a:latin typeface="Calibri" pitchFamily="34" charset="0"/>
+                <a:ea typeface="Calibri" pitchFamily="34" charset="-122"/>
+                <a:cs typeface="Calibri" pitchFamily="34" charset="-120"/>
+              </a:rPr>
+              <a:t>具体表现: 600 步长时序中动作高频抖动 (Chattering)，无法输出坚决战术决断</a:t>
+            </a:r>
+            <a:endParaRPr lang="en-US" sz="1600" dirty="0"/>
+          </a:p>
+          <a:p>
+            <a:pPr indent="0" marL="0">
+              <a:lnSpc>
+                <a:spcPct val="155000"/>
+              </a:lnSpc>
+              <a:buNone/>
+            </a:pPr>
+            <a:r>
+              <a:rPr lang="en-US" sz="1600" dirty="0">
+                <a:solidFill>
+                  <a:srgbClr val="4A5568"/>
+                </a:solidFill>
+                <a:latin typeface="Calibri" pitchFamily="34" charset="0"/>
+                <a:ea typeface="Calibri" pitchFamily="34" charset="-122"/>
+                <a:cs typeface="Calibri" pitchFamily="34" charset="-120"/>
+              </a:rPr>
+              <a:t>根因: 探索在 2D 流形上扩散，熵失控至 4.15</a:t>
+            </a:r>
+            <a:endParaRPr lang="en-US" sz="1600" dirty="0"/>
           </a:p>
         </p:txBody>
       </p:sp>
@@ -5306,8 +5386,8 @@
         </p:nvSpPr>
         <p:spPr>
           <a:xfrm>
-            <a:off x="4343400" y="5303520"/>
-            <a:ext cx="3474720" cy="594360"/>
+            <a:off x="4297680" y="5303520"/>
+            <a:ext cx="3520440" cy="594360"/>
           </a:xfrm>
           <a:prstGeom prst="roundRect">
             <a:avLst>
@@ -5328,8 +5408,8 @@
         </p:nvSpPr>
         <p:spPr>
           <a:xfrm>
-            <a:off x="4434840" y="5303520"/>
-            <a:ext cx="3291840" cy="594360"/>
+            <a:off x="4389120" y="5303520"/>
+            <a:ext cx="3337560" cy="594360"/>
           </a:xfrm>
           <a:prstGeom prst="rect">
             <a:avLst/>
@@ -5367,12 +5447,12 @@
         </p:nvSpPr>
         <p:spPr>
           <a:xfrm>
-            <a:off x="8138160" y="777240"/>
-            <a:ext cx="3749040" cy="5669280"/>
+            <a:off x="8092440" y="777240"/>
+            <a:ext cx="3794760" cy="5715000"/>
           </a:xfrm>
           <a:prstGeom prst="roundRect">
             <a:avLst>
-              <a:gd name="adj" fmla="val 1220"/>
+              <a:gd name="adj" fmla="val 1205"/>
             </a:avLst>
           </a:prstGeom>
           <a:solidFill>
@@ -5396,8 +5476,8 @@
         </p:nvSpPr>
         <p:spPr>
           <a:xfrm>
-            <a:off x="8275320" y="868680"/>
-            <a:ext cx="3474720" cy="411480"/>
+            <a:off x="8229600" y="868680"/>
+            <a:ext cx="3520440" cy="384048"/>
           </a:xfrm>
           <a:prstGeom prst="rect">
             <a:avLst/>
@@ -5413,7 +5493,7 @@
               <a:buNone/>
             </a:pPr>
             <a:r>
-              <a:rPr lang="en-US" sz="1800" b="1" dirty="0">
+              <a:rPr lang="en-US" sz="1700" b="1" dirty="0">
                 <a:solidFill>
                   <a:srgbClr val="F96167"/>
                 </a:solidFill>
@@ -5423,7 +5503,7 @@
               </a:rPr>
               <a:t>C. 时空相位脱节 (AND-gate)</a:t>
             </a:r>
-            <a:endParaRPr lang="en-US" sz="1800" dirty="0"/>
+            <a:endParaRPr lang="en-US" sz="1700" dirty="0"/>
           </a:p>
         </p:txBody>
       </p:sp>
@@ -5435,8 +5515,8 @@
         </p:nvSpPr>
         <p:spPr>
           <a:xfrm>
-            <a:off x="8275320" y="1371600"/>
-            <a:ext cx="3474720" cy="3657600"/>
+            <a:off x="8229600" y="1325880"/>
+            <a:ext cx="3520440" cy="3657600"/>
           </a:xfrm>
           <a:prstGeom prst="rect">
             <a:avLst/>
@@ -5450,12 +5530,12 @@
           <a:p>
             <a:pPr indent="0" marL="0">
               <a:lnSpc>
-                <a:spcPct val="160000"/>
+                <a:spcPct val="155000"/>
               </a:lnSpc>
               <a:buNone/>
             </a:pPr>
             <a:r>
-              <a:rPr lang="en-US" sz="1700" b="1" dirty="0">
+              <a:rPr lang="en-US" sz="1600" dirty="0">
                 <a:solidFill>
                   <a:srgbClr val="4A5568"/>
                 </a:solidFill>
@@ -5463,9 +5543,49 @@
                 <a:ea typeface="Calibri" pitchFamily="34" charset="-122"/>
                 <a:cs typeface="Calibri" pitchFamily="34" charset="-120"/>
               </a:rPr>
-              <a:t>空间 34.8° 黄金包抄——合格。时间同步率 0.0%——长机 329m 突入截断，僚机 1,974m 外绝望。交战步数腰斩至 165。</a:t>
-            </a:r>
-            <a:endParaRPr lang="en-US" sz="1700" dirty="0"/>
+              <a:t>致命缺陷: 空间合格 (34.8°) 但时间零分 (同步率 0.0%)</a:t>
+            </a:r>
+            <a:endParaRPr lang="en-US" sz="1600" dirty="0"/>
+          </a:p>
+          <a:p>
+            <a:pPr indent="0" marL="0">
+              <a:lnSpc>
+                <a:spcPct val="155000"/>
+              </a:lnSpc>
+              <a:buNone/>
+            </a:pPr>
+            <a:r>
+              <a:rPr lang="en-US" sz="1600" dirty="0">
+                <a:solidFill>
+                  <a:srgbClr val="4A5568"/>
+                </a:solidFill>
+                <a:latin typeface="Calibri" pitchFamily="34" charset="0"/>
+                <a:ea typeface="Calibri" pitchFamily="34" charset="-122"/>
+                <a:cs typeface="Calibri" pitchFamily="34" charset="-120"/>
+              </a:rPr>
+              <a:t>具体表现: 长机 329m 突入截断，僚机 1,974m 外绝望。交战步数腰斩至 165</a:t>
+            </a:r>
+            <a:endParaRPr lang="en-US" sz="1600" dirty="0"/>
+          </a:p>
+          <a:p>
+            <a:pPr indent="0" marL="0">
+              <a:lnSpc>
+                <a:spcPct val="155000"/>
+              </a:lnSpc>
+              <a:buNone/>
+            </a:pPr>
+            <a:r>
+              <a:rPr lang="en-US" sz="1600" dirty="0">
+                <a:solidFill>
+                  <a:srgbClr val="4A5568"/>
+                </a:solidFill>
+                <a:latin typeface="Calibri" pitchFamily="34" charset="0"/>
+                <a:ea typeface="Calibri" pitchFamily="34" charset="-122"/>
+                <a:cs typeface="Calibri" pitchFamily="34" charset="-120"/>
+              </a:rPr>
+              <a:t>根因: 长机单刀引发环境截断，僚机时间线在半路被无情斩断</a:t>
+            </a:r>
+            <a:endParaRPr lang="en-US" sz="1600" dirty="0"/>
           </a:p>
         </p:txBody>
       </p:sp>
@@ -5477,8 +5597,8 @@
         </p:nvSpPr>
         <p:spPr>
           <a:xfrm>
-            <a:off x="8275320" y="5303520"/>
-            <a:ext cx="3474720" cy="594360"/>
+            <a:off x="8229600" y="5303520"/>
+            <a:ext cx="3520440" cy="594360"/>
           </a:xfrm>
           <a:prstGeom prst="roundRect">
             <a:avLst>
@@ -5499,8 +5619,8 @@
         </p:nvSpPr>
         <p:spPr>
           <a:xfrm>
-            <a:off x="8366760" y="5303520"/>
-            <a:ext cx="3291840" cy="594360"/>
+            <a:off x="8321040" y="5303520"/>
+            <a:ext cx="3337560" cy="594360"/>
           </a:xfrm>
           <a:prstGeom prst="rect">
             <a:avLst/>
@@ -5570,7 +5690,7 @@
         </p:nvSpPr>
         <p:spPr>
           <a:xfrm>
-            <a:off x="274320" y="137160"/>
+            <a:off x="228600" y="109728"/>
             <a:ext cx="45720" cy="365760"/>
           </a:xfrm>
           <a:prstGeom prst="rect">
@@ -5590,8 +5710,8 @@
         </p:nvSpPr>
         <p:spPr>
           <a:xfrm>
-            <a:off x="274320" y="91440"/>
-            <a:ext cx="548640" cy="411480"/>
+            <a:off x="228600" y="73152"/>
+            <a:ext cx="457200" cy="411480"/>
           </a:xfrm>
           <a:prstGeom prst="rect">
             <a:avLst/>
@@ -5607,7 +5727,7 @@
               <a:buNone/>
             </a:pPr>
             <a:r>
-              <a:rPr lang="en-US" sz="2200" b="1" dirty="0">
+              <a:rPr lang="en-US" sz="2000" b="1" dirty="0">
                 <a:solidFill>
                   <a:srgbClr val="F96167"/>
                 </a:solidFill>
@@ -5617,7 +5737,7 @@
               </a:rPr>
               <a:t>2</a:t>
             </a:r>
-            <a:endParaRPr lang="en-US" sz="2200" dirty="0"/>
+            <a:endParaRPr lang="en-US" sz="2000" dirty="0"/>
           </a:p>
         </p:txBody>
       </p:sp>
@@ -5629,8 +5749,8 @@
         </p:nvSpPr>
         <p:spPr>
           <a:xfrm>
-            <a:off x="822960" y="91440"/>
-            <a:ext cx="411480" cy="0"/>
+            <a:off x="731520" y="73152"/>
+            <a:ext cx="11155680" cy="457200"/>
           </a:xfrm>
           <a:prstGeom prst="rect">
             <a:avLst/>
@@ -5646,7 +5766,7 @@
               <a:buNone/>
             </a:pPr>
             <a:r>
-              <a:rPr lang="en-US" sz="2600" b="1" dirty="0">
+              <a:rPr lang="en-US" sz="2400" b="1" dirty="0">
                 <a:solidFill>
                   <a:srgbClr val="065A82"/>
                 </a:solidFill>
@@ -5656,7 +5776,7 @@
               </a:rPr>
               <a:t>架构重构 A: 参数共享 Self-Attention CTDE</a:t>
             </a:r>
-            <a:endParaRPr lang="en-US" sz="2600" dirty="0"/>
+            <a:endParaRPr lang="en-US" sz="2400" dirty="0"/>
           </a:p>
         </p:txBody>
       </p:sp>
@@ -5668,8 +5788,8 @@
         </p:nvSpPr>
         <p:spPr>
           <a:xfrm>
-            <a:off x="274320" y="566928"/>
-            <a:ext cx="11612880" cy="9144"/>
+            <a:off x="228600" y="566928"/>
+            <a:ext cx="11704320" cy="9144"/>
           </a:xfrm>
           <a:prstGeom prst="rect">
             <a:avLst/>
@@ -5688,12 +5808,12 @@
         </p:nvSpPr>
         <p:spPr>
           <a:xfrm>
-            <a:off x="274320" y="777240"/>
-            <a:ext cx="5943600" cy="1371600"/>
+            <a:off x="228600" y="777240"/>
+            <a:ext cx="5943600" cy="1433322"/>
           </a:xfrm>
           <a:prstGeom prst="roundRect">
             <a:avLst>
-              <a:gd name="adj" fmla="val 3333"/>
+              <a:gd name="adj" fmla="val 3190"/>
             </a:avLst>
           </a:prstGeom>
           <a:solidFill>
@@ -5717,8 +5837,8 @@
         </p:nvSpPr>
         <p:spPr>
           <a:xfrm>
-            <a:off x="438912" y="777240"/>
-            <a:ext cx="5614416" cy="1371600"/>
+            <a:off x="411480" y="777240"/>
+            <a:ext cx="5577840" cy="1433322"/>
           </a:xfrm>
           <a:prstGeom prst="rect">
             <a:avLst/>
@@ -5732,12 +5852,12 @@
           <a:p>
             <a:pPr indent="0" marL="0">
               <a:lnSpc>
-                <a:spcPct val="115000"/>
+                <a:spcPct val="112000"/>
               </a:lnSpc>
               <a:buNone/>
             </a:pPr>
             <a:r>
-              <a:rPr lang="en-US" sz="1700" b="1" dirty="0">
+              <a:rPr lang="en-US" sz="1600" b="1" dirty="0">
                 <a:solidFill>
                   <a:srgbClr val="4A5568"/>
                 </a:solidFill>
@@ -5745,9 +5865,9 @@
                 <a:ea typeface="Calibri" pitchFamily="34" charset="-122"/>
                 <a:cs typeface="Calibri" pitchFamily="34" charset="-120"/>
               </a:rPr>
-              <a:t>打破扁平拼接: 33-dim 解耦为 Self(13) / Target(14) / Mate(6) 三个独立语义 Token，通过线性层映射到 d=128 高阶表征空间</a:t>
-            </a:r>
-            <a:endParaRPr lang="en-US" sz="1700" dirty="0"/>
+              <a:t>[特征解耦] 打破扁平拼接: 33-dim 观测解耦为 Self(13) / Target(14) / Mate(6) 三个独立语义 Token，通过线性层映射到 d=128 高阶表征空间</a:t>
+            </a:r>
+            <a:endParaRPr lang="en-US" sz="1600" dirty="0"/>
           </a:p>
         </p:txBody>
       </p:sp>
@@ -5759,12 +5879,12 @@
         </p:nvSpPr>
         <p:spPr>
           <a:xfrm>
-            <a:off x="274320" y="2221992"/>
-            <a:ext cx="5943600" cy="1371600"/>
+            <a:off x="228600" y="2265426"/>
+            <a:ext cx="5943600" cy="1433322"/>
           </a:xfrm>
           <a:prstGeom prst="roundRect">
             <a:avLst>
-              <a:gd name="adj" fmla="val 3333"/>
+              <a:gd name="adj" fmla="val 3190"/>
             </a:avLst>
           </a:prstGeom>
           <a:solidFill>
@@ -5788,8 +5908,8 @@
         </p:nvSpPr>
         <p:spPr>
           <a:xfrm>
-            <a:off x="438912" y="2221992"/>
-            <a:ext cx="5614416" cy="1371600"/>
+            <a:off x="411480" y="2265426"/>
+            <a:ext cx="5577840" cy="1433322"/>
           </a:xfrm>
           <a:prstGeom prst="rect">
             <a:avLst/>
@@ -5803,12 +5923,12 @@
           <a:p>
             <a:pPr indent="0" marL="0">
               <a:lnSpc>
-                <a:spcPct val="115000"/>
+                <a:spcPct val="112000"/>
               </a:lnSpc>
               <a:buNone/>
             </a:pPr>
             <a:r>
-              <a:rPr lang="en-US" sz="1700" b="1" dirty="0">
+              <a:rPr lang="en-US" sz="1600" b="1" dirty="0">
                 <a:solidFill>
                   <a:srgbClr val="4A5568"/>
                 </a:solidFill>
@@ -5816,9 +5936,9 @@
                 <a:ea typeface="Calibri" pitchFamily="34" charset="-122"/>
                 <a:cs typeface="Calibri" pitchFamily="34" charset="-120"/>
               </a:rPr>
-              <a:t>4-Head MHA (d=128) → Learned Attention Pooling → MLP [256,256] → 动作输出。Q-K-V 交互建立 Self-Mate-Target 三维运动学关联</a:t>
-            </a:r>
-            <a:endParaRPr lang="en-US" sz="1700" dirty="0"/>
+              <a:t>[注意力路由] 4-Head MHA (d=128): Q-K-V 交互强迫智能体在表征层内部自发建立 Self-Mate-Target 三维相对运动学关联与拓扑约束</a:t>
+            </a:r>
+            <a:endParaRPr lang="en-US" sz="1600" dirty="0"/>
           </a:p>
         </p:txBody>
       </p:sp>
@@ -5830,12 +5950,12 @@
         </p:nvSpPr>
         <p:spPr>
           <a:xfrm>
-            <a:off x="274320" y="3666744"/>
-            <a:ext cx="5943600" cy="1371600"/>
+            <a:off x="228600" y="3753612"/>
+            <a:ext cx="5943600" cy="1433322"/>
           </a:xfrm>
           <a:prstGeom prst="roundRect">
             <a:avLst>
-              <a:gd name="adj" fmla="val 3333"/>
+              <a:gd name="adj" fmla="val 3190"/>
             </a:avLst>
           </a:prstGeom>
           <a:solidFill>
@@ -5859,8 +5979,8 @@
         </p:nvSpPr>
         <p:spPr>
           <a:xfrm>
-            <a:off x="438912" y="3666744"/>
-            <a:ext cx="5614416" cy="1371600"/>
+            <a:off x="411480" y="3753612"/>
+            <a:ext cx="5577840" cy="1433322"/>
           </a:xfrm>
           <a:prstGeom prst="rect">
             <a:avLst/>
@@ -5874,12 +5994,12 @@
           <a:p>
             <a:pPr indent="0" marL="0">
               <a:lnSpc>
-                <a:spcPct val="115000"/>
+                <a:spcPct val="112000"/>
               </a:lnSpc>
               <a:buNone/>
             </a:pPr>
             <a:r>
-              <a:rPr lang="en-US" sz="1700" b="1" dirty="0">
+              <a:rPr lang="en-US" sz="1600" b="1" dirty="0">
                 <a:solidFill>
                   <a:srgbClr val="4A5568"/>
                 </a:solidFill>
@@ -5887,9 +6007,9 @@
                 <a:ea typeface="Calibri" pitchFamily="34" charset="-122"/>
                 <a:cs typeface="Calibri" pitchFamily="34" charset="-120"/>
               </a:rPr>
-              <a:t>参数共享 + 位置无关性 (Permutation Invariance): 同权重不同 Mate Token → 自注意力层自发引爆角色分化</a:t>
-            </a:r>
-            <a:endParaRPr lang="en-US" sz="1700" dirty="0"/>
+              <a:t>[对称破缺] 参数共享 + 位置无关性 (Permutation Invariance): 同权重不同 Mate Token → 自注意力层自发引爆异质化角色分化</a:t>
+            </a:r>
+            <a:endParaRPr lang="en-US" sz="1600" dirty="0"/>
           </a:p>
         </p:txBody>
       </p:sp>
@@ -5901,12 +6021,12 @@
         </p:nvSpPr>
         <p:spPr>
           <a:xfrm>
-            <a:off x="274320" y="5111496"/>
-            <a:ext cx="5943600" cy="1371600"/>
+            <a:off x="228600" y="5241798"/>
+            <a:ext cx="5943600" cy="1433322"/>
           </a:xfrm>
           <a:prstGeom prst="roundRect">
             <a:avLst>
-              <a:gd name="adj" fmla="val 3333"/>
+              <a:gd name="adj" fmla="val 3190"/>
             </a:avLst>
           </a:prstGeom>
           <a:solidFill>
@@ -5930,8 +6050,8 @@
         </p:nvSpPr>
         <p:spPr>
           <a:xfrm>
-            <a:off x="438912" y="5111496"/>
-            <a:ext cx="5614416" cy="1371600"/>
+            <a:off x="411480" y="5241798"/>
+            <a:ext cx="5577840" cy="1433322"/>
           </a:xfrm>
           <a:prstGeom prst="rect">
             <a:avLst/>
@@ -5945,12 +6065,12 @@
           <a:p>
             <a:pPr indent="0" marL="0">
               <a:lnSpc>
-                <a:spcPct val="115000"/>
+                <a:spcPct val="112000"/>
               </a:lnSpc>
               <a:buNone/>
             </a:pPr>
             <a:r>
-              <a:rPr lang="en-US" sz="1700" b="1" dirty="0">
+              <a:rPr lang="en-US" sz="1600" b="1" dirty="0">
                 <a:solidFill>
                   <a:srgbClr val="4A5568"/>
                 </a:solidFill>
@@ -5958,26 +6078,49 @@
                 <a:ea typeface="Calibri" pitchFamily="34" charset="-122"/>
                 <a:cs typeface="Calibri" pitchFamily="34" charset="-120"/>
               </a:rPr>
-              <a:t>Centralized Critic: 接收两机联合全局运动学状态，为分布式执行提供无偏低方差全局价值引导信号</a:t>
-            </a:r>
-            <a:endParaRPr lang="en-US" sz="1700" dirty="0"/>
-          </a:p>
-        </p:txBody>
-      </p:sp>
-      <p:sp>
-        <p:nvSpPr>
-          <p:cNvPr id="14" name="Shape 12"/>
-          <p:cNvSpPr/>
-          <p:nvPr/>
-        </p:nvSpPr>
+              <a:t>[价值引导] Centralized Critic: 评论员接收两机联合全局运动学状态，为分布式执行提供无偏低方差全局价值信号</a:t>
+            </a:r>
+            <a:endParaRPr lang="en-US" sz="1600" dirty="0"/>
+          </a:p>
+        </p:txBody>
+      </p:sp>
+      <p:pic>
+        <p:nvPicPr>
+          <p:cNvPr id="14" name="Image 0" descr="results/viz/fig_self_attention_arch.png">    </p:cNvPr>
+          <p:cNvPicPr>
+            <a:picLocks noChangeAspect="1"/>
+          </p:cNvPicPr>
+          <p:nvPr/>
+        </p:nvPicPr>
+        <p:blipFill>
+          <a:blip r:embed="rId1"/>
+          <a:srcRect l="0" r="0" t="0" b="0"/>
+          <a:stretch/>
+        </p:blipFill>
         <p:spPr>
           <a:xfrm>
             <a:off x="6583680" y="777240"/>
-            <a:ext cx="1737360" cy="1188720"/>
+            <a:ext cx="5303520" cy="5029200"/>
+          </a:xfrm>
+          <a:prstGeom prst="rect">
+            <a:avLst/>
+          </a:prstGeom>
+        </p:spPr>
+      </p:pic>
+      <p:sp>
+        <p:nvSpPr>
+          <p:cNvPr id="15" name="Shape 12"/>
+          <p:cNvSpPr/>
+          <p:nvPr/>
+        </p:nvSpPr>
+        <p:spPr>
+          <a:xfrm>
+            <a:off x="6583680" y="5669280"/>
+            <a:ext cx="1691640" cy="1097280"/>
           </a:xfrm>
           <a:prstGeom prst="roundRect">
             <a:avLst>
-              <a:gd name="adj" fmla="val 3846"/>
+              <a:gd name="adj" fmla="val 4167"/>
             </a:avLst>
           </a:prstGeom>
           <a:solidFill>
@@ -5995,14 +6138,14 @@
       </p:sp>
       <p:sp>
         <p:nvSpPr>
-          <p:cNvPr id="15" name="Text 13"/>
-          <p:cNvSpPr/>
-          <p:nvPr/>
-        </p:nvSpPr>
-        <p:spPr>
-          <a:xfrm>
-            <a:off x="6583680" y="813816"/>
-            <a:ext cx="1737360" cy="457200"/>
+          <p:cNvPr id="16" name="Text 13"/>
+          <p:cNvSpPr/>
+          <p:nvPr/>
+        </p:nvSpPr>
+        <p:spPr>
+          <a:xfrm>
+            <a:off x="6583680" y="5705856"/>
+            <a:ext cx="1691640" cy="457200"/>
           </a:xfrm>
           <a:prstGeom prst="rect">
             <a:avLst/>
@@ -6018,7 +6161,7 @@
               <a:buNone/>
             </a:pPr>
             <a:r>
-              <a:rPr lang="en-US" sz="2800" b="1" dirty="0">
+              <a:rPr lang="en-US" sz="2600" b="1" dirty="0">
                 <a:solidFill>
                   <a:srgbClr val="F96167"/>
                 </a:solidFill>
@@ -6028,20 +6171,20 @@
               </a:rPr>
               <a:t>0.450</a:t>
             </a:r>
-            <a:endParaRPr lang="en-US" sz="2800" dirty="0"/>
-          </a:p>
-        </p:txBody>
-      </p:sp>
-      <p:sp>
-        <p:nvSpPr>
-          <p:cNvPr id="16" name="Text 14"/>
-          <p:cNvSpPr/>
-          <p:nvPr/>
-        </p:nvSpPr>
-        <p:spPr>
-          <a:xfrm>
-            <a:off x="6583680" y="1280160"/>
-            <a:ext cx="1737360" cy="320040"/>
+            <a:endParaRPr lang="en-US" sz="2600" dirty="0"/>
+          </a:p>
+        </p:txBody>
+      </p:sp>
+      <p:sp>
+        <p:nvSpPr>
+          <p:cNvPr id="17" name="Text 14"/>
+          <p:cNvSpPr/>
+          <p:nvPr/>
+        </p:nvSpPr>
+        <p:spPr>
+          <a:xfrm>
+            <a:off x="6583680" y="6172200"/>
+            <a:ext cx="1691640" cy="320040"/>
           </a:xfrm>
           <a:prstGeom prst="rect">
             <a:avLst/>
@@ -6060,7 +6203,7 @@
               <a:buNone/>
             </a:pPr>
             <a:r>
-              <a:rPr lang="en-US" sz="1200" b="1" dirty="0">
+              <a:rPr lang="en-US" sz="1100" b="1" dirty="0">
                 <a:solidFill>
                   <a:srgbClr val="4A5568"/>
                 </a:solidFill>
@@ -6070,7 +6213,7 @@
               </a:rPr>
               <a:t>Striker</a:t>
             </a:r>
-            <a:endParaRPr lang="en-US" sz="1200" dirty="0"/>
+            <a:endParaRPr lang="en-US" sz="1100" dirty="0"/>
           </a:p>
           <a:p>
             <a:pPr algn="ctr" indent="0" marL="0">
@@ -6080,7 +6223,7 @@
               <a:buNone/>
             </a:pPr>
             <a:r>
-              <a:rPr lang="en-US" sz="1200" b="1" dirty="0">
+              <a:rPr lang="en-US" sz="1100" b="1" dirty="0">
                 <a:solidFill>
                   <a:srgbClr val="4A5568"/>
                 </a:solidFill>
@@ -6088,26 +6231,26 @@
                 <a:ea typeface="Calibri" pitchFamily="34" charset="-122"/>
                 <a:cs typeface="Calibri" pitchFamily="34" charset="-120"/>
               </a:rPr>
-              <a:t>Self→Mate</a:t>
-            </a:r>
-            <a:endParaRPr lang="en-US" sz="1200" dirty="0"/>
-          </a:p>
-        </p:txBody>
-      </p:sp>
-      <p:sp>
-        <p:nvSpPr>
-          <p:cNvPr id="17" name="Shape 15"/>
-          <p:cNvSpPr/>
-          <p:nvPr/>
-        </p:nvSpPr>
-        <p:spPr>
-          <a:xfrm>
-            <a:off x="8503920" y="777240"/>
-            <a:ext cx="1737360" cy="1188720"/>
+              <a:t>Self-&gt;Mate</a:t>
+            </a:r>
+            <a:endParaRPr lang="en-US" sz="1100" dirty="0"/>
+          </a:p>
+        </p:txBody>
+      </p:sp>
+      <p:sp>
+        <p:nvSpPr>
+          <p:cNvPr id="18" name="Shape 15"/>
+          <p:cNvSpPr/>
+          <p:nvPr/>
+        </p:nvSpPr>
+        <p:spPr>
+          <a:xfrm>
+            <a:off x="8503920" y="5669280"/>
+            <a:ext cx="1691640" cy="1097280"/>
           </a:xfrm>
           <a:prstGeom prst="roundRect">
             <a:avLst>
-              <a:gd name="adj" fmla="val 3846"/>
+              <a:gd name="adj" fmla="val 4167"/>
             </a:avLst>
           </a:prstGeom>
           <a:solidFill>
@@ -6125,14 +6268,14 @@
       </p:sp>
       <p:sp>
         <p:nvSpPr>
-          <p:cNvPr id="18" name="Text 16"/>
-          <p:cNvSpPr/>
-          <p:nvPr/>
-        </p:nvSpPr>
-        <p:spPr>
-          <a:xfrm>
-            <a:off x="8503920" y="813816"/>
-            <a:ext cx="1737360" cy="457200"/>
+          <p:cNvPr id="19" name="Text 16"/>
+          <p:cNvSpPr/>
+          <p:nvPr/>
+        </p:nvSpPr>
+        <p:spPr>
+          <a:xfrm>
+            <a:off x="8503920" y="5705856"/>
+            <a:ext cx="1691640" cy="457200"/>
           </a:xfrm>
           <a:prstGeom prst="rect">
             <a:avLst/>
@@ -6148,7 +6291,7 @@
               <a:buNone/>
             </a:pPr>
             <a:r>
-              <a:rPr lang="en-US" sz="2800" b="1" dirty="0">
+              <a:rPr lang="en-US" sz="2600" b="1" dirty="0">
                 <a:solidFill>
                   <a:srgbClr val="F96167"/>
                 </a:solidFill>
@@ -6158,20 +6301,20 @@
               </a:rPr>
               <a:t>-0.53</a:t>
             </a:r>
-            <a:endParaRPr lang="en-US" sz="2800" dirty="0"/>
-          </a:p>
-        </p:txBody>
-      </p:sp>
-      <p:sp>
-        <p:nvSpPr>
-          <p:cNvPr id="19" name="Text 17"/>
-          <p:cNvSpPr/>
-          <p:nvPr/>
-        </p:nvSpPr>
-        <p:spPr>
-          <a:xfrm>
-            <a:off x="8503920" y="1280160"/>
-            <a:ext cx="1737360" cy="320040"/>
+            <a:endParaRPr lang="en-US" sz="2600" dirty="0"/>
+          </a:p>
+        </p:txBody>
+      </p:sp>
+      <p:sp>
+        <p:nvSpPr>
+          <p:cNvPr id="20" name="Text 17"/>
+          <p:cNvSpPr/>
+          <p:nvPr/>
+        </p:nvSpPr>
+        <p:spPr>
+          <a:xfrm>
+            <a:off x="8503920" y="6172200"/>
+            <a:ext cx="1691640" cy="320040"/>
           </a:xfrm>
           <a:prstGeom prst="rect">
             <a:avLst/>
@@ -6190,7 +6333,7 @@
               <a:buNone/>
             </a:pPr>
             <a:r>
-              <a:rPr lang="en-US" sz="1200" b="1" dirty="0">
+              <a:rPr lang="en-US" sz="1100" b="1" dirty="0">
                 <a:solidFill>
                   <a:srgbClr val="4A5568"/>
                 </a:solidFill>
@@ -6200,7 +6343,7 @@
               </a:rPr>
               <a:t>Cohen d</a:t>
             </a:r>
-            <a:endParaRPr lang="en-US" sz="1200" dirty="0"/>
+            <a:endParaRPr lang="en-US" sz="1100" dirty="0"/>
           </a:p>
           <a:p>
             <a:pPr algn="ctr" indent="0" marL="0">
@@ -6210,7 +6353,7 @@
               <a:buNone/>
             </a:pPr>
             <a:r>
-              <a:rPr lang="en-US" sz="1200" b="1" dirty="0">
+              <a:rPr lang="en-US" sz="1100" b="1" dirty="0">
                 <a:solidFill>
                   <a:srgbClr val="4A5568"/>
                 </a:solidFill>
@@ -6220,24 +6363,24 @@
               </a:rPr>
               <a:t>(large)</a:t>
             </a:r>
-            <a:endParaRPr lang="en-US" sz="1200" dirty="0"/>
-          </a:p>
-        </p:txBody>
-      </p:sp>
-      <p:sp>
-        <p:nvSpPr>
-          <p:cNvPr id="20" name="Shape 18"/>
-          <p:cNvSpPr/>
-          <p:nvPr/>
-        </p:nvSpPr>
-        <p:spPr>
-          <a:xfrm>
-            <a:off x="10424160" y="777240"/>
-            <a:ext cx="1737360" cy="1188720"/>
+            <a:endParaRPr lang="en-US" sz="1100" dirty="0"/>
+          </a:p>
+        </p:txBody>
+      </p:sp>
+      <p:sp>
+        <p:nvSpPr>
+          <p:cNvPr id="21" name="Shape 18"/>
+          <p:cNvSpPr/>
+          <p:nvPr/>
+        </p:nvSpPr>
+        <p:spPr>
+          <a:xfrm>
+            <a:off x="10424160" y="5669280"/>
+            <a:ext cx="1691640" cy="1097280"/>
           </a:xfrm>
           <a:prstGeom prst="roundRect">
             <a:avLst>
-              <a:gd name="adj" fmla="val 3846"/>
+              <a:gd name="adj" fmla="val 4167"/>
             </a:avLst>
           </a:prstGeom>
           <a:solidFill>
@@ -6255,14 +6398,14 @@
       </p:sp>
       <p:sp>
         <p:nvSpPr>
-          <p:cNvPr id="21" name="Text 19"/>
-          <p:cNvSpPr/>
-          <p:nvPr/>
-        </p:nvSpPr>
-        <p:spPr>
-          <a:xfrm>
-            <a:off x="10424160" y="813816"/>
-            <a:ext cx="1737360" cy="457200"/>
+          <p:cNvPr id="22" name="Text 19"/>
+          <p:cNvSpPr/>
+          <p:nvPr/>
+        </p:nvSpPr>
+        <p:spPr>
+          <a:xfrm>
+            <a:off x="10424160" y="5705856"/>
+            <a:ext cx="1691640" cy="457200"/>
           </a:xfrm>
           <a:prstGeom prst="rect">
             <a:avLst/>
@@ -6278,7 +6421,7 @@
               <a:buNone/>
             </a:pPr>
             <a:r>
-              <a:rPr lang="en-US" sz="2800" b="1" dirty="0">
+              <a:rPr lang="en-US" sz="2600" b="1" dirty="0">
                 <a:solidFill>
                   <a:srgbClr val="F96167"/>
                 </a:solidFill>
@@ -6288,20 +6431,20 @@
               </a:rPr>
               <a:t>0.44</a:t>
             </a:r>
-            <a:endParaRPr lang="en-US" sz="2800" dirty="0"/>
-          </a:p>
-        </p:txBody>
-      </p:sp>
-      <p:sp>
-        <p:nvSpPr>
-          <p:cNvPr id="22" name="Text 20"/>
-          <p:cNvSpPr/>
-          <p:nvPr/>
-        </p:nvSpPr>
-        <p:spPr>
-          <a:xfrm>
-            <a:off x="10424160" y="1280160"/>
-            <a:ext cx="1737360" cy="320040"/>
+            <a:endParaRPr lang="en-US" sz="2600" dirty="0"/>
+          </a:p>
+        </p:txBody>
+      </p:sp>
+      <p:sp>
+        <p:nvSpPr>
+          <p:cNvPr id="23" name="Text 20"/>
+          <p:cNvSpPr/>
+          <p:nvPr/>
+        </p:nvSpPr>
+        <p:spPr>
+          <a:xfrm>
+            <a:off x="10424160" y="6172200"/>
+            <a:ext cx="1691640" cy="320040"/>
           </a:xfrm>
           <a:prstGeom prst="rect">
             <a:avLst/>
@@ -6320,7 +6463,7 @@
               <a:buNone/>
             </a:pPr>
             <a:r>
-              <a:rPr lang="en-US" sz="1200" b="1" dirty="0">
+              <a:rPr lang="en-US" sz="1100" b="1" dirty="0">
                 <a:solidFill>
                   <a:srgbClr val="4A5568"/>
                 </a:solidFill>
@@ -6330,7 +6473,7 @@
               </a:rPr>
               <a:t>Mutual Mate</a:t>
             </a:r>
-            <a:endParaRPr lang="en-US" sz="1200" dirty="0"/>
+            <a:endParaRPr lang="en-US" sz="1100" dirty="0"/>
           </a:p>
           <a:p>
             <a:pPr algn="ctr" indent="0" marL="0">
@@ -6340,7 +6483,7 @@
               <a:buNone/>
             </a:pPr>
             <a:r>
-              <a:rPr lang="en-US" sz="1200" b="1" dirty="0">
+              <a:rPr lang="en-US" sz="1100" b="1" dirty="0">
                 <a:solidFill>
                   <a:srgbClr val="4A5568"/>
                 </a:solidFill>
@@ -6350,33 +6493,10 @@
               </a:rPr>
               <a:t>Attention</a:t>
             </a:r>
-            <a:endParaRPr lang="en-US" sz="1200" dirty="0"/>
-          </a:p>
-        </p:txBody>
-      </p:sp>
-      <p:pic>
-        <p:nvPicPr>
-          <p:cNvPr id="23" name="Image 0" descr="results/viz/fig3_role_attention_matrix.png">    </p:cNvPr>
-          <p:cNvPicPr>
-            <a:picLocks noChangeAspect="1"/>
-          </p:cNvPicPr>
-          <p:nvPr/>
-        </p:nvPicPr>
-        <p:blipFill>
-          <a:blip r:embed="rId1"/>
-          <a:srcRect l="0" r="0" t="0" b="0"/>
-          <a:stretch/>
-        </p:blipFill>
-        <p:spPr>
-          <a:xfrm>
-            <a:off x="6583680" y="2286000"/>
-            <a:ext cx="5029200" cy="4389120"/>
-          </a:xfrm>
-          <a:prstGeom prst="rect">
-            <a:avLst/>
-          </a:prstGeom>
-        </p:spPr>
-      </p:pic>
+            <a:endParaRPr lang="en-US" sz="1100" dirty="0"/>
+          </a:p>
+        </p:txBody>
+      </p:sp>
     </p:spTree>
   </p:cSld>
   <p:clrMapOvr>
@@ -6417,7 +6537,7 @@
         </p:nvSpPr>
         <p:spPr>
           <a:xfrm>
-            <a:off x="274320" y="137160"/>
+            <a:off x="228600" y="109728"/>
             <a:ext cx="45720" cy="365760"/>
           </a:xfrm>
           <a:prstGeom prst="rect">
@@ -6437,8 +6557,8 @@
         </p:nvSpPr>
         <p:spPr>
           <a:xfrm>
-            <a:off x="274320" y="91440"/>
-            <a:ext cx="548640" cy="411480"/>
+            <a:off x="228600" y="73152"/>
+            <a:ext cx="457200" cy="411480"/>
           </a:xfrm>
           <a:prstGeom prst="rect">
             <a:avLst/>
@@ -6454,7 +6574,7 @@
               <a:buNone/>
             </a:pPr>
             <a:r>
-              <a:rPr lang="en-US" sz="2200" b="1" dirty="0">
+              <a:rPr lang="en-US" sz="2000" b="1" dirty="0">
                 <a:solidFill>
                   <a:srgbClr val="F96167"/>
                 </a:solidFill>
@@ -6464,7 +6584,7 @@
               </a:rPr>
               <a:t>3</a:t>
             </a:r>
-            <a:endParaRPr lang="en-US" sz="2200" dirty="0"/>
+            <a:endParaRPr lang="en-US" sz="2000" dirty="0"/>
           </a:p>
         </p:txBody>
       </p:sp>
@@ -6476,8 +6596,8 @@
         </p:nvSpPr>
         <p:spPr>
           <a:xfrm>
-            <a:off x="822960" y="91440"/>
-            <a:ext cx="411480" cy="0"/>
+            <a:off x="731520" y="73152"/>
+            <a:ext cx="11155680" cy="457200"/>
           </a:xfrm>
           <a:prstGeom prst="rect">
             <a:avLst/>
@@ -6493,7 +6613,7 @@
               <a:buNone/>
             </a:pPr>
             <a:r>
-              <a:rPr lang="en-US" sz="2600" b="1" dirty="0">
+              <a:rPr lang="en-US" sz="2400" b="1" dirty="0">
                 <a:solidFill>
                   <a:srgbClr val="065A82"/>
                 </a:solidFill>
@@ -6503,7 +6623,7 @@
               </a:rPr>
               <a:t>架构重构 B: 离散战术图元 + Action Masking 上游剪枝</a:t>
             </a:r>
-            <a:endParaRPr lang="en-US" sz="2600" dirty="0"/>
+            <a:endParaRPr lang="en-US" sz="2400" dirty="0"/>
           </a:p>
         </p:txBody>
       </p:sp>
@@ -6515,8 +6635,8 @@
         </p:nvSpPr>
         <p:spPr>
           <a:xfrm>
-            <a:off x="274320" y="566928"/>
-            <a:ext cx="11612880" cy="9144"/>
+            <a:off x="228600" y="566928"/>
+            <a:ext cx="11704320" cy="9144"/>
           </a:xfrm>
           <a:prstGeom prst="rect">
             <a:avLst/>
@@ -6535,12 +6655,12 @@
         </p:nvSpPr>
         <p:spPr>
           <a:xfrm>
-            <a:off x="274320" y="777240"/>
-            <a:ext cx="5029200" cy="1371600"/>
+            <a:off x="228600" y="777240"/>
+            <a:ext cx="5029200" cy="1463040"/>
           </a:xfrm>
           <a:prstGeom prst="roundRect">
             <a:avLst>
-              <a:gd name="adj" fmla="val 3333"/>
+              <a:gd name="adj" fmla="val 3125"/>
             </a:avLst>
           </a:prstGeom>
           <a:solidFill>
@@ -6564,8 +6684,8 @@
         </p:nvSpPr>
         <p:spPr>
           <a:xfrm>
-            <a:off x="438912" y="777240"/>
-            <a:ext cx="4700016" cy="1371600"/>
+            <a:off x="411480" y="777240"/>
+            <a:ext cx="4663440" cy="1463040"/>
           </a:xfrm>
           <a:prstGeom prst="rect">
             <a:avLst/>
@@ -6579,12 +6699,12 @@
           <a:p>
             <a:pPr indent="0" marL="0">
               <a:lnSpc>
-                <a:spcPct val="115000"/>
+                <a:spcPct val="112000"/>
               </a:lnSpc>
               <a:buNone/>
             </a:pPr>
             <a:r>
-              <a:rPr lang="en-US" sz="1800" b="1" dirty="0">
+              <a:rPr lang="en-US" sz="1700" b="1" dirty="0">
                 <a:solidFill>
                   <a:srgbClr val="4A5568"/>
                 </a:solidFill>
@@ -6592,9 +6712,9 @@
                 <a:ea typeface="Calibri" pitchFamily="34" charset="-122"/>
                 <a:cs typeface="Calibri" pitchFamily="34" charset="-120"/>
               </a:rPr>
-              <a:t>15 种宏观战术图元: 5 档航向率 (急左/缓左/直飞/缓右/急右) × 3 档速度基线 (慢速180m/s / 巡航250m/s / 加力320m/s)</a:t>
-            </a:r>
-            <a:endParaRPr lang="en-US" sz="1800" dirty="0"/>
+              <a:t>[维度压缩] 15 种宏观战术图元: 5 档航向率 (急左/缓左/直飞/缓右/急右) × 3 档速度基线 (慢速180 / 巡航250 / 加力320 m/s)</a:t>
+            </a:r>
+            <a:endParaRPr lang="en-US" sz="1700" dirty="0"/>
           </a:p>
         </p:txBody>
       </p:sp>
@@ -6606,12 +6726,12 @@
         </p:nvSpPr>
         <p:spPr>
           <a:xfrm>
-            <a:off x="274320" y="2221992"/>
-            <a:ext cx="5029200" cy="1371600"/>
+            <a:off x="228600" y="2295144"/>
+            <a:ext cx="5029200" cy="1463040"/>
           </a:xfrm>
           <a:prstGeom prst="roundRect">
             <a:avLst>
-              <a:gd name="adj" fmla="val 3333"/>
+              <a:gd name="adj" fmla="val 3125"/>
             </a:avLst>
           </a:prstGeom>
           <a:solidFill>
@@ -6635,8 +6755,8 @@
         </p:nvSpPr>
         <p:spPr>
           <a:xfrm>
-            <a:off x="438912" y="2221992"/>
-            <a:ext cx="4700016" cy="1371600"/>
+            <a:off x="411480" y="2295144"/>
+            <a:ext cx="4663440" cy="1463040"/>
           </a:xfrm>
           <a:prstGeom prst="rect">
             <a:avLst/>
@@ -6650,12 +6770,12 @@
           <a:p>
             <a:pPr indent="0" marL="0">
               <a:lnSpc>
-                <a:spcPct val="115000"/>
+                <a:spcPct val="112000"/>
               </a:lnSpc>
               <a:buNone/>
             </a:pPr>
             <a:r>
-              <a:rPr lang="en-US" sz="1800" b="1" dirty="0">
+              <a:rPr lang="en-US" sz="1700" b="1" dirty="0">
                 <a:solidFill>
                   <a:srgbClr val="4A5568"/>
                 </a:solidFill>
@@ -6663,9 +6783,9 @@
                 <a:ea typeface="Calibri" pitchFamily="34" charset="-122"/>
                 <a:cs typeface="Calibri" pitchFamily="34" charset="-120"/>
               </a:rPr>
-              <a:t>探索熵上限数学锁死在 ln(5)+ln(3)≈2.71 —— 硬性约束，从根本上消除浮点边缘高频颤噪 Runaway 现象</a:t>
-            </a:r>
-            <a:endParaRPr lang="en-US" sz="1800" dirty="0"/>
+              <a:t>[熵约束] 探索熵上限数学锁死在 ln(5)+ln(3)≈2.71 ——硬性约束，从根本上消除浮点边缘高频颤噪 Runaway 现象</a:t>
+            </a:r>
+            <a:endParaRPr lang="en-US" sz="1700" dirty="0"/>
           </a:p>
         </p:txBody>
       </p:sp>
@@ -6677,12 +6797,12 @@
         </p:nvSpPr>
         <p:spPr>
           <a:xfrm>
-            <a:off x="274320" y="3666744"/>
-            <a:ext cx="5029200" cy="1371600"/>
+            <a:off x="228600" y="3813048"/>
+            <a:ext cx="5029200" cy="1463040"/>
           </a:xfrm>
           <a:prstGeom prst="roundRect">
             <a:avLst>
-              <a:gd name="adj" fmla="val 3333"/>
+              <a:gd name="adj" fmla="val 3125"/>
             </a:avLst>
           </a:prstGeom>
           <a:solidFill>
@@ -6706,8 +6826,8 @@
         </p:nvSpPr>
         <p:spPr>
           <a:xfrm>
-            <a:off x="438912" y="3666744"/>
-            <a:ext cx="4700016" cy="1371600"/>
+            <a:off x="411480" y="3813048"/>
+            <a:ext cx="4663440" cy="1463040"/>
           </a:xfrm>
           <a:prstGeom prst="rect">
             <a:avLst/>
@@ -6721,12 +6841,12 @@
           <a:p>
             <a:pPr indent="0" marL="0">
               <a:lnSpc>
-                <a:spcPct val="115000"/>
+                <a:spcPct val="112000"/>
               </a:lnSpc>
               <a:buNone/>
             </a:pPr>
             <a:r>
-              <a:rPr lang="en-US" sz="1800" b="1" dirty="0">
+              <a:rPr lang="en-US" sz="1700" b="1" dirty="0">
                 <a:solidFill>
                   <a:srgbClr val="4A5568"/>
                 </a:solidFill>
@@ -6734,9 +6854,9 @@
                 <a:ea typeface="Calibri" pitchFamily="34" charset="-122"/>
                 <a:cs typeface="Calibri" pitchFamily="34" charset="-120"/>
               </a:rPr>
-              <a:t>Action Masking 上游剪枝: 失速(&lt;130m/s)→禁慢速+急转; 近地(&lt;200m)→禁急转; 超速→禁加力。上游 Logits 直接抹为 -inf，为长时序信用分配清除致死混沌梯度</a:t>
-            </a:r>
-            <a:endParaRPr lang="en-US" sz="1800" dirty="0"/>
+              <a:t>[安全剪枝] Action Masking 上游拦截: 失速(&lt;130m/s)→禁慢速+急转; 近地(&lt;200m)→禁急转; 超速→禁加力。上游 Logits 直接抹为 -inf，为长时序信用分配清除致死混沌梯度</a:t>
+            </a:r>
+            <a:endParaRPr lang="en-US" sz="1700" dirty="0"/>
           </a:p>
         </p:txBody>
       </p:sp>
@@ -6748,7 +6868,7 @@
         </p:nvSpPr>
         <p:spPr>
           <a:xfrm>
-            <a:off x="5760720" y="777240"/>
+            <a:off x="5669280" y="777240"/>
             <a:ext cx="2286000" cy="274320"/>
           </a:xfrm>
           <a:prstGeom prst="rect">
@@ -6787,8 +6907,8 @@
         </p:nvSpPr>
         <p:spPr>
           <a:xfrm>
-            <a:off x="5760720" y="1143000"/>
-            <a:ext cx="5760720" cy="402336"/>
+            <a:off x="5669280" y="1115568"/>
+            <a:ext cx="5852160" cy="402336"/>
           </a:xfrm>
           <a:prstGeom prst="roundRect">
             <a:avLst>
@@ -6816,7 +6936,7 @@
         </p:nvSpPr>
         <p:spPr>
           <a:xfrm>
-            <a:off x="5852160" y="1143000"/>
+            <a:off x="5760720" y="1115568"/>
             <a:ext cx="274320" cy="402336"/>
           </a:xfrm>
           <a:prstGeom prst="rect">
@@ -6855,8 +6975,8 @@
         </p:nvSpPr>
         <p:spPr>
           <a:xfrm>
-            <a:off x="6217920" y="1143000"/>
-            <a:ext cx="5120640" cy="402336"/>
+            <a:off x="6126480" y="1115568"/>
+            <a:ext cx="5303520" cy="402336"/>
           </a:xfrm>
           <a:prstGeom prst="rect">
             <a:avLst/>
@@ -6894,8 +7014,8 @@
         </p:nvSpPr>
         <p:spPr>
           <a:xfrm>
-            <a:off x="5760720" y="1581912"/>
-            <a:ext cx="5760720" cy="402336"/>
+            <a:off x="5669280" y="1554480"/>
+            <a:ext cx="5852160" cy="402336"/>
           </a:xfrm>
           <a:prstGeom prst="roundRect">
             <a:avLst>
@@ -6923,7 +7043,7 @@
         </p:nvSpPr>
         <p:spPr>
           <a:xfrm>
-            <a:off x="5852160" y="1581912"/>
+            <a:off x="5760720" y="1554480"/>
             <a:ext cx="274320" cy="402336"/>
           </a:xfrm>
           <a:prstGeom prst="rect">
@@ -6962,8 +7082,8 @@
         </p:nvSpPr>
         <p:spPr>
           <a:xfrm>
-            <a:off x="6217920" y="1581912"/>
-            <a:ext cx="5120640" cy="402336"/>
+            <a:off x="6126480" y="1554480"/>
+            <a:ext cx="5303520" cy="402336"/>
           </a:xfrm>
           <a:prstGeom prst="rect">
             <a:avLst/>
@@ -7001,8 +7121,8 @@
         </p:nvSpPr>
         <p:spPr>
           <a:xfrm>
-            <a:off x="5760720" y="2020824"/>
-            <a:ext cx="5760720" cy="402336"/>
+            <a:off x="5669280" y="1993392"/>
+            <a:ext cx="5852160" cy="402336"/>
           </a:xfrm>
           <a:prstGeom prst="roundRect">
             <a:avLst>
@@ -7030,7 +7150,7 @@
         </p:nvSpPr>
         <p:spPr>
           <a:xfrm>
-            <a:off x="5852160" y="2020824"/>
+            <a:off x="5760720" y="1993392"/>
             <a:ext cx="274320" cy="402336"/>
           </a:xfrm>
           <a:prstGeom prst="rect">
@@ -7069,8 +7189,8 @@
         </p:nvSpPr>
         <p:spPr>
           <a:xfrm>
-            <a:off x="6217920" y="2020824"/>
-            <a:ext cx="5120640" cy="402336"/>
+            <a:off x="6126480" y="1993392"/>
+            <a:ext cx="5303520" cy="402336"/>
           </a:xfrm>
           <a:prstGeom prst="rect">
             <a:avLst/>
@@ -7108,8 +7228,8 @@
         </p:nvSpPr>
         <p:spPr>
           <a:xfrm>
-            <a:off x="5760720" y="2459736"/>
-            <a:ext cx="5760720" cy="402336"/>
+            <a:off x="5669280" y="2432304"/>
+            <a:ext cx="5852160" cy="402336"/>
           </a:xfrm>
           <a:prstGeom prst="roundRect">
             <a:avLst>
@@ -7137,7 +7257,7 @@
         </p:nvSpPr>
         <p:spPr>
           <a:xfrm>
-            <a:off x="5852160" y="2459736"/>
+            <a:off x="5760720" y="2432304"/>
             <a:ext cx="274320" cy="402336"/>
           </a:xfrm>
           <a:prstGeom prst="rect">
@@ -7176,8 +7296,8 @@
         </p:nvSpPr>
         <p:spPr>
           <a:xfrm>
-            <a:off x="6217920" y="2459736"/>
-            <a:ext cx="5120640" cy="402336"/>
+            <a:off x="6126480" y="2432304"/>
+            <a:ext cx="5303520" cy="402336"/>
           </a:xfrm>
           <a:prstGeom prst="rect">
             <a:avLst/>
@@ -7215,8 +7335,8 @@
         </p:nvSpPr>
         <p:spPr>
           <a:xfrm>
-            <a:off x="5760720" y="2898648"/>
-            <a:ext cx="5760720" cy="402336"/>
+            <a:off x="5669280" y="2871216"/>
+            <a:ext cx="5852160" cy="402336"/>
           </a:xfrm>
           <a:prstGeom prst="roundRect">
             <a:avLst>
@@ -7244,7 +7364,7 @@
         </p:nvSpPr>
         <p:spPr>
           <a:xfrm>
-            <a:off x="5852160" y="2898648"/>
+            <a:off x="5760720" y="2871216"/>
             <a:ext cx="274320" cy="402336"/>
           </a:xfrm>
           <a:prstGeom prst="rect">
@@ -7283,8 +7403,8 @@
         </p:nvSpPr>
         <p:spPr>
           <a:xfrm>
-            <a:off x="6217920" y="2898648"/>
-            <a:ext cx="5120640" cy="402336"/>
+            <a:off x="6126480" y="2871216"/>
+            <a:ext cx="5303520" cy="402336"/>
           </a:xfrm>
           <a:prstGeom prst="rect">
             <a:avLst/>
@@ -7322,7 +7442,7 @@
         </p:nvSpPr>
         <p:spPr>
           <a:xfrm>
-            <a:off x="5760720" y="3520440"/>
+            <a:off x="5669280" y="3474720"/>
             <a:ext cx="2286000" cy="274320"/>
           </a:xfrm>
           <a:prstGeom prst="rect">
@@ -7361,8 +7481,8 @@
         </p:nvSpPr>
         <p:spPr>
           <a:xfrm>
-            <a:off x="5760720" y="3867912"/>
-            <a:ext cx="5760720" cy="402336"/>
+            <a:off x="5669280" y="3822192"/>
+            <a:ext cx="5852160" cy="402336"/>
           </a:xfrm>
           <a:prstGeom prst="roundRect">
             <a:avLst>
@@ -7390,7 +7510,7 @@
         </p:nvSpPr>
         <p:spPr>
           <a:xfrm>
-            <a:off x="5852160" y="3867912"/>
+            <a:off x="5760720" y="3822192"/>
             <a:ext cx="274320" cy="402336"/>
           </a:xfrm>
           <a:prstGeom prst="rect">
@@ -7429,8 +7549,8 @@
         </p:nvSpPr>
         <p:spPr>
           <a:xfrm>
-            <a:off x="6217920" y="3867912"/>
-            <a:ext cx="5120640" cy="402336"/>
+            <a:off x="6126480" y="3822192"/>
+            <a:ext cx="5303520" cy="402336"/>
           </a:xfrm>
           <a:prstGeom prst="rect">
             <a:avLst/>
@@ -7468,8 +7588,8 @@
         </p:nvSpPr>
         <p:spPr>
           <a:xfrm>
-            <a:off x="5760720" y="4306824"/>
-            <a:ext cx="5760720" cy="402336"/>
+            <a:off x="5669280" y="4261104"/>
+            <a:ext cx="5852160" cy="402336"/>
           </a:xfrm>
           <a:prstGeom prst="roundRect">
             <a:avLst>
@@ -7497,7 +7617,7 @@
         </p:nvSpPr>
         <p:spPr>
           <a:xfrm>
-            <a:off x="5852160" y="4306824"/>
+            <a:off x="5760720" y="4261104"/>
             <a:ext cx="274320" cy="402336"/>
           </a:xfrm>
           <a:prstGeom prst="rect">
@@ -7536,8 +7656,8 @@
         </p:nvSpPr>
         <p:spPr>
           <a:xfrm>
-            <a:off x="6217920" y="4306824"/>
-            <a:ext cx="5120640" cy="402336"/>
+            <a:off x="6126480" y="4261104"/>
+            <a:ext cx="5303520" cy="402336"/>
           </a:xfrm>
           <a:prstGeom prst="rect">
             <a:avLst/>
@@ -7575,8 +7695,8 @@
         </p:nvSpPr>
         <p:spPr>
           <a:xfrm>
-            <a:off x="5760720" y="4745736"/>
-            <a:ext cx="5760720" cy="402336"/>
+            <a:off x="5669280" y="4700016"/>
+            <a:ext cx="5852160" cy="402336"/>
           </a:xfrm>
           <a:prstGeom prst="roundRect">
             <a:avLst>
@@ -7604,7 +7724,7 @@
         </p:nvSpPr>
         <p:spPr>
           <a:xfrm>
-            <a:off x="5852160" y="4745736"/>
+            <a:off x="5760720" y="4700016"/>
             <a:ext cx="274320" cy="402336"/>
           </a:xfrm>
           <a:prstGeom prst="rect">
@@ -7643,8 +7763,8 @@
         </p:nvSpPr>
         <p:spPr>
           <a:xfrm>
-            <a:off x="6217920" y="4745736"/>
-            <a:ext cx="5120640" cy="402336"/>
+            <a:off x="6126480" y="4700016"/>
+            <a:ext cx="5303520" cy="402336"/>
           </a:xfrm>
           <a:prstGeom prst="rect">
             <a:avLst/>
@@ -7714,7 +7834,7 @@
         </p:nvSpPr>
         <p:spPr>
           <a:xfrm>
-            <a:off x="274320" y="137160"/>
+            <a:off x="228600" y="109728"/>
             <a:ext cx="45720" cy="365760"/>
           </a:xfrm>
           <a:prstGeom prst="rect">
@@ -7734,8 +7854,8 @@
         </p:nvSpPr>
         <p:spPr>
           <a:xfrm>
-            <a:off x="274320" y="91440"/>
-            <a:ext cx="548640" cy="411480"/>
+            <a:off x="228600" y="73152"/>
+            <a:ext cx="457200" cy="411480"/>
           </a:xfrm>
           <a:prstGeom prst="rect">
             <a:avLst/>
@@ -7751,7 +7871,7 @@
               <a:buNone/>
             </a:pPr>
             <a:r>
-              <a:rPr lang="en-US" sz="2200" b="1" dirty="0">
+              <a:rPr lang="en-US" sz="2000" b="1" dirty="0">
                 <a:solidFill>
                   <a:srgbClr val="F96167"/>
                 </a:solidFill>
@@ -7761,7 +7881,7 @@
               </a:rPr>
               <a:t>4</a:t>
             </a:r>
-            <a:endParaRPr lang="en-US" sz="2200" dirty="0"/>
+            <a:endParaRPr lang="en-US" sz="2000" dirty="0"/>
           </a:p>
         </p:txBody>
       </p:sp>
@@ -7773,8 +7893,8 @@
         </p:nvSpPr>
         <p:spPr>
           <a:xfrm>
-            <a:off x="822960" y="91440"/>
-            <a:ext cx="411480" cy="0"/>
+            <a:off x="731520" y="73152"/>
+            <a:ext cx="11155680" cy="457200"/>
           </a:xfrm>
           <a:prstGeom prst="rect">
             <a:avLst/>
@@ -7790,7 +7910,7 @@
               <a:buNone/>
             </a:pPr>
             <a:r>
-              <a:rPr lang="en-US" sz="2600" b="1" dirty="0">
+              <a:rPr lang="en-US" sz="2400" b="1" dirty="0">
                 <a:solidFill>
                   <a:srgbClr val="065A82"/>
                 </a:solidFill>
@@ -7800,7 +7920,7 @@
               </a:rPr>
               <a:t>动作图元时序演变: 从无序探索到确定性战术固化</a:t>
             </a:r>
-            <a:endParaRPr lang="en-US" sz="2600" dirty="0"/>
+            <a:endParaRPr lang="en-US" sz="2400" dirty="0"/>
           </a:p>
         </p:txBody>
       </p:sp>
@@ -7812,8 +7932,8 @@
         </p:nvSpPr>
         <p:spPr>
           <a:xfrm>
-            <a:off x="274320" y="566928"/>
-            <a:ext cx="11612880" cy="9144"/>
+            <a:off x="228600" y="566928"/>
+            <a:ext cx="11704320" cy="9144"/>
           </a:xfrm>
           <a:prstGeom prst="rect">
             <a:avLst/>
@@ -7839,8 +7959,8 @@
         </p:blipFill>
         <p:spPr>
           <a:xfrm>
-            <a:off x="137160" y="822960"/>
-            <a:ext cx="8046720" cy="5760720"/>
+            <a:off x="91440" y="777240"/>
+            <a:ext cx="8046720" cy="5852160"/>
           </a:xfrm>
           <a:prstGeom prst="rect">
             <a:avLst/>
@@ -7855,12 +7975,12 @@
         </p:nvSpPr>
         <p:spPr>
           <a:xfrm>
-            <a:off x="8503920" y="822960"/>
-            <a:ext cx="3474720" cy="1371600"/>
+            <a:off x="8503920" y="777240"/>
+            <a:ext cx="3474720" cy="1463040"/>
           </a:xfrm>
           <a:prstGeom prst="roundRect">
             <a:avLst>
-              <a:gd name="adj" fmla="val 3333"/>
+              <a:gd name="adj" fmla="val 3125"/>
             </a:avLst>
           </a:prstGeom>
           <a:solidFill>
@@ -7884,8 +8004,8 @@
         </p:nvSpPr>
         <p:spPr>
           <a:xfrm>
-            <a:off x="8668512" y="822960"/>
-            <a:ext cx="3145536" cy="1371600"/>
+            <a:off x="8686800" y="777240"/>
+            <a:ext cx="3108960" cy="1463040"/>
           </a:xfrm>
           <a:prstGeom prst="rect">
             <a:avLst/>
@@ -7899,12 +8019,12 @@
           <a:p>
             <a:pPr indent="0" marL="0">
               <a:lnSpc>
-                <a:spcPct val="115000"/>
+                <a:spcPct val="112000"/>
               </a:lnSpc>
               <a:buNone/>
             </a:pPr>
             <a:r>
-              <a:rPr lang="en-US" sz="1600" b="1" dirty="0">
+              <a:rPr lang="en-US" sz="1500" b="1" dirty="0">
                 <a:solidFill>
                   <a:srgbClr val="4A5568"/>
                 </a:solidFill>
@@ -7912,9 +8032,9 @@
                 <a:ea typeface="Calibri" pitchFamily="34" charset="-122"/>
                 <a:cs typeface="Calibri" pitchFamily="34" charset="-120"/>
               </a:rPr>
-              <a:t>早期 (0-50轮): 色块均匀平铺，Categorical 盲目探索期</a:t>
-            </a:r>
-            <a:endParaRPr lang="en-US" sz="1600" dirty="0"/>
+              <a:t>[探索期] 早期 (0-50轮): 色块均匀平铺，智能体处于全局 Categorical 盲目探索期，战术行为充斥着频繁换向与左右拉扯</a:t>
+            </a:r>
+            <a:endParaRPr lang="en-US" sz="1500" dirty="0"/>
           </a:p>
         </p:txBody>
       </p:sp>
@@ -7926,12 +8046,12 @@
         </p:nvSpPr>
         <p:spPr>
           <a:xfrm>
-            <a:off x="8503920" y="2267712"/>
-            <a:ext cx="3474720" cy="1371600"/>
+            <a:off x="8503920" y="2295144"/>
+            <a:ext cx="3474720" cy="1463040"/>
           </a:xfrm>
           <a:prstGeom prst="roundRect">
             <a:avLst>
-              <a:gd name="adj" fmla="val 3333"/>
+              <a:gd name="adj" fmla="val 3125"/>
             </a:avLst>
           </a:prstGeom>
           <a:solidFill>
@@ -7955,8 +8075,8 @@
         </p:nvSpPr>
         <p:spPr>
           <a:xfrm>
-            <a:off x="8668512" y="2267712"/>
-            <a:ext cx="3145536" cy="1371600"/>
+            <a:off x="8686800" y="2295144"/>
+            <a:ext cx="3108960" cy="1463040"/>
           </a:xfrm>
           <a:prstGeom prst="rect">
             <a:avLst/>
@@ -7970,12 +8090,12 @@
           <a:p>
             <a:pPr indent="0" marL="0">
               <a:lnSpc>
-                <a:spcPct val="115000"/>
+                <a:spcPct val="112000"/>
               </a:lnSpc>
               <a:buNone/>
             </a:pPr>
             <a:r>
-              <a:rPr lang="en-US" sz="1600" b="1" dirty="0">
+              <a:rPr lang="en-US" sz="1500" b="1" dirty="0">
                 <a:solidFill>
                   <a:srgbClr val="4A5568"/>
                 </a:solidFill>
@@ -7983,9 +8103,9 @@
                 <a:ea typeface="Calibri" pitchFamily="34" charset="-122"/>
                 <a:cs typeface="Calibri" pitchFamily="34" charset="-120"/>
               </a:rPr>
-              <a:t>后期 (250-320轮): 僚机 Fast (260m/s) 概率锁定 78%+；长机自发大面积 Slow (180m/s)</a:t>
-            </a:r>
-            <a:endParaRPr lang="en-US" sz="1600" dirty="0"/>
+              <a:t>[收敛期] 后期 (250-320轮): 僚机 Fast (260m/s) 概率爆发跃升并单调锁死在 78%+；长机突入内圈后自发将大面积概率分配给 Slow (180m/s) 蓄势等待</a:t>
+            </a:r>
+            <a:endParaRPr lang="en-US" sz="1500" dirty="0"/>
           </a:p>
         </p:txBody>
       </p:sp>
@@ -7997,12 +8117,12 @@
         </p:nvSpPr>
         <p:spPr>
           <a:xfrm>
-            <a:off x="8503920" y="3712464"/>
-            <a:ext cx="3474720" cy="1371600"/>
+            <a:off x="8503920" y="3813048"/>
+            <a:ext cx="3474720" cy="1463040"/>
           </a:xfrm>
           <a:prstGeom prst="roundRect">
             <a:avLst>
-              <a:gd name="adj" fmla="val 3333"/>
+              <a:gd name="adj" fmla="val 3125"/>
             </a:avLst>
           </a:prstGeom>
           <a:solidFill>
@@ -8026,8 +8146,8 @@
         </p:nvSpPr>
         <p:spPr>
           <a:xfrm>
-            <a:off x="8668512" y="3712464"/>
-            <a:ext cx="3145536" cy="1371600"/>
+            <a:off x="8686800" y="3813048"/>
+            <a:ext cx="3108960" cy="1463040"/>
           </a:xfrm>
           <a:prstGeom prst="rect">
             <a:avLst/>
@@ -8041,12 +8161,12 @@
           <a:p>
             <a:pPr indent="0" marL="0">
               <a:lnSpc>
-                <a:spcPct val="115000"/>
+                <a:spcPct val="112000"/>
               </a:lnSpc>
               <a:buNone/>
             </a:pPr>
             <a:r>
-              <a:rPr lang="en-US" sz="1600" b="1" dirty="0">
+              <a:rPr lang="en-US" sz="1500" b="1" dirty="0">
                 <a:solidFill>
                   <a:srgbClr val="4A5568"/>
                 </a:solidFill>
@@ -8054,9 +8174,9 @@
                 <a:ea typeface="Calibri" pitchFamily="34" charset="-122"/>
                 <a:cs typeface="Calibri" pitchFamily="34" charset="-120"/>
               </a:rPr>
-              <a:t>结论: 双机自发通过 80m/s 宏观速度差收拢弧长差——闭环高级协同涌现</a:t>
-            </a:r>
-            <a:endParaRPr lang="en-US" sz="1600" dirty="0"/>
+              <a:t>[战术涌现] 结论: 双机自发通过 80m/s 宏观速度差强行收拢几何弧长差——在离散动作空间中涌现出闭环高级协同形态</a:t>
+            </a:r>
+            <a:endParaRPr lang="en-US" sz="1500" dirty="0"/>
           </a:p>
         </p:txBody>
       </p:sp>
@@ -8100,7 +8220,7 @@
         </p:nvSpPr>
         <p:spPr>
           <a:xfrm>
-            <a:off x="274320" y="137160"/>
+            <a:off x="228600" y="109728"/>
             <a:ext cx="45720" cy="365760"/>
           </a:xfrm>
           <a:prstGeom prst="rect">
@@ -8120,8 +8240,8 @@
         </p:nvSpPr>
         <p:spPr>
           <a:xfrm>
-            <a:off x="274320" y="91440"/>
-            <a:ext cx="548640" cy="411480"/>
+            <a:off x="228600" y="73152"/>
+            <a:ext cx="457200" cy="411480"/>
           </a:xfrm>
           <a:prstGeom prst="rect">
             <a:avLst/>
@@ -8137,7 +8257,7 @@
               <a:buNone/>
             </a:pPr>
             <a:r>
-              <a:rPr lang="en-US" sz="2200" b="1" dirty="0">
+              <a:rPr lang="en-US" sz="2000" b="1" dirty="0">
                 <a:solidFill>
                   <a:srgbClr val="F96167"/>
                 </a:solidFill>
@@ -8147,7 +8267,7 @@
               </a:rPr>
               <a:t>5</a:t>
             </a:r>
-            <a:endParaRPr lang="en-US" sz="2200" dirty="0"/>
+            <a:endParaRPr lang="en-US" sz="2000" dirty="0"/>
           </a:p>
         </p:txBody>
       </p:sp>
@@ -8159,8 +8279,8 @@
         </p:nvSpPr>
         <p:spPr>
           <a:xfrm>
-            <a:off x="822960" y="91440"/>
-            <a:ext cx="411480" cy="0"/>
+            <a:off x="731520" y="73152"/>
+            <a:ext cx="11155680" cy="457200"/>
           </a:xfrm>
           <a:prstGeom prst="rect">
             <a:avLst/>
@@ -8176,7 +8296,7 @@
               <a:buNone/>
             </a:pPr>
             <a:r>
-              <a:rPr lang="en-US" sz="2600" b="1" dirty="0">
+              <a:rPr lang="en-US" sz="2400" b="1" dirty="0">
                 <a:solidFill>
                   <a:srgbClr val="065A82"/>
                 </a:solidFill>
@@ -8186,7 +8306,7 @@
               </a:rPr>
               <a:t>核心机制创新: 动态包线退火 (DAC) + 非对称惩罚</a:t>
             </a:r>
-            <a:endParaRPr lang="en-US" sz="2600" dirty="0"/>
+            <a:endParaRPr lang="en-US" sz="2400" dirty="0"/>
           </a:p>
         </p:txBody>
       </p:sp>
@@ -8198,8 +8318,8 @@
         </p:nvSpPr>
         <p:spPr>
           <a:xfrm>
-            <a:off x="274320" y="566928"/>
-            <a:ext cx="11612880" cy="9144"/>
+            <a:off x="228600" y="566928"/>
+            <a:ext cx="11704320" cy="9144"/>
           </a:xfrm>
           <a:prstGeom prst="rect">
             <a:avLst/>
@@ -8218,12 +8338,12 @@
         </p:nvSpPr>
         <p:spPr>
           <a:xfrm>
-            <a:off x="274320" y="777240"/>
-            <a:ext cx="6583680" cy="1371600"/>
+            <a:off x="228600" y="777240"/>
+            <a:ext cx="6583680" cy="1433322"/>
           </a:xfrm>
           <a:prstGeom prst="roundRect">
             <a:avLst>
-              <a:gd name="adj" fmla="val 3333"/>
+              <a:gd name="adj" fmla="val 3190"/>
             </a:avLst>
           </a:prstGeom>
           <a:solidFill>
@@ -8247,8 +8367,8 @@
         </p:nvSpPr>
         <p:spPr>
           <a:xfrm>
-            <a:off x="438912" y="777240"/>
-            <a:ext cx="6254496" cy="1371600"/>
+            <a:off x="411480" y="777240"/>
+            <a:ext cx="6217920" cy="1433322"/>
           </a:xfrm>
           <a:prstGeom prst="rect">
             <a:avLst/>
@@ -8262,7 +8382,7 @@
           <a:p>
             <a:pPr indent="0" marL="0">
               <a:lnSpc>
-                <a:spcPct val="115000"/>
+                <a:spcPct val="112000"/>
               </a:lnSpc>
               <a:buNone/>
             </a:pPr>
@@ -8275,7 +8395,7 @@
                 <a:ea typeface="Calibri" pitchFamily="34" charset="-122"/>
                 <a:cs typeface="Calibri" pitchFamily="34" charset="-120"/>
               </a:rPr>
-              <a:t>距离不对称惩罚 (DAP): |d0-d1|&gt;500m → 团队受罚，全时动态监控双机瞬时间距，强行摧毁分布式早期盲目搭便车死锁</a:t>
+              <a:t>[惩罚机制] 距离不对称惩罚 (DAP): |d0-d1|&gt;500m → 团队受罚，全时动态监控双机瞬时间距，强行摧毁分布式早期盲目搭便车死锁</a:t>
             </a:r>
             <a:endParaRPr lang="en-US" sz="1700" dirty="0"/>
           </a:p>
@@ -8289,12 +8409,12 @@
         </p:nvSpPr>
         <p:spPr>
           <a:xfrm>
-            <a:off x="274320" y="2221992"/>
-            <a:ext cx="6583680" cy="1371600"/>
+            <a:off x="228600" y="2265426"/>
+            <a:ext cx="6583680" cy="1433322"/>
           </a:xfrm>
           <a:prstGeom prst="roundRect">
             <a:avLst>
-              <a:gd name="adj" fmla="val 3333"/>
+              <a:gd name="adj" fmla="val 3190"/>
             </a:avLst>
           </a:prstGeom>
           <a:solidFill>
@@ -8318,8 +8438,8 @@
         </p:nvSpPr>
         <p:spPr>
           <a:xfrm>
-            <a:off x="438912" y="2221992"/>
-            <a:ext cx="6254496" cy="1371600"/>
+            <a:off x="411480" y="2265426"/>
+            <a:ext cx="6217920" cy="1433322"/>
           </a:xfrm>
           <a:prstGeom prst="rect">
             <a:avLst/>
@@ -8333,7 +8453,7 @@
           <a:p>
             <a:pPr indent="0" marL="0">
               <a:lnSpc>
-                <a:spcPct val="115000"/>
+                <a:spcPct val="112000"/>
               </a:lnSpc>
               <a:buNone/>
             </a:pPr>
@@ -8346,7 +8466,7 @@
                 <a:ea typeface="Calibri" pitchFamily="34" charset="-122"/>
                 <a:cs typeface="Calibri" pitchFamily="34" charset="-120"/>
               </a:rPr>
-              <a:t>动态退火 (DAC): Thresh = max(800, 2000−decay×iter)。前 100 轮 2000m 即引爆 +5,000 成功奖赏，漏斗线性收窄至 800m</a:t>
+              <a:t>[课程设计] 动态退火 (DAC): Thresh = max(800, 2000−decay×iter)。前 100 轮 2000m 即引爆 +5,000 成功奖赏，漏斗线性收窄至 800m</a:t>
             </a:r>
             <a:endParaRPr lang="en-US" sz="1700" dirty="0"/>
           </a:p>
@@ -8360,12 +8480,12 @@
         </p:nvSpPr>
         <p:spPr>
           <a:xfrm>
-            <a:off x="274320" y="3666744"/>
-            <a:ext cx="6583680" cy="1371600"/>
+            <a:off x="228600" y="3753612"/>
+            <a:ext cx="6583680" cy="1433322"/>
           </a:xfrm>
           <a:prstGeom prst="roundRect">
             <a:avLst>
-              <a:gd name="adj" fmla="val 3333"/>
+              <a:gd name="adj" fmla="val 3190"/>
             </a:avLst>
           </a:prstGeom>
           <a:solidFill>
@@ -8389,8 +8509,8 @@
         </p:nvSpPr>
         <p:spPr>
           <a:xfrm>
-            <a:off x="438912" y="3666744"/>
-            <a:ext cx="6254496" cy="1371600"/>
+            <a:off x="411480" y="3753612"/>
+            <a:ext cx="6217920" cy="1433322"/>
           </a:xfrm>
           <a:prstGeom prst="rect">
             <a:avLst/>
@@ -8404,7 +8524,7 @@
           <a:p>
             <a:pPr indent="0" marL="0">
               <a:lnSpc>
-                <a:spcPct val="115000"/>
+                <a:spcPct val="112000"/>
               </a:lnSpc>
               <a:buNone/>
             </a:pPr>
@@ -8417,7 +8537,7 @@
                 <a:ea typeface="Calibri" pitchFamily="34" charset="-122"/>
                 <a:cs typeface="Calibri" pitchFamily="34" charset="-120"/>
               </a:rPr>
-              <a:t>配速惩罚: Striker&lt;1200m 且 Interceptor&gt;1500m → 团队受罚，强制长机等待僚机同步，防止独狼贪婪冲锋</a:t>
+              <a:t>[同步约束] 配速惩罚: Striker&lt;1200m 且 Interceptor&gt;1500m → 团队受罚，强制长机等待僚机同步，防止独狼贪婪冲锋</a:t>
             </a:r>
             <a:endParaRPr lang="en-US" sz="1700" dirty="0"/>
           </a:p>
@@ -8431,12 +8551,12 @@
         </p:nvSpPr>
         <p:spPr>
           <a:xfrm>
-            <a:off x="274320" y="5111496"/>
-            <a:ext cx="6583680" cy="1371600"/>
+            <a:off x="228600" y="5241798"/>
+            <a:ext cx="6583680" cy="1433322"/>
           </a:xfrm>
           <a:prstGeom prst="roundRect">
             <a:avLst>
-              <a:gd name="adj" fmla="val 3333"/>
+              <a:gd name="adj" fmla="val 3190"/>
             </a:avLst>
           </a:prstGeom>
           <a:solidFill>
@@ -8460,8 +8580,8 @@
         </p:nvSpPr>
         <p:spPr>
           <a:xfrm>
-            <a:off x="438912" y="5111496"/>
-            <a:ext cx="6254496" cy="1371600"/>
+            <a:off x="411480" y="5241798"/>
+            <a:ext cx="6217920" cy="1433322"/>
           </a:xfrm>
           <a:prstGeom prst="rect">
             <a:avLst/>
@@ -8475,7 +8595,7 @@
           <a:p>
             <a:pPr indent="0" marL="0">
               <a:lnSpc>
-                <a:spcPct val="115000"/>
+                <a:spcPct val="112000"/>
               </a:lnSpc>
               <a:buNone/>
             </a:pPr>
@@ -8488,7 +8608,7 @@
                 <a:ea typeface="Calibri" pitchFamily="34" charset="-122"/>
                 <a:cs typeface="Calibri" pitchFamily="34" charset="-120"/>
               </a:rPr>
-              <a:t>综合效果: AND-gate 基线从 −5,909 暴力拉升 5,000 分至 −1,171 突破性高度</a:t>
+              <a:t>[综合效果] DAC 联合机制将 AND-gate 基线从 −5,909 暴力拉升 5,000 分至 −1,171 突破性高度</a:t>
             </a:r>
             <a:endParaRPr lang="en-US" sz="1700" dirty="0"/>
           </a:p>
@@ -8502,7 +8622,7 @@
         </p:nvSpPr>
         <p:spPr>
           <a:xfrm>
-            <a:off x="7315200" y="777240"/>
+            <a:off x="7132320" y="777240"/>
             <a:ext cx="2377440" cy="1280160"/>
           </a:xfrm>
           <a:prstGeom prst="roundRect">
@@ -8531,7 +8651,7 @@
         </p:nvSpPr>
         <p:spPr>
           <a:xfrm>
-            <a:off x="7315200" y="813816"/>
+            <a:off x="7132320" y="813816"/>
             <a:ext cx="2377440" cy="457200"/>
           </a:xfrm>
           <a:prstGeom prst="rect">
@@ -8548,7 +8668,7 @@
               <a:buNone/>
             </a:pPr>
             <a:r>
-              <a:rPr lang="en-US" sz="2800" b="1" dirty="0">
+              <a:rPr lang="en-US" sz="2600" b="1" dirty="0">
                 <a:solidFill>
                   <a:srgbClr val="F96167"/>
                 </a:solidFill>
@@ -8558,7 +8678,7 @@
               </a:rPr>
               <a:t>+5,000</a:t>
             </a:r>
-            <a:endParaRPr lang="en-US" sz="2800" dirty="0"/>
+            <a:endParaRPr lang="en-US" sz="2600" dirty="0"/>
           </a:p>
         </p:txBody>
       </p:sp>
@@ -8570,7 +8690,7 @@
         </p:nvSpPr>
         <p:spPr>
           <a:xfrm>
-            <a:off x="7315200" y="1280160"/>
+            <a:off x="7132320" y="1280160"/>
             <a:ext cx="2377440" cy="320040"/>
           </a:xfrm>
           <a:prstGeom prst="rect">
@@ -8590,7 +8710,7 @@
               <a:buNone/>
             </a:pPr>
             <a:r>
-              <a:rPr lang="en-US" sz="1200" b="1" dirty="0">
+              <a:rPr lang="en-US" sz="1100" b="1" dirty="0">
                 <a:solidFill>
                   <a:srgbClr val="4A5568"/>
                 </a:solidFill>
@@ -8600,7 +8720,7 @@
               </a:rPr>
               <a:t>DAC 拉升</a:t>
             </a:r>
-            <a:endParaRPr lang="en-US" sz="1200" dirty="0"/>
+            <a:endParaRPr lang="en-US" sz="1100" dirty="0"/>
           </a:p>
           <a:p>
             <a:pPr algn="ctr" indent="0" marL="0">
@@ -8610,7 +8730,7 @@
               <a:buNone/>
             </a:pPr>
             <a:r>
-              <a:rPr lang="en-US" sz="1200" b="1" dirty="0">
+              <a:rPr lang="en-US" sz="1100" b="1" dirty="0">
                 <a:solidFill>
                   <a:srgbClr val="4A5568"/>
                 </a:solidFill>
@@ -8620,7 +8740,7 @@
               </a:rPr>
               <a:t>(vs 严格)</a:t>
             </a:r>
-            <a:endParaRPr lang="en-US" sz="1200" dirty="0"/>
+            <a:endParaRPr lang="en-US" sz="1100" dirty="0"/>
           </a:p>
         </p:txBody>
       </p:sp>
@@ -8632,7 +8752,7 @@
         </p:nvSpPr>
         <p:spPr>
           <a:xfrm>
-            <a:off x="9829800" y="777240"/>
+            <a:off x="9646920" y="777240"/>
             <a:ext cx="2377440" cy="1280160"/>
           </a:xfrm>
           <a:prstGeom prst="roundRect">
@@ -8661,7 +8781,7 @@
         </p:nvSpPr>
         <p:spPr>
           <a:xfrm>
-            <a:off x="9829800" y="813816"/>
+            <a:off x="9646920" y="813816"/>
             <a:ext cx="2377440" cy="457200"/>
           </a:xfrm>
           <a:prstGeom prst="rect">
@@ -8678,7 +8798,7 @@
               <a:buNone/>
             </a:pPr>
             <a:r>
-              <a:rPr lang="en-US" sz="2800" b="1" dirty="0">
+              <a:rPr lang="en-US" sz="2600" b="1" dirty="0">
                 <a:solidFill>
                   <a:srgbClr val="F96167"/>
                 </a:solidFill>
@@ -8688,7 +8808,7 @@
               </a:rPr>
               <a:t>-5,909</a:t>
             </a:r>
-            <a:endParaRPr lang="en-US" sz="2800" dirty="0"/>
+            <a:endParaRPr lang="en-US" sz="2600" dirty="0"/>
           </a:p>
         </p:txBody>
       </p:sp>
@@ -8700,7 +8820,7 @@
         </p:nvSpPr>
         <p:spPr>
           <a:xfrm>
-            <a:off x="9829800" y="1280160"/>
+            <a:off x="9646920" y="1280160"/>
             <a:ext cx="2377440" cy="320040"/>
           </a:xfrm>
           <a:prstGeom prst="rect">
@@ -8720,7 +8840,7 @@
               <a:buNone/>
             </a:pPr>
             <a:r>
-              <a:rPr lang="en-US" sz="1200" b="1" dirty="0">
+              <a:rPr lang="en-US" sz="1100" b="1" dirty="0">
                 <a:solidFill>
                   <a:srgbClr val="4A5568"/>
                 </a:solidFill>
@@ -8730,7 +8850,7 @@
               </a:rPr>
               <a:t>重构前</a:t>
             </a:r>
-            <a:endParaRPr lang="en-US" sz="1200" dirty="0"/>
+            <a:endParaRPr lang="en-US" sz="1100" dirty="0"/>
           </a:p>
           <a:p>
             <a:pPr algn="ctr" indent="0" marL="0">
@@ -8740,7 +8860,7 @@
               <a:buNone/>
             </a:pPr>
             <a:r>
-              <a:rPr lang="en-US" sz="1200" b="1" dirty="0">
+              <a:rPr lang="en-US" sz="1100" b="1" dirty="0">
                 <a:solidFill>
                   <a:srgbClr val="4A5568"/>
                 </a:solidFill>
@@ -8750,7 +8870,7 @@
               </a:rPr>
               <a:t>基线</a:t>
             </a:r>
-            <a:endParaRPr lang="en-US" sz="1200" dirty="0"/>
+            <a:endParaRPr lang="en-US" sz="1100" dirty="0"/>
           </a:p>
         </p:txBody>
       </p:sp>
@@ -8762,7 +8882,7 @@
         </p:nvSpPr>
         <p:spPr>
           <a:xfrm>
-            <a:off x="7315200" y="2194560"/>
+            <a:off x="7132320" y="2194560"/>
             <a:ext cx="2377440" cy="1280160"/>
           </a:xfrm>
           <a:prstGeom prst="roundRect">
@@ -8791,7 +8911,7 @@
         </p:nvSpPr>
         <p:spPr>
           <a:xfrm>
-            <a:off x="7315200" y="2231136"/>
+            <a:off x="7132320" y="2231136"/>
             <a:ext cx="2377440" cy="457200"/>
           </a:xfrm>
           <a:prstGeom prst="rect">
@@ -8808,7 +8928,7 @@
               <a:buNone/>
             </a:pPr>
             <a:r>
-              <a:rPr lang="en-US" sz="2800" b="1" dirty="0">
+              <a:rPr lang="en-US" sz="2600" b="1" dirty="0">
                 <a:solidFill>
                   <a:srgbClr val="F96167"/>
                 </a:solidFill>
@@ -8818,7 +8938,7 @@
               </a:rPr>
               <a:t>-1,171</a:t>
             </a:r>
-            <a:endParaRPr lang="en-US" sz="2800" dirty="0"/>
+            <a:endParaRPr lang="en-US" sz="2600" dirty="0"/>
           </a:p>
         </p:txBody>
       </p:sp>
@@ -8830,7 +8950,7 @@
         </p:nvSpPr>
         <p:spPr>
           <a:xfrm>
-            <a:off x="7315200" y="2697480"/>
+            <a:off x="7132320" y="2697480"/>
             <a:ext cx="2377440" cy="320040"/>
           </a:xfrm>
           <a:prstGeom prst="rect">
@@ -8850,7 +8970,7 @@
               <a:buNone/>
             </a:pPr>
             <a:r>
-              <a:rPr lang="en-US" sz="1200" b="1" dirty="0">
+              <a:rPr lang="en-US" sz="1100" b="1" dirty="0">
                 <a:solidFill>
                   <a:srgbClr val="4A5568"/>
                 </a:solidFill>
@@ -8860,7 +8980,7 @@
               </a:rPr>
               <a:t>DAC 后</a:t>
             </a:r>
-            <a:endParaRPr lang="en-US" sz="1200" dirty="0"/>
+            <a:endParaRPr lang="en-US" sz="1100" dirty="0"/>
           </a:p>
           <a:p>
             <a:pPr algn="ctr" indent="0" marL="0">
@@ -8870,7 +8990,7 @@
               <a:buNone/>
             </a:pPr>
             <a:r>
-              <a:rPr lang="en-US" sz="1200" b="1" dirty="0">
+              <a:rPr lang="en-US" sz="1100" b="1" dirty="0">
                 <a:solidFill>
                   <a:srgbClr val="4A5568"/>
                 </a:solidFill>
@@ -8880,7 +9000,7 @@
               </a:rPr>
               <a:t>最优</a:t>
             </a:r>
-            <a:endParaRPr lang="en-US" sz="1200" dirty="0"/>
+            <a:endParaRPr lang="en-US" sz="1100" dirty="0"/>
           </a:p>
         </p:txBody>
       </p:sp>
@@ -8892,7 +9012,7 @@
         </p:nvSpPr>
         <p:spPr>
           <a:xfrm>
-            <a:off x="9829800" y="2194560"/>
+            <a:off x="9646920" y="2194560"/>
             <a:ext cx="2377440" cy="1280160"/>
           </a:xfrm>
           <a:prstGeom prst="roundRect">
@@ -8921,7 +9041,7 @@
         </p:nvSpPr>
         <p:spPr>
           <a:xfrm>
-            <a:off x="9829800" y="2231136"/>
+            <a:off x="9646920" y="2231136"/>
             <a:ext cx="2377440" cy="457200"/>
           </a:xfrm>
           <a:prstGeom prst="rect">
@@ -8938,7 +9058,7 @@
               <a:buNone/>
             </a:pPr>
             <a:r>
-              <a:rPr lang="en-US" sz="2800" b="1" dirty="0">
+              <a:rPr lang="en-US" sz="2600" b="1" dirty="0">
                 <a:solidFill>
                   <a:srgbClr val="F96167"/>
                 </a:solidFill>
@@ -8948,7 +9068,7 @@
               </a:rPr>
               <a:t>1,974m</a:t>
             </a:r>
-            <a:endParaRPr lang="en-US" sz="2800" dirty="0"/>
+            <a:endParaRPr lang="en-US" sz="2600" dirty="0"/>
           </a:p>
         </p:txBody>
       </p:sp>
@@ -8960,7 +9080,7 @@
         </p:nvSpPr>
         <p:spPr>
           <a:xfrm>
-            <a:off x="9829800" y="2697480"/>
+            <a:off x="9646920" y="2697480"/>
             <a:ext cx="2377440" cy="320040"/>
           </a:xfrm>
           <a:prstGeom prst="rect">
@@ -8980,7 +9100,7 @@
               <a:buNone/>
             </a:pPr>
             <a:r>
-              <a:rPr lang="en-US" sz="1200" b="1" dirty="0">
+              <a:rPr lang="en-US" sz="1100" b="1" dirty="0">
                 <a:solidFill>
                   <a:srgbClr val="4A5568"/>
                 </a:solidFill>
@@ -8990,7 +9110,7 @@
               </a:rPr>
               <a:t>P1 中位</a:t>
             </a:r>
-            <a:endParaRPr lang="en-US" sz="1200" dirty="0"/>
+            <a:endParaRPr lang="en-US" sz="1100" dirty="0"/>
           </a:p>
           <a:p>
             <a:pPr algn="ctr" indent="0" marL="0">
@@ -9000,7 +9120,7 @@
               <a:buNone/>
             </a:pPr>
             <a:r>
-              <a:rPr lang="en-US" sz="1200" b="1" dirty="0">
+              <a:rPr lang="en-US" sz="1100" b="1" dirty="0">
                 <a:solidFill>
                   <a:srgbClr val="4A5568"/>
                 </a:solidFill>
@@ -9010,7 +9130,7 @@
               </a:rPr>
               <a:t>(极限)</a:t>
             </a:r>
-            <a:endParaRPr lang="en-US" sz="1200" dirty="0"/>
+            <a:endParaRPr lang="en-US" sz="1100" dirty="0"/>
           </a:p>
         </p:txBody>
       </p:sp>
@@ -9054,7 +9174,7 @@
         </p:nvSpPr>
         <p:spPr>
           <a:xfrm>
-            <a:off x="274320" y="137160"/>
+            <a:off x="228600" y="109728"/>
             <a:ext cx="45720" cy="365760"/>
           </a:xfrm>
           <a:prstGeom prst="rect">
@@ -9074,8 +9194,8 @@
         </p:nvSpPr>
         <p:spPr>
           <a:xfrm>
-            <a:off x="274320" y="91440"/>
-            <a:ext cx="548640" cy="411480"/>
+            <a:off x="228600" y="73152"/>
+            <a:ext cx="457200" cy="411480"/>
           </a:xfrm>
           <a:prstGeom prst="rect">
             <a:avLst/>
@@ -9091,7 +9211,7 @@
               <a:buNone/>
             </a:pPr>
             <a:r>
-              <a:rPr lang="en-US" sz="2200" b="1" dirty="0">
+              <a:rPr lang="en-US" sz="2000" b="1" dirty="0">
                 <a:solidFill>
                   <a:srgbClr val="F96167"/>
                 </a:solidFill>
@@ -9101,7 +9221,7 @@
               </a:rPr>
               <a:t>6</a:t>
             </a:r>
-            <a:endParaRPr lang="en-US" sz="2200" dirty="0"/>
+            <a:endParaRPr lang="en-US" sz="2000" dirty="0"/>
           </a:p>
         </p:txBody>
       </p:sp>
@@ -9113,8 +9233,8 @@
         </p:nvSpPr>
         <p:spPr>
           <a:xfrm>
-            <a:off x="822960" y="91440"/>
-            <a:ext cx="411480" cy="0"/>
+            <a:off x="731520" y="73152"/>
+            <a:ext cx="11155680" cy="457200"/>
           </a:xfrm>
           <a:prstGeom prst="rect">
             <a:avLst/>
@@ -9130,7 +9250,7 @@
               <a:buNone/>
             </a:pPr>
             <a:r>
-              <a:rPr lang="en-US" sz="2600" b="1" dirty="0">
+              <a:rPr lang="en-US" sz="2400" b="1" dirty="0">
                 <a:solidFill>
                   <a:srgbClr val="065A82"/>
                 </a:solidFill>
@@ -9140,7 +9260,7 @@
               </a:rPr>
               <a:t>奖励成分解耦: 课程学习的梯度接力实证</a:t>
             </a:r>
-            <a:endParaRPr lang="en-US" sz="2600" dirty="0"/>
+            <a:endParaRPr lang="en-US" sz="2400" dirty="0"/>
           </a:p>
         </p:txBody>
       </p:sp>
@@ -9152,8 +9272,8 @@
         </p:nvSpPr>
         <p:spPr>
           <a:xfrm>
-            <a:off x="274320" y="566928"/>
-            <a:ext cx="11612880" cy="9144"/>
+            <a:off x="228600" y="566928"/>
+            <a:ext cx="11704320" cy="9144"/>
           </a:xfrm>
           <a:prstGeom prst="rect">
             <a:avLst/>
@@ -9179,8 +9299,8 @@
         </p:blipFill>
         <p:spPr>
           <a:xfrm>
-            <a:off x="137160" y="822960"/>
-            <a:ext cx="7772400" cy="5760720"/>
+            <a:off x="91440" y="777240"/>
+            <a:ext cx="7772400" cy="5852160"/>
           </a:xfrm>
           <a:prstGeom prst="rect">
             <a:avLst/>
@@ -9195,12 +9315,12 @@
         </p:nvSpPr>
         <p:spPr>
           <a:xfrm>
-            <a:off x="8229600" y="822960"/>
-            <a:ext cx="3657600" cy="1371600"/>
+            <a:off x="8229600" y="777240"/>
+            <a:ext cx="3657600" cy="1463040"/>
           </a:xfrm>
           <a:prstGeom prst="roundRect">
             <a:avLst>
-              <a:gd name="adj" fmla="val 3333"/>
+              <a:gd name="adj" fmla="val 3125"/>
             </a:avLst>
           </a:prstGeom>
           <a:solidFill>
@@ -9224,8 +9344,8 @@
         </p:nvSpPr>
         <p:spPr>
           <a:xfrm>
-            <a:off x="8394192" y="822960"/>
-            <a:ext cx="3328416" cy="1371600"/>
+            <a:off x="8412480" y="777240"/>
+            <a:ext cx="3291840" cy="1463040"/>
           </a:xfrm>
           <a:prstGeom prst="rect">
             <a:avLst/>
@@ -9239,12 +9359,12 @@
           <a:p>
             <a:pPr indent="0" marL="0">
               <a:lnSpc>
-                <a:spcPct val="115000"/>
+                <a:spcPct val="112000"/>
               </a:lnSpc>
               <a:buNone/>
             </a:pPr>
             <a:r>
-              <a:rPr lang="en-US" sz="1600" b="1" dirty="0">
+              <a:rPr lang="en-US" sz="1500" b="1" dirty="0">
                 <a:solidFill>
                   <a:srgbClr val="4A5568"/>
                 </a:solidFill>
@@ -9252,9 +9372,9 @@
                 <a:ea typeface="Calibri" pitchFamily="34" charset="-122"/>
                 <a:cs typeface="Calibri" pitchFamily="34" charset="-120"/>
               </a:rPr>
-              <a:t>前 100 轮: Progress+ATA 主导贡献，DAP 面积被压低。智能体高频吸收空间收拢稠密梯度，未发生 Reward Hacking</a:t>
-            </a:r>
-            <a:endParaRPr lang="en-US" sz="1600" dirty="0"/>
+              <a:t>[Phase 1] 前 100 轮: Progress+ATA 主导贡献，DAP 惩罚面积被压低。智能体高频吸收空间收拢稠密梯度，未发生 Reward Hacking</a:t>
+            </a:r>
+            <a:endParaRPr lang="en-US" sz="1500" dirty="0"/>
           </a:p>
         </p:txBody>
       </p:sp>
@@ -9266,12 +9386,12 @@
         </p:nvSpPr>
         <p:spPr>
           <a:xfrm>
-            <a:off x="8229600" y="2267712"/>
-            <a:ext cx="3657600" cy="1371600"/>
+            <a:off x="8229600" y="2295144"/>
+            <a:ext cx="3657600" cy="1463040"/>
           </a:xfrm>
           <a:prstGeom prst="roundRect">
             <a:avLst>
-              <a:gd name="adj" fmla="val 3333"/>
+              <a:gd name="adj" fmla="val 3125"/>
             </a:avLst>
           </a:prstGeom>
           <a:solidFill>
@@ -9295,8 +9415,8 @@
         </p:nvSpPr>
         <p:spPr>
           <a:xfrm>
-            <a:off x="8394192" y="2267712"/>
-            <a:ext cx="3328416" cy="1371600"/>
+            <a:off x="8412480" y="2295144"/>
+            <a:ext cx="3291840" cy="1463040"/>
           </a:xfrm>
           <a:prstGeom prst="rect">
             <a:avLst/>
@@ -9310,12 +9430,12 @@
           <a:p>
             <a:pPr indent="0" marL="0">
               <a:lnSpc>
-                <a:spcPct val="115000"/>
+                <a:spcPct val="112000"/>
               </a:lnSpc>
               <a:buNone/>
             </a:pPr>
             <a:r>
-              <a:rPr lang="en-US" sz="1600" b="1" dirty="0">
+              <a:rPr lang="en-US" sz="1500" b="1" dirty="0">
                 <a:solidFill>
                   <a:srgbClr val="4A5568"/>
                 </a:solidFill>
@@ -9323,9 +9443,9 @@
                 <a:ea typeface="Calibri" pitchFamily="34" charset="-122"/>
                 <a:cs typeface="Calibri" pitchFamily="34" charset="-120"/>
               </a:rPr>
-              <a:t>150 轮后 (退火收紧): Progress 平滑趋于饱和，协同合围成功奖励面积呈统计显著性单调扩张</a:t>
-            </a:r>
-            <a:endParaRPr lang="en-US" sz="1600" dirty="0"/>
+              <a:t>[Phase 2] 150 轮后 (退火收紧): Progress 平滑趋于饱和，协同合围成功奖励亮色面积开始呈统计显著性单调扩张</a:t>
+            </a:r>
+            <a:endParaRPr lang="en-US" sz="1500" dirty="0"/>
           </a:p>
         </p:txBody>
       </p:sp>
@@ -9337,12 +9457,12 @@
         </p:nvSpPr>
         <p:spPr>
           <a:xfrm>
-            <a:off x="8229600" y="3712464"/>
-            <a:ext cx="3657600" cy="1371600"/>
+            <a:off x="8229600" y="3813048"/>
+            <a:ext cx="3657600" cy="1463040"/>
           </a:xfrm>
           <a:prstGeom prst="roundRect">
             <a:avLst>
-              <a:gd name="adj" fmla="val 3333"/>
+              <a:gd name="adj" fmla="val 3125"/>
             </a:avLst>
           </a:prstGeom>
           <a:solidFill>
@@ -9366,8 +9486,8 @@
         </p:nvSpPr>
         <p:spPr>
           <a:xfrm>
-            <a:off x="8394192" y="3712464"/>
-            <a:ext cx="3328416" cy="1371600"/>
+            <a:off x="8412480" y="3813048"/>
+            <a:ext cx="3291840" cy="1463040"/>
           </a:xfrm>
           <a:prstGeom prst="rect">
             <a:avLst/>
@@ -9381,12 +9501,12 @@
           <a:p>
             <a:pPr indent="0" marL="0">
               <a:lnSpc>
-                <a:spcPct val="115000"/>
+                <a:spcPct val="112000"/>
               </a:lnSpc>
               <a:buNone/>
             </a:pPr>
             <a:r>
-              <a:rPr lang="en-US" sz="1600" b="1" dirty="0">
+              <a:rPr lang="en-US" sz="1500" b="1" dirty="0">
                 <a:solidFill>
                   <a:srgbClr val="4A5568"/>
                 </a:solidFill>
@@ -9394,9 +9514,9 @@
                 <a:ea typeface="Calibri" pitchFamily="34" charset="-122"/>
                 <a:cs typeface="Calibri" pitchFamily="34" charset="-120"/>
               </a:rPr>
-              <a:t>完美 Handover: 梯度从空间引导平滑接力到协同合围——课程学习搭梯子跨越价值真空区的演进机理</a:t>
-            </a:r>
-            <a:endParaRPr lang="en-US" sz="1600" dirty="0"/>
+              <a:t>[机理] 完美 Handover: 梯度从空间引导平滑接力到协同合围——课程学习搭梯子跨越价值真空区的演进机理</a:t>
+            </a:r>
+            <a:endParaRPr lang="en-US" sz="1500" dirty="0"/>
           </a:p>
         </p:txBody>
       </p:sp>
@@ -9440,7 +9560,7 @@
         </p:nvSpPr>
         <p:spPr>
           <a:xfrm>
-            <a:off x="274320" y="137160"/>
+            <a:off x="228600" y="109728"/>
             <a:ext cx="45720" cy="365760"/>
           </a:xfrm>
           <a:prstGeom prst="rect">
@@ -9460,8 +9580,8 @@
         </p:nvSpPr>
         <p:spPr>
           <a:xfrm>
-            <a:off x="274320" y="91440"/>
-            <a:ext cx="548640" cy="411480"/>
+            <a:off x="228600" y="73152"/>
+            <a:ext cx="457200" cy="411480"/>
           </a:xfrm>
           <a:prstGeom prst="rect">
             <a:avLst/>
@@ -9477,7 +9597,7 @@
               <a:buNone/>
             </a:pPr>
             <a:r>
-              <a:rPr lang="en-US" sz="2200" b="1" dirty="0">
+              <a:rPr lang="en-US" sz="2000" b="1" dirty="0">
                 <a:solidFill>
                   <a:srgbClr val="F96167"/>
                 </a:solidFill>
@@ -9487,7 +9607,7 @@
               </a:rPr>
               <a:t>7</a:t>
             </a:r>
-            <a:endParaRPr lang="en-US" sz="2200" dirty="0"/>
+            <a:endParaRPr lang="en-US" sz="2000" dirty="0"/>
           </a:p>
         </p:txBody>
       </p:sp>
@@ -9499,8 +9619,8 @@
         </p:nvSpPr>
         <p:spPr>
           <a:xfrm>
-            <a:off x="822960" y="91440"/>
-            <a:ext cx="411480" cy="0"/>
+            <a:off x="731520" y="73152"/>
+            <a:ext cx="11155680" cy="457200"/>
           </a:xfrm>
           <a:prstGeom prst="rect">
             <a:avLst/>
@@ -9516,7 +9636,7 @@
               <a:buNone/>
             </a:pPr>
             <a:r>
-              <a:rPr lang="en-US" sz="2600" b="1" dirty="0">
+              <a:rPr lang="en-US" sz="2400" b="1" dirty="0">
                 <a:solidFill>
                   <a:srgbClr val="065A82"/>
                 </a:solidFill>
@@ -9526,7 +9646,7 @@
               </a:rPr>
               <a:t>全版本消融大盘点: 六代模型完整进化证据链</a:t>
             </a:r>
-            <a:endParaRPr lang="en-US" sz="2600" dirty="0"/>
+            <a:endParaRPr lang="en-US" sz="2400" dirty="0"/>
           </a:p>
         </p:txBody>
       </p:sp>
@@ -9538,8 +9658,8 @@
         </p:nvSpPr>
         <p:spPr>
           <a:xfrm>
-            <a:off x="274320" y="566928"/>
-            <a:ext cx="11612880" cy="9144"/>
+            <a:off x="228600" y="566928"/>
+            <a:ext cx="11704320" cy="9144"/>
           </a:xfrm>
           <a:prstGeom prst="rect">
             <a:avLst/>
@@ -9798,7 +9918,7 @@
                 <a:ea typeface="Georgia" pitchFamily="34" charset="-122"/>
                 <a:cs typeface="Georgia" pitchFamily="34" charset="-120"/>
               </a:rPr>
-              <a:t>最佳 Eval</a:t>
+              <a:t>最佳Eval</a:t>
             </a:r>
             <a:endParaRPr lang="en-US" sz="1100" dirty="0"/>
           </a:p>
@@ -12383,7 +12503,7 @@
         </p:nvSpPr>
         <p:spPr>
           <a:xfrm>
-            <a:off x="274320" y="137160"/>
+            <a:off x="228600" y="109728"/>
             <a:ext cx="45720" cy="365760"/>
           </a:xfrm>
           <a:prstGeom prst="rect">
@@ -12403,8 +12523,8 @@
         </p:nvSpPr>
         <p:spPr>
           <a:xfrm>
-            <a:off x="274320" y="91440"/>
-            <a:ext cx="548640" cy="411480"/>
+            <a:off x="228600" y="73152"/>
+            <a:ext cx="457200" cy="411480"/>
           </a:xfrm>
           <a:prstGeom prst="rect">
             <a:avLst/>
@@ -12420,7 +12540,7 @@
               <a:buNone/>
             </a:pPr>
             <a:r>
-              <a:rPr lang="en-US" sz="2200" b="1" dirty="0">
+              <a:rPr lang="en-US" sz="2000" b="1" dirty="0">
                 <a:solidFill>
                   <a:srgbClr val="F96167"/>
                 </a:solidFill>
@@ -12430,7 +12550,7 @@
               </a:rPr>
               <a:t>8</a:t>
             </a:r>
-            <a:endParaRPr lang="en-US" sz="2200" dirty="0"/>
+            <a:endParaRPr lang="en-US" sz="2000" dirty="0"/>
           </a:p>
         </p:txBody>
       </p:sp>
@@ -12442,8 +12562,8 @@
         </p:nvSpPr>
         <p:spPr>
           <a:xfrm>
-            <a:off x="822960" y="91440"/>
-            <a:ext cx="411480" cy="0"/>
+            <a:off x="731520" y="73152"/>
+            <a:ext cx="11155680" cy="457200"/>
           </a:xfrm>
           <a:prstGeom prst="rect">
             <a:avLst/>
@@ -12459,7 +12579,7 @@
               <a:buNone/>
             </a:pPr>
             <a:r>
-              <a:rPr lang="en-US" sz="2600" b="1" dirty="0">
+              <a:rPr lang="en-US" sz="2400" b="1" dirty="0">
                 <a:solidFill>
                   <a:srgbClr val="065A82"/>
                 </a:solidFill>
@@ -12469,7 +12589,7 @@
               </a:rPr>
               <a:t>核心成果 1: 离散自注意力下的零知识战术涌现</a:t>
             </a:r>
-            <a:endParaRPr lang="en-US" sz="2600" dirty="0"/>
+            <a:endParaRPr lang="en-US" sz="2400" dirty="0"/>
           </a:p>
         </p:txBody>
       </p:sp>
@@ -12481,8 +12601,8 @@
         </p:nvSpPr>
         <p:spPr>
           <a:xfrm>
-            <a:off x="274320" y="566928"/>
-            <a:ext cx="11612880" cy="9144"/>
+            <a:off x="228600" y="566928"/>
+            <a:ext cx="11704320" cy="9144"/>
           </a:xfrm>
           <a:prstGeom prst="rect">
             <a:avLst/>
@@ -12501,12 +12621,12 @@
         </p:nvSpPr>
         <p:spPr>
           <a:xfrm>
-            <a:off x="274320" y="777240"/>
-            <a:ext cx="5303520" cy="1371600"/>
+            <a:off x="228600" y="777240"/>
+            <a:ext cx="5303520" cy="1463040"/>
           </a:xfrm>
           <a:prstGeom prst="roundRect">
             <a:avLst>
-              <a:gd name="adj" fmla="val 3333"/>
+              <a:gd name="adj" fmla="val 3125"/>
             </a:avLst>
           </a:prstGeom>
           <a:solidFill>
@@ -12530,8 +12650,8 @@
         </p:nvSpPr>
         <p:spPr>
           <a:xfrm>
-            <a:off x="438912" y="777240"/>
-            <a:ext cx="4974336" cy="1371600"/>
+            <a:off x="411480" y="777240"/>
+            <a:ext cx="4937760" cy="1463040"/>
           </a:xfrm>
           <a:prstGeom prst="rect">
             <a:avLst/>
@@ -12545,12 +12665,12 @@
           <a:p>
             <a:pPr indent="0" marL="0">
               <a:lnSpc>
-                <a:spcPct val="115000"/>
+                <a:spcPct val="112000"/>
               </a:lnSpc>
               <a:buNone/>
             </a:pPr>
             <a:r>
-              <a:rPr lang="en-US" sz="1700" b="1" dirty="0">
+              <a:rPr lang="en-US" sz="1600" b="1" dirty="0">
                 <a:solidFill>
                   <a:srgbClr val="4A5568"/>
                 </a:solidFill>
@@ -12558,9 +12678,9 @@
                 <a:ea typeface="Calibri" pitchFamily="34" charset="-122"/>
                 <a:cs typeface="Calibri" pitchFamily="34" charset="-120"/>
               </a:rPr>
-              <a:t>打破死记硬背质疑: 绝对冷启动，320 轮 3 次 Eval 大转正 (+1,345, +2,376, +4.0)，最高峰 +2,376 历史性高位</a:t>
-            </a:r>
-            <a:endParaRPr lang="en-US" sz="1700" dirty="0"/>
+              <a:t>[零知识] 打破死记硬背质疑: 绝对冷启动，零 BC 引导。320 轮内 3 次 Eval 大转正 (+1,345, +2,376, +4.0)，最高峰 +2,376 历史性高位</a:t>
+            </a:r>
+            <a:endParaRPr lang="en-US" sz="1600" dirty="0"/>
           </a:p>
         </p:txBody>
       </p:sp>
@@ -12572,12 +12692,12 @@
         </p:nvSpPr>
         <p:spPr>
           <a:xfrm>
-            <a:off x="274320" y="2221992"/>
-            <a:ext cx="5303520" cy="1371600"/>
+            <a:off x="228600" y="2295144"/>
+            <a:ext cx="5303520" cy="1463040"/>
           </a:xfrm>
           <a:prstGeom prst="roundRect">
             <a:avLst>
-              <a:gd name="adj" fmla="val 3333"/>
+              <a:gd name="adj" fmla="val 3125"/>
             </a:avLst>
           </a:prstGeom>
           <a:solidFill>
@@ -12601,8 +12721,8 @@
         </p:nvSpPr>
         <p:spPr>
           <a:xfrm>
-            <a:off x="438912" y="2221992"/>
-            <a:ext cx="4974336" cy="1371600"/>
+            <a:off x="411480" y="2295144"/>
+            <a:ext cx="4937760" cy="1463040"/>
           </a:xfrm>
           <a:prstGeom prst="rect">
             <a:avLst/>
@@ -12616,12 +12736,12 @@
           <a:p>
             <a:pPr indent="0" marL="0">
               <a:lnSpc>
-                <a:spcPct val="115000"/>
+                <a:spcPct val="112000"/>
               </a:lnSpc>
               <a:buNone/>
             </a:pPr>
             <a:r>
-              <a:rPr lang="en-US" sz="1700" b="1" dirty="0">
+              <a:rPr lang="en-US" sz="1600" b="1" dirty="0">
                 <a:solidFill>
                   <a:srgbClr val="4A5568"/>
                 </a:solidFill>
@@ -12629,9 +12749,9 @@
                 <a:ea typeface="Calibri" pitchFamily="34" charset="-122"/>
                 <a:cs typeface="Calibri" pitchFamily="34" charset="-120"/>
               </a:rPr>
-              <a:t>3D 轨迹三维校准: X:Y:Z=1:1:0.1 精确轴比修正。长机 200m 锁敌，高度包线 ±10m 平滑固化，无任何重力套利嫌疑</a:t>
-            </a:r>
-            <a:endParaRPr lang="en-US" sz="1700" dirty="0"/>
+              <a:t>[校准] 3D 轨迹三维校准: X:Y:Z=1:1:0.1 精确轴比修正。长机 200m 锁敌，高度包线 ±10m 平滑固化，绝无任何重力套利嫌疑</a:t>
+            </a:r>
+            <a:endParaRPr lang="en-US" sz="1600" dirty="0"/>
           </a:p>
         </p:txBody>
       </p:sp>
@@ -12643,12 +12763,12 @@
         </p:nvSpPr>
         <p:spPr>
           <a:xfrm>
-            <a:off x="274320" y="3666744"/>
-            <a:ext cx="5303520" cy="1371600"/>
+            <a:off x="228600" y="3813048"/>
+            <a:ext cx="5303520" cy="1463040"/>
           </a:xfrm>
           <a:prstGeom prst="roundRect">
             <a:avLst>
-              <a:gd name="adj" fmla="val 3333"/>
+              <a:gd name="adj" fmla="val 3125"/>
             </a:avLst>
           </a:prstGeom>
           <a:solidFill>
@@ -12672,8 +12792,8 @@
         </p:nvSpPr>
         <p:spPr>
           <a:xfrm>
-            <a:off x="438912" y="3666744"/>
-            <a:ext cx="4974336" cy="1371600"/>
+            <a:off x="411480" y="3813048"/>
+            <a:ext cx="4937760" cy="1463040"/>
           </a:xfrm>
           <a:prstGeom prst="rect">
             <a:avLst/>
@@ -12687,12 +12807,12 @@
           <a:p>
             <a:pPr indent="0" marL="0">
               <a:lnSpc>
-                <a:spcPct val="115000"/>
+                <a:spcPct val="112000"/>
               </a:lnSpc>
               <a:buNone/>
             </a:pPr>
             <a:r>
-              <a:rPr lang="en-US" sz="1700" b="1" dirty="0">
+              <a:rPr lang="en-US" sz="1600" b="1" dirty="0">
                 <a:solidFill>
                   <a:srgbClr val="4A5568"/>
                 </a:solidFill>
@@ -12700,9 +12820,9 @@
                 <a:ea typeface="Calibri" pitchFamily="34" charset="-122"/>
                 <a:cs typeface="Calibri" pitchFamily="34" charset="-120"/>
               </a:rPr>
-              <a:t>2D KDE 统计铁证: 50 集 15,000+ 帧全量评估。红方打点在敌机尾部 35°-60° 黄金包围圈内凝聚为高密深红热区——协同引导已成全盘大样本统计本能</a:t>
-            </a:r>
-            <a:endParaRPr lang="en-US" sz="1700" dirty="0"/>
+              <a:t>[统计] 2D KDE 统计铁证: 50 集 15,000+ 帧全量评估。红方打点在敌机尾部 35°-60° 黄金包围圈内凝聚为高密深红热区——协同引导已成全盘大样本统计本能</a:t>
+            </a:r>
+            <a:endParaRPr lang="en-US" sz="1600" dirty="0"/>
           </a:p>
         </p:txBody>
       </p:sp>
@@ -12714,7 +12834,7 @@
         </p:nvSpPr>
         <p:spPr>
           <a:xfrm>
-            <a:off x="274320" y="5394960"/>
+            <a:off x="228600" y="5394960"/>
             <a:ext cx="2148840" cy="1143000"/>
           </a:xfrm>
           <a:prstGeom prst="roundRect">
@@ -12743,7 +12863,7 @@
         </p:nvSpPr>
         <p:spPr>
           <a:xfrm>
-            <a:off x="274320" y="5431536"/>
+            <a:off x="228600" y="5431536"/>
             <a:ext cx="2148840" cy="457200"/>
           </a:xfrm>
           <a:prstGeom prst="rect">
@@ -12760,7 +12880,7 @@
               <a:buNone/>
             </a:pPr>
             <a:r>
-              <a:rPr lang="en-US" sz="2800" b="1" dirty="0">
+              <a:rPr lang="en-US" sz="2600" b="1" dirty="0">
                 <a:solidFill>
                   <a:srgbClr val="F96167"/>
                 </a:solidFill>
@@ -12770,7 +12890,7 @@
               </a:rPr>
               <a:t>+2,376</a:t>
             </a:r>
-            <a:endParaRPr lang="en-US" sz="2800" dirty="0"/>
+            <a:endParaRPr lang="en-US" sz="2600" dirty="0"/>
           </a:p>
         </p:txBody>
       </p:sp>
@@ -12782,7 +12902,7 @@
         </p:nvSpPr>
         <p:spPr>
           <a:xfrm>
-            <a:off x="274320" y="5897880"/>
+            <a:off x="228600" y="5897880"/>
             <a:ext cx="2148840" cy="320040"/>
           </a:xfrm>
           <a:prstGeom prst="rect">
@@ -12802,7 +12922,7 @@
               <a:buNone/>
             </a:pPr>
             <a:r>
-              <a:rPr lang="en-US" sz="1200" b="1" dirty="0">
+              <a:rPr lang="en-US" sz="1100" b="1" dirty="0">
                 <a:solidFill>
                   <a:srgbClr val="4A5568"/>
                 </a:solidFill>
@@ -12812,7 +12932,7 @@
               </a:rPr>
               <a:t>最高Eval</a:t>
             </a:r>
-            <a:endParaRPr lang="en-US" sz="1200" dirty="0"/>
+            <a:endParaRPr lang="en-US" sz="1100" dirty="0"/>
           </a:p>
           <a:p>
             <a:pPr algn="ctr" indent="0" marL="0">
@@ -12822,7 +12942,7 @@
               <a:buNone/>
             </a:pPr>
             <a:r>
-              <a:rPr lang="en-US" sz="1200" b="1" dirty="0">
+              <a:rPr lang="en-US" sz="1100" b="1" dirty="0">
                 <a:solidFill>
                   <a:srgbClr val="4A5568"/>
                 </a:solidFill>
@@ -12832,7 +12952,7 @@
               </a:rPr>
               <a:t>突破</a:t>
             </a:r>
-            <a:endParaRPr lang="en-US" sz="1200" dirty="0"/>
+            <a:endParaRPr lang="en-US" sz="1100" dirty="0"/>
           </a:p>
         </p:txBody>
       </p:sp>
@@ -12844,7 +12964,7 @@
         </p:nvSpPr>
         <p:spPr>
           <a:xfrm>
-            <a:off x="2606040" y="5394960"/>
+            <a:off x="2560320" y="5394960"/>
             <a:ext cx="2148840" cy="1143000"/>
           </a:xfrm>
           <a:prstGeom prst="roundRect">
@@ -12873,7 +12993,7 @@
         </p:nvSpPr>
         <p:spPr>
           <a:xfrm>
-            <a:off x="2606040" y="5431536"/>
+            <a:off x="2560320" y="5431536"/>
             <a:ext cx="2148840" cy="457200"/>
           </a:xfrm>
           <a:prstGeom prst="rect">
@@ -12890,7 +13010,7 @@
               <a:buNone/>
             </a:pPr>
             <a:r>
-              <a:rPr lang="en-US" sz="2800" b="1" dirty="0">
+              <a:rPr lang="en-US" sz="2600" b="1" dirty="0">
                 <a:solidFill>
                   <a:srgbClr val="F96167"/>
                 </a:solidFill>
@@ -12900,7 +13020,7 @@
               </a:rPr>
               <a:t>3×</a:t>
             </a:r>
-            <a:endParaRPr lang="en-US" sz="2800" dirty="0"/>
+            <a:endParaRPr lang="en-US" sz="2600" dirty="0"/>
           </a:p>
         </p:txBody>
       </p:sp>
@@ -12912,7 +13032,7 @@
         </p:nvSpPr>
         <p:spPr>
           <a:xfrm>
-            <a:off x="2606040" y="5897880"/>
+            <a:off x="2560320" y="5897880"/>
             <a:ext cx="2148840" cy="320040"/>
           </a:xfrm>
           <a:prstGeom prst="rect">
@@ -12932,7 +13052,7 @@
               <a:buNone/>
             </a:pPr>
             <a:r>
-              <a:rPr lang="en-US" sz="1200" b="1" dirty="0">
+              <a:rPr lang="en-US" sz="1100" b="1" dirty="0">
                 <a:solidFill>
                   <a:srgbClr val="4A5568"/>
                 </a:solidFill>
@@ -12942,7 +13062,7 @@
               </a:rPr>
               <a:t>正向转正</a:t>
             </a:r>
-            <a:endParaRPr lang="en-US" sz="1200" dirty="0"/>
+            <a:endParaRPr lang="en-US" sz="1100" dirty="0"/>
           </a:p>
           <a:p>
             <a:pPr algn="ctr" indent="0" marL="0">
@@ -12952,7 +13072,7 @@
               <a:buNone/>
             </a:pPr>
             <a:r>
-              <a:rPr lang="en-US" sz="1200" b="1" dirty="0">
+              <a:rPr lang="en-US" sz="1100" b="1" dirty="0">
                 <a:solidFill>
                   <a:srgbClr val="4A5568"/>
                 </a:solidFill>
@@ -12962,7 +13082,7 @@
               </a:rPr>
               <a:t>次数</a:t>
             </a:r>
-            <a:endParaRPr lang="en-US" sz="1200" dirty="0"/>
+            <a:endParaRPr lang="en-US" sz="1100" dirty="0"/>
           </a:p>
         </p:txBody>
       </p:sp>
@@ -12974,7 +13094,7 @@
         </p:nvSpPr>
         <p:spPr>
           <a:xfrm>
-            <a:off x="4937760" y="5394960"/>
+            <a:off x="4892040" y="5394960"/>
             <a:ext cx="2148840" cy="1143000"/>
           </a:xfrm>
           <a:prstGeom prst="roundRect">
@@ -13003,7 +13123,7 @@
         </p:nvSpPr>
         <p:spPr>
           <a:xfrm>
-            <a:off x="4937760" y="5431536"/>
+            <a:off x="4892040" y="5431536"/>
             <a:ext cx="2148840" cy="457200"/>
           </a:xfrm>
           <a:prstGeom prst="rect">
@@ -13020,7 +13140,7 @@
               <a:buNone/>
             </a:pPr>
             <a:r>
-              <a:rPr lang="en-US" sz="2800" b="1" dirty="0">
+              <a:rPr lang="en-US" sz="2600" b="1" dirty="0">
                 <a:solidFill>
                   <a:srgbClr val="F96167"/>
                 </a:solidFill>
@@ -13030,7 +13150,7 @@
               </a:rPr>
               <a:t>320</a:t>
             </a:r>
-            <a:endParaRPr lang="en-US" sz="2800" dirty="0"/>
+            <a:endParaRPr lang="en-US" sz="2600" dirty="0"/>
           </a:p>
         </p:txBody>
       </p:sp>
@@ -13042,7 +13162,7 @@
         </p:nvSpPr>
         <p:spPr>
           <a:xfrm>
-            <a:off x="4937760" y="5897880"/>
+            <a:off x="4892040" y="5897880"/>
             <a:ext cx="2148840" cy="320040"/>
           </a:xfrm>
           <a:prstGeom prst="rect">
@@ -13062,7 +13182,7 @@
               <a:buNone/>
             </a:pPr>
             <a:r>
-              <a:rPr lang="en-US" sz="1200" b="1" dirty="0">
+              <a:rPr lang="en-US" sz="1100" b="1" dirty="0">
                 <a:solidFill>
                   <a:srgbClr val="4A5568"/>
                 </a:solidFill>
@@ -13072,7 +13192,7 @@
               </a:rPr>
               <a:t>冷启动</a:t>
             </a:r>
-            <a:endParaRPr lang="en-US" sz="1200" dirty="0"/>
+            <a:endParaRPr lang="en-US" sz="1100" dirty="0"/>
           </a:p>
           <a:p>
             <a:pPr algn="ctr" indent="0" marL="0">
@@ -13082,7 +13202,7 @@
               <a:buNone/>
             </a:pPr>
             <a:r>
-              <a:rPr lang="en-US" sz="1200" b="1" dirty="0">
+              <a:rPr lang="en-US" sz="1100" b="1" dirty="0">
                 <a:solidFill>
                   <a:srgbClr val="4A5568"/>
                 </a:solidFill>
@@ -13092,7 +13212,7 @@
               </a:rPr>
               <a:t>轮数</a:t>
             </a:r>
-            <a:endParaRPr lang="en-US" sz="1200" dirty="0"/>
+            <a:endParaRPr lang="en-US" sz="1100" dirty="0"/>
           </a:p>
         </p:txBody>
       </p:sp>
@@ -13104,7 +13224,7 @@
         </p:nvSpPr>
         <p:spPr>
           <a:xfrm>
-            <a:off x="7269480" y="5394960"/>
+            <a:off x="7223760" y="5394960"/>
             <a:ext cx="2148840" cy="1143000"/>
           </a:xfrm>
           <a:prstGeom prst="roundRect">
@@ -13133,7 +13253,7 @@
         </p:nvSpPr>
         <p:spPr>
           <a:xfrm>
-            <a:off x="7269480" y="5431536"/>
+            <a:off x="7223760" y="5431536"/>
             <a:ext cx="2148840" cy="457200"/>
           </a:xfrm>
           <a:prstGeom prst="rect">
@@ -13150,7 +13270,7 @@
               <a:buNone/>
             </a:pPr>
             <a:r>
-              <a:rPr lang="en-US" sz="2800" b="1" dirty="0">
+              <a:rPr lang="en-US" sz="2600" b="1" dirty="0">
                 <a:solidFill>
                   <a:srgbClr val="F96167"/>
                 </a:solidFill>
@@ -13160,7 +13280,7 @@
               </a:rPr>
               <a:t>0</a:t>
             </a:r>
-            <a:endParaRPr lang="en-US" sz="2800" dirty="0"/>
+            <a:endParaRPr lang="en-US" sz="2600" dirty="0"/>
           </a:p>
         </p:txBody>
       </p:sp>
@@ -13172,7 +13292,7 @@
         </p:nvSpPr>
         <p:spPr>
           <a:xfrm>
-            <a:off x="7269480" y="5897880"/>
+            <a:off x="7223760" y="5897880"/>
             <a:ext cx="2148840" cy="320040"/>
           </a:xfrm>
           <a:prstGeom prst="rect">
@@ -13192,7 +13312,7 @@
               <a:buNone/>
             </a:pPr>
             <a:r>
-              <a:rPr lang="en-US" sz="1200" b="1" dirty="0">
+              <a:rPr lang="en-US" sz="1100" b="1" dirty="0">
                 <a:solidFill>
                   <a:srgbClr val="4A5568"/>
                 </a:solidFill>
@@ -13202,7 +13322,7 @@
               </a:rPr>
               <a:t>专家样本</a:t>
             </a:r>
-            <a:endParaRPr lang="en-US" sz="1200" dirty="0"/>
+            <a:endParaRPr lang="en-US" sz="1100" dirty="0"/>
           </a:p>
           <a:p>
             <a:pPr algn="ctr" indent="0" marL="0">
@@ -13212,7 +13332,7 @@
               <a:buNone/>
             </a:pPr>
             <a:r>
-              <a:rPr lang="en-US" sz="1200" b="1" dirty="0">
+              <a:rPr lang="en-US" sz="1100" b="1" dirty="0">
                 <a:solidFill>
                   <a:srgbClr val="4A5568"/>
                 </a:solidFill>
@@ -13222,7 +13342,7 @@
               </a:rPr>
               <a:t>干预</a:t>
             </a:r>
-            <a:endParaRPr lang="en-US" sz="1200" dirty="0"/>
+            <a:endParaRPr lang="en-US" sz="1100" dirty="0"/>
           </a:p>
         </p:txBody>
       </p:sp>
@@ -13241,8 +13361,8 @@
         </p:blipFill>
         <p:spPr>
           <a:xfrm>
-            <a:off x="6035040" y="822960"/>
-            <a:ext cx="3017520" cy="2926080"/>
+            <a:off x="6035040" y="777240"/>
+            <a:ext cx="3017520" cy="3017520"/>
           </a:xfrm>
           <a:prstGeom prst="rect">
             <a:avLst/>
@@ -13264,8 +13384,8 @@
         </p:blipFill>
         <p:spPr>
           <a:xfrm>
-            <a:off x="9235440" y="822960"/>
-            <a:ext cx="2743200" cy="2926080"/>
+            <a:off x="9235440" y="777240"/>
+            <a:ext cx="2743200" cy="3017520"/>
           </a:xfrm>
           <a:prstGeom prst="rect">
             <a:avLst/>

</xml_diff>

<commit_message>
fix: architecture diagram — all boxes within bounds, plain labels
Widened figure to 17.5" x-range, replaced circled digits (①-⑥)
with plain text labels (1.-6.) to avoid DejaVu Serif CJK tofu.
PPT regenerated with updated diagram on P3.
</commit_message>
<xml_diff>
--- a/results/ppt/formation_coop_v7.pptx
+++ b/results/ppt/formation_coop_v7.pptx
@@ -954,7 +954,7 @@
           <a:p>
             <a:r>
               <a:rPr lang="en-US" dirty="0"/>
-              <a:t>IPPO 导致 -7,536 内卷死锁。连续高斯噪声使策略在 600 步长时序中严重抖动。AND-gate 下空间完美但时间零分——长机 329m 突入截断，僚机 1,974m 外绝望。时空脱节死锁。</a:t>
+              <a:t>IPPO 导致 -7,536 内卷死锁。连续高斯噪声使策略在 600 步长时序中严重抖动。AND-gate 下空间完美但时间零分——长机 329m 突入截断，僚机 1974m 外绝望。时空脱节死锁。</a:t>
             </a:r>
             <a:endParaRPr lang="en-US" dirty="0"/>
           </a:p>
@@ -2120,7 +2120,7 @@
                 <a:ea typeface="Calibri" pitchFamily="34" charset="-122"/>
                 <a:cs typeface="Calibri" pitchFamily="34" charset="-120"/>
               </a:rPr>
-              <a:t>Sean Nishimiya  ·  Zhejiang University  ·  July 2026</a:t>
+              <a:t>Sean Nishimiya  .  Zhejiang University  .  July 2026</a:t>
             </a:r>
             <a:endParaRPr lang="en-US" sz="1100" dirty="0"/>
           </a:p>
@@ -4436,7 +4436,7 @@
                 <a:ea typeface="Georgia" pitchFamily="34" charset="-122"/>
                 <a:cs typeface="Georgia" pitchFamily="34" charset="-120"/>
               </a:rPr>
-              <a:t>感谢聆听 · 欢迎提问与讨论</a:t>
+              <a:t>感谢聆听 . 欢迎提问与讨论</a:t>
             </a:r>
             <a:endParaRPr lang="en-US" sz="2600" dirty="0"/>
           </a:p>
@@ -4475,7 +4475,7 @@
                 <a:ea typeface="Calibri" pitchFamily="34" charset="-122"/>
                 <a:cs typeface="Calibri" pitchFamily="34" charset="-120"/>
               </a:rPr>
-              <a:t>sean@zju.edu.cn  ·  github.com/NishimiyaXSean/jsbsim-marl-formation</a:t>
+              <a:t>sean@zju.edu.cn  .  github.com/NishimiyaXSean/jsbsim-marl-formation</a:t>
             </a:r>
             <a:endParaRPr lang="en-US" sz="1200" dirty="0"/>
           </a:p>
@@ -5543,7 +5543,7 @@
                 <a:ea typeface="Calibri" pitchFamily="34" charset="-122"/>
                 <a:cs typeface="Calibri" pitchFamily="34" charset="-120"/>
               </a:rPr>
-              <a:t>致命缺陷: 空间合格 (34.8°) 但时间零分 (同步率 0.0%)</a:t>
+              <a:t>致命缺陷: 空间合格 (34.8deg) 但时间零分 (同步率 0.0%)</a:t>
             </a:r>
             <a:endParaRPr lang="en-US" sz="1600" dirty="0"/>
           </a:p>
@@ -5563,7 +5563,7 @@
                 <a:ea typeface="Calibri" pitchFamily="34" charset="-122"/>
                 <a:cs typeface="Calibri" pitchFamily="34" charset="-120"/>
               </a:rPr>
-              <a:t>具体表现: 长机 329m 突入截断，僚机 1,974m 外绝望。交战步数腰斩至 165</a:t>
+              <a:t>具体表现: 长机 329m 突入截断，僚机 1974m 外绝望。交战步数腰斩至 165</a:t>
             </a:r>
             <a:endParaRPr lang="en-US" sz="1600" dirty="0"/>
           </a:p>
@@ -5809,7 +5809,7 @@
         <p:spPr>
           <a:xfrm>
             <a:off x="228600" y="777240"/>
-            <a:ext cx="5943600" cy="1433322"/>
+            <a:ext cx="5760720" cy="1433322"/>
           </a:xfrm>
           <a:prstGeom prst="roundRect">
             <a:avLst>
@@ -5838,7 +5838,7 @@
         <p:spPr>
           <a:xfrm>
             <a:off x="411480" y="777240"/>
-            <a:ext cx="5577840" cy="1433322"/>
+            <a:ext cx="5394960" cy="1433322"/>
           </a:xfrm>
           <a:prstGeom prst="rect">
             <a:avLst/>
@@ -5880,7 +5880,7 @@
         <p:spPr>
           <a:xfrm>
             <a:off x="228600" y="2265426"/>
-            <a:ext cx="5943600" cy="1433322"/>
+            <a:ext cx="5760720" cy="1433322"/>
           </a:xfrm>
           <a:prstGeom prst="roundRect">
             <a:avLst>
@@ -5909,7 +5909,7 @@
         <p:spPr>
           <a:xfrm>
             <a:off x="411480" y="2265426"/>
-            <a:ext cx="5577840" cy="1433322"/>
+            <a:ext cx="5394960" cy="1433322"/>
           </a:xfrm>
           <a:prstGeom prst="rect">
             <a:avLst/>
@@ -5951,7 +5951,7 @@
         <p:spPr>
           <a:xfrm>
             <a:off x="228600" y="3753612"/>
-            <a:ext cx="5943600" cy="1433322"/>
+            <a:ext cx="5760720" cy="1433322"/>
           </a:xfrm>
           <a:prstGeom prst="roundRect">
             <a:avLst>
@@ -5980,7 +5980,7 @@
         <p:spPr>
           <a:xfrm>
             <a:off x="411480" y="3753612"/>
-            <a:ext cx="5577840" cy="1433322"/>
+            <a:ext cx="5394960" cy="1433322"/>
           </a:xfrm>
           <a:prstGeom prst="rect">
             <a:avLst/>
@@ -6022,7 +6022,7 @@
         <p:spPr>
           <a:xfrm>
             <a:off x="228600" y="5241798"/>
-            <a:ext cx="5943600" cy="1433322"/>
+            <a:ext cx="5760720" cy="1433322"/>
           </a:xfrm>
           <a:prstGeom prst="roundRect">
             <a:avLst>
@@ -6051,7 +6051,7 @@
         <p:spPr>
           <a:xfrm>
             <a:off x="411480" y="5241798"/>
-            <a:ext cx="5577840" cy="1433322"/>
+            <a:ext cx="5394960" cy="1433322"/>
           </a:xfrm>
           <a:prstGeom prst="rect">
             <a:avLst/>
@@ -6099,8 +6099,8 @@
         </p:blipFill>
         <p:spPr>
           <a:xfrm>
-            <a:off x="6583680" y="777240"/>
-            <a:ext cx="5303520" cy="5029200"/>
+            <a:off x="6309360" y="777240"/>
+            <a:ext cx="5669280" cy="5303520"/>
           </a:xfrm>
           <a:prstGeom prst="rect">
             <a:avLst/>
@@ -6115,8 +6115,8 @@
         </p:nvSpPr>
         <p:spPr>
           <a:xfrm>
-            <a:off x="6583680" y="5669280"/>
-            <a:ext cx="1691640" cy="1097280"/>
+            <a:off x="6309360" y="5577840"/>
+            <a:ext cx="1737360" cy="1097280"/>
           </a:xfrm>
           <a:prstGeom prst="roundRect">
             <a:avLst>
@@ -6144,8 +6144,8 @@
         </p:nvSpPr>
         <p:spPr>
           <a:xfrm>
-            <a:off x="6583680" y="5705856"/>
-            <a:ext cx="1691640" cy="457200"/>
+            <a:off x="6309360" y="5614416"/>
+            <a:ext cx="1737360" cy="457200"/>
           </a:xfrm>
           <a:prstGeom prst="rect">
             <a:avLst/>
@@ -6183,8 +6183,8 @@
         </p:nvSpPr>
         <p:spPr>
           <a:xfrm>
-            <a:off x="6583680" y="6172200"/>
-            <a:ext cx="1691640" cy="320040"/>
+            <a:off x="6309360" y="6080760"/>
+            <a:ext cx="1737360" cy="320040"/>
           </a:xfrm>
           <a:prstGeom prst="rect">
             <a:avLst/>
@@ -6231,7 +6231,7 @@
                 <a:ea typeface="Calibri" pitchFamily="34" charset="-122"/>
                 <a:cs typeface="Calibri" pitchFamily="34" charset="-120"/>
               </a:rPr>
-              <a:t>Self-&gt;Mate</a:t>
+              <a:t>Self-Mate</a:t>
             </a:r>
             <a:endParaRPr lang="en-US" sz="1100" dirty="0"/>
           </a:p>
@@ -6245,8 +6245,8 @@
         </p:nvSpPr>
         <p:spPr>
           <a:xfrm>
-            <a:off x="8503920" y="5669280"/>
-            <a:ext cx="1691640" cy="1097280"/>
+            <a:off x="8229600" y="5577840"/>
+            <a:ext cx="1737360" cy="1097280"/>
           </a:xfrm>
           <a:prstGeom prst="roundRect">
             <a:avLst>
@@ -6274,8 +6274,8 @@
         </p:nvSpPr>
         <p:spPr>
           <a:xfrm>
-            <a:off x="8503920" y="5705856"/>
-            <a:ext cx="1691640" cy="457200"/>
+            <a:off x="8229600" y="5614416"/>
+            <a:ext cx="1737360" cy="457200"/>
           </a:xfrm>
           <a:prstGeom prst="rect">
             <a:avLst/>
@@ -6313,8 +6313,8 @@
         </p:nvSpPr>
         <p:spPr>
           <a:xfrm>
-            <a:off x="8503920" y="6172200"/>
-            <a:ext cx="1691640" cy="320040"/>
+            <a:off x="8229600" y="6080760"/>
+            <a:ext cx="1737360" cy="320040"/>
           </a:xfrm>
           <a:prstGeom prst="rect">
             <a:avLst/>
@@ -6375,8 +6375,8 @@
         </p:nvSpPr>
         <p:spPr>
           <a:xfrm>
-            <a:off x="10424160" y="5669280"/>
-            <a:ext cx="1691640" cy="1097280"/>
+            <a:off x="10149840" y="5577840"/>
+            <a:ext cx="1737360" cy="1097280"/>
           </a:xfrm>
           <a:prstGeom prst="roundRect">
             <a:avLst>
@@ -6404,8 +6404,8 @@
         </p:nvSpPr>
         <p:spPr>
           <a:xfrm>
-            <a:off x="10424160" y="5705856"/>
-            <a:ext cx="1691640" cy="457200"/>
+            <a:off x="10149840" y="5614416"/>
+            <a:ext cx="1737360" cy="457200"/>
           </a:xfrm>
           <a:prstGeom prst="rect">
             <a:avLst/>
@@ -6443,8 +6443,8 @@
         </p:nvSpPr>
         <p:spPr>
           <a:xfrm>
-            <a:off x="10424160" y="6172200"/>
-            <a:ext cx="1691640" cy="320040"/>
+            <a:off x="10149840" y="6080760"/>
+            <a:ext cx="1737360" cy="320040"/>
           </a:xfrm>
           <a:prstGeom prst="rect">
             <a:avLst/>
@@ -13018,7 +13018,7 @@
                 <a:ea typeface="Georgia" pitchFamily="34" charset="-122"/>
                 <a:cs typeface="Georgia" pitchFamily="34" charset="-120"/>
               </a:rPr>
-              <a:t>3×</a:t>
+              <a:t>3x</a:t>
             </a:r>
             <a:endParaRPr lang="en-US" sz="2600" dirty="0"/>
           </a:p>

</xml_diff>